<commit_message>
Updates and improvements to slides
</commit_message>
<xml_diff>
--- a/slides/1_Introduction.pptx
+++ b/slides/1_Introduction.pptx
@@ -5,7 +5,7 @@
     <p:sldMasterId id="2147483648" r:id="rId1"/>
   </p:sldMasterIdLst>
   <p:notesMasterIdLst>
-    <p:notesMasterId r:id="rId60"/>
+    <p:notesMasterId r:id="rId61"/>
   </p:notesMasterIdLst>
   <p:sldIdLst>
     <p:sldId id="256" r:id="rId2"/>
@@ -37,35 +37,36 @@
     <p:sldId id="725" r:id="rId28"/>
     <p:sldId id="401" r:id="rId29"/>
     <p:sldId id="713" r:id="rId30"/>
-    <p:sldId id="387" r:id="rId31"/>
-    <p:sldId id="720" r:id="rId32"/>
-    <p:sldId id="784" r:id="rId33"/>
+    <p:sldId id="784" r:id="rId31"/>
+    <p:sldId id="387" r:id="rId32"/>
+    <p:sldId id="720" r:id="rId33"/>
     <p:sldId id="382" r:id="rId34"/>
-    <p:sldId id="357" r:id="rId35"/>
-    <p:sldId id="385" r:id="rId36"/>
-    <p:sldId id="359" r:id="rId37"/>
-    <p:sldId id="727" r:id="rId38"/>
-    <p:sldId id="386" r:id="rId39"/>
-    <p:sldId id="714" r:id="rId40"/>
-    <p:sldId id="360" r:id="rId41"/>
-    <p:sldId id="731" r:id="rId42"/>
-    <p:sldId id="374" r:id="rId43"/>
-    <p:sldId id="375" r:id="rId44"/>
-    <p:sldId id="738" r:id="rId45"/>
-    <p:sldId id="377" r:id="rId46"/>
-    <p:sldId id="729" r:id="rId47"/>
-    <p:sldId id="730" r:id="rId48"/>
-    <p:sldId id="739" r:id="rId49"/>
-    <p:sldId id="376" r:id="rId50"/>
-    <p:sldId id="728" r:id="rId51"/>
-    <p:sldId id="379" r:id="rId52"/>
-    <p:sldId id="380" r:id="rId53"/>
-    <p:sldId id="742" r:id="rId54"/>
-    <p:sldId id="743" r:id="rId55"/>
-    <p:sldId id="744" r:id="rId56"/>
-    <p:sldId id="785" r:id="rId57"/>
-    <p:sldId id="740" r:id="rId58"/>
-    <p:sldId id="384" r:id="rId59"/>
+    <p:sldId id="787" r:id="rId35"/>
+    <p:sldId id="357" r:id="rId36"/>
+    <p:sldId id="385" r:id="rId37"/>
+    <p:sldId id="359" r:id="rId38"/>
+    <p:sldId id="727" r:id="rId39"/>
+    <p:sldId id="386" r:id="rId40"/>
+    <p:sldId id="714" r:id="rId41"/>
+    <p:sldId id="360" r:id="rId42"/>
+    <p:sldId id="731" r:id="rId43"/>
+    <p:sldId id="374" r:id="rId44"/>
+    <p:sldId id="375" r:id="rId45"/>
+    <p:sldId id="738" r:id="rId46"/>
+    <p:sldId id="377" r:id="rId47"/>
+    <p:sldId id="729" r:id="rId48"/>
+    <p:sldId id="730" r:id="rId49"/>
+    <p:sldId id="739" r:id="rId50"/>
+    <p:sldId id="376" r:id="rId51"/>
+    <p:sldId id="728" r:id="rId52"/>
+    <p:sldId id="379" r:id="rId53"/>
+    <p:sldId id="380" r:id="rId54"/>
+    <p:sldId id="742" r:id="rId55"/>
+    <p:sldId id="743" r:id="rId56"/>
+    <p:sldId id="744" r:id="rId57"/>
+    <p:sldId id="785" r:id="rId58"/>
+    <p:sldId id="740" r:id="rId59"/>
+    <p:sldId id="384" r:id="rId60"/>
   </p:sldIdLst>
   <p:sldSz cx="12192000" cy="6858000"/>
   <p:notesSz cx="6858000" cy="9144000"/>
@@ -16181,62 +16182,42 @@
             </a:r>
             <a:r>
               <a:rPr lang="en-US" dirty="0"/>
-              <a:t>, Tatyana Boland: </a:t>
-            </a:r>
-            <a:r>
-              <a:rPr lang="en-US" dirty="0">
-                <a:latin typeface="Google Sans"/>
-              </a:rPr>
-              <a:t>tab840 at </a:t>
-            </a:r>
-            <a:r>
-              <a:rPr lang="en-US" b="0" i="0" dirty="0">
-                <a:effectLst/>
-                <a:latin typeface="Google Sans"/>
-              </a:rPr>
-              <a:t>g dot Harvard dot </a:t>
-            </a:r>
-            <a:r>
-              <a:rPr lang="en-US" b="0" i="0" dirty="0" err="1">
-                <a:effectLst/>
-                <a:latin typeface="Google Sans"/>
-              </a:rPr>
+              <a:t>, Jacqeline Hardy: </a:t>
+            </a:r>
+            <a:r>
+              <a:rPr lang="en-US" dirty="0" err="1"/>
+              <a:t>jacquelinehardy</a:t>
+            </a:r>
+            <a:r>
+              <a:rPr lang="en-US" dirty="0"/>
+              <a:t> at g dot </a:t>
+            </a:r>
+            <a:r>
+              <a:rPr lang="en-US" dirty="0" err="1"/>
+              <a:t>harvard</a:t>
+            </a:r>
+            <a:r>
+              <a:rPr lang="en-US" dirty="0"/>
+              <a:t> dot </a:t>
+            </a:r>
+            <a:r>
+              <a:rPr lang="en-US" dirty="0" err="1"/>
               <a:t>edu</a:t>
             </a:r>
             <a:r>
-              <a:rPr lang="en-US" dirty="0">
-                <a:latin typeface="Google Sans"/>
-              </a:rPr>
-              <a:t>, or </a:t>
-            </a:r>
-            <a:r>
-              <a:rPr lang="en-US" dirty="0" err="1">
-                <a:latin typeface="Google Sans"/>
-              </a:rPr>
-              <a:t>Waree</a:t>
-            </a:r>
-            <a:r>
-              <a:rPr lang="en-US" dirty="0">
-                <a:latin typeface="Google Sans"/>
-              </a:rPr>
-              <a:t> </a:t>
-            </a:r>
-            <a:r>
-              <a:rPr lang="en-US" dirty="0" err="1">
-                <a:latin typeface="Google Sans"/>
-              </a:rPr>
-              <a:t>Porprommart</a:t>
-            </a:r>
-            <a:r>
-              <a:rPr lang="en-US" dirty="0">
-                <a:latin typeface="Google Sans"/>
-              </a:rPr>
-              <a:t>: wap185 at g dot Harvard dot </a:t>
-            </a:r>
-            <a:r>
-              <a:rPr lang="en-US" dirty="0" err="1">
-                <a:latin typeface="Google Sans"/>
-              </a:rPr>
+              <a:rPr lang="en-US" dirty="0"/>
+              <a:t>, Eric Trucksess: ert713 at g dot </a:t>
+            </a:r>
+            <a:r>
+              <a:rPr lang="en-US" dirty="0" err="1"/>
+              <a:t>harvard</a:t>
+            </a:r>
+            <a:r>
+              <a:rPr lang="en-US" dirty="0"/>
+              <a:t> dot </a:t>
+            </a:r>
+            <a:r>
+              <a:rPr lang="en-US" dirty="0" err="1"/>
               <a:t>edu</a:t>
             </a:r>
             <a:endParaRPr lang="en-US" b="0" i="0" dirty="0">
@@ -18025,6 +18006,1143 @@
   <p:cSld>
     <p:spTree>
       <p:nvGrpSpPr>
+        <p:cNvPr id="1" name="">
+          <a:extLst>
+            <a:ext uri="{FF2B5EF4-FFF2-40B4-BE49-F238E27FC236}">
+              <a16:creationId xmlns:a16="http://schemas.microsoft.com/office/drawing/2014/main" id="{ED7A9242-6F04-0255-B6E4-003EE805CF99}"/>
+            </a:ext>
+          </a:extLst>
+        </p:cNvPr>
+        <p:cNvGrpSpPr/>
+        <p:nvPr/>
+      </p:nvGrpSpPr>
+      <p:grpSpPr>
+        <a:xfrm>
+          <a:off x="0" y="0"/>
+          <a:ext cx="0" cy="0"/>
+          <a:chOff x="0" y="0"/>
+          <a:chExt cx="0" cy="0"/>
+        </a:xfrm>
+      </p:grpSpPr>
+      <p:sp>
+        <p:nvSpPr>
+          <p:cNvPr id="2" name="Title 1">
+            <a:extLst>
+              <a:ext uri="{FF2B5EF4-FFF2-40B4-BE49-F238E27FC236}">
+                <a16:creationId xmlns:a16="http://schemas.microsoft.com/office/drawing/2014/main" id="{97C0B4EF-F7E3-7E82-AE6D-66E8ED303FDB}"/>
+              </a:ext>
+            </a:extLst>
+          </p:cNvPr>
+          <p:cNvSpPr>
+            <a:spLocks noGrp="1"/>
+          </p:cNvSpPr>
+          <p:nvPr>
+            <p:ph type="title"/>
+          </p:nvPr>
+        </p:nvSpPr>
+        <p:spPr>
+          <a:xfrm>
+            <a:off x="916187" y="249623"/>
+            <a:ext cx="10515600" cy="662230"/>
+          </a:xfrm>
+        </p:spPr>
+        <p:txBody>
+          <a:bodyPr>
+            <a:normAutofit fontScale="90000"/>
+          </a:bodyPr>
+          <a:lstStyle/>
+          <a:p>
+            <a:r>
+              <a:rPr lang="en-US" sz="4900" dirty="0">
+                <a:latin typeface="+mn-lt"/>
+              </a:rPr>
+              <a:t>Main topics in this course</a:t>
+            </a:r>
+            <a:br>
+              <a:rPr lang="en-US" sz="4000" dirty="0">
+                <a:latin typeface="+mn-lt"/>
+              </a:rPr>
+            </a:br>
+            <a:endParaRPr lang="en-US" sz="4000" dirty="0">
+              <a:latin typeface="+mn-lt"/>
+            </a:endParaRPr>
+          </a:p>
+        </p:txBody>
+      </p:sp>
+      <p:sp>
+        <p:nvSpPr>
+          <p:cNvPr id="3" name="Left Brace 2">
+            <a:extLst>
+              <a:ext uri="{FF2B5EF4-FFF2-40B4-BE49-F238E27FC236}">
+                <a16:creationId xmlns:a16="http://schemas.microsoft.com/office/drawing/2014/main" id="{B43E0B5E-B811-4BBC-CEDF-97FC2AAC1766}"/>
+              </a:ext>
+            </a:extLst>
+          </p:cNvPr>
+          <p:cNvSpPr/>
+          <p:nvPr/>
+        </p:nvSpPr>
+        <p:spPr>
+          <a:xfrm>
+            <a:off x="756889" y="1964356"/>
+            <a:ext cx="225209" cy="1273261"/>
+          </a:xfrm>
+          <a:prstGeom prst="leftBrace">
+            <a:avLst/>
+          </a:prstGeom>
+          <a:ln w="19050">
+            <a:solidFill>
+              <a:schemeClr val="tx1"/>
+            </a:solidFill>
+          </a:ln>
+        </p:spPr>
+        <p:style>
+          <a:lnRef idx="1">
+            <a:schemeClr val="accent1"/>
+          </a:lnRef>
+          <a:fillRef idx="0">
+            <a:schemeClr val="accent1"/>
+          </a:fillRef>
+          <a:effectRef idx="0">
+            <a:schemeClr val="accent1"/>
+          </a:effectRef>
+          <a:fontRef idx="minor">
+            <a:schemeClr val="tx1"/>
+          </a:fontRef>
+        </p:style>
+        <p:txBody>
+          <a:bodyPr rtlCol="0" anchor="ctr"/>
+          <a:lstStyle/>
+          <a:p>
+            <a:pPr algn="ctr"/>
+            <a:endParaRPr lang="en-US"/>
+          </a:p>
+        </p:txBody>
+      </p:sp>
+      <p:sp>
+        <p:nvSpPr>
+          <p:cNvPr id="4" name="TextBox 3">
+            <a:extLst>
+              <a:ext uri="{FF2B5EF4-FFF2-40B4-BE49-F238E27FC236}">
+                <a16:creationId xmlns:a16="http://schemas.microsoft.com/office/drawing/2014/main" id="{77BB0425-4708-2E61-70FB-876C788A79E2}"/>
+              </a:ext>
+            </a:extLst>
+          </p:cNvPr>
+          <p:cNvSpPr txBox="1"/>
+          <p:nvPr/>
+        </p:nvSpPr>
+        <p:spPr>
+          <a:xfrm rot="16200000">
+            <a:off x="-238228" y="2251765"/>
+            <a:ext cx="1571596" cy="400110"/>
+          </a:xfrm>
+          <a:prstGeom prst="rect">
+            <a:avLst/>
+          </a:prstGeom>
+          <a:noFill/>
+        </p:spPr>
+        <p:txBody>
+          <a:bodyPr wrap="square" rtlCol="0">
+            <a:spAutoFit/>
+          </a:bodyPr>
+          <a:lstStyle/>
+          <a:p>
+            <a:pPr algn="ctr"/>
+            <a:r>
+              <a:rPr lang="en-US" sz="2000" dirty="0"/>
+              <a:t>Foundations </a:t>
+            </a:r>
+          </a:p>
+        </p:txBody>
+      </p:sp>
+      <p:sp>
+        <p:nvSpPr>
+          <p:cNvPr id="5" name="Rectangle 4">
+            <a:extLst>
+              <a:ext uri="{FF2B5EF4-FFF2-40B4-BE49-F238E27FC236}">
+                <a16:creationId xmlns:a16="http://schemas.microsoft.com/office/drawing/2014/main" id="{DAA42CDB-2EBC-28B2-6456-04829EC7EF48}"/>
+              </a:ext>
+            </a:extLst>
+          </p:cNvPr>
+          <p:cNvSpPr/>
+          <p:nvPr/>
+        </p:nvSpPr>
+        <p:spPr>
+          <a:xfrm>
+            <a:off x="1259812" y="1983695"/>
+            <a:ext cx="1951346" cy="1253922"/>
+          </a:xfrm>
+          <a:prstGeom prst="rect">
+            <a:avLst/>
+          </a:prstGeom>
+          <a:noFill/>
+          <a:ln w="38100">
+            <a:solidFill>
+              <a:srgbClr val="C00000"/>
+            </a:solidFill>
+          </a:ln>
+        </p:spPr>
+        <p:style>
+          <a:lnRef idx="2">
+            <a:schemeClr val="accent1">
+              <a:shade val="15000"/>
+            </a:schemeClr>
+          </a:lnRef>
+          <a:fillRef idx="1">
+            <a:schemeClr val="accent1"/>
+          </a:fillRef>
+          <a:effectRef idx="0">
+            <a:schemeClr val="accent1"/>
+          </a:effectRef>
+          <a:fontRef idx="minor">
+            <a:schemeClr val="lt1"/>
+          </a:fontRef>
+        </p:style>
+        <p:txBody>
+          <a:bodyPr rtlCol="0" anchor="ctr"/>
+          <a:lstStyle/>
+          <a:p>
+            <a:pPr algn="ctr"/>
+            <a:r>
+              <a:rPr lang="en-US" sz="2000" dirty="0">
+                <a:solidFill>
+                  <a:schemeClr val="tx1"/>
+                </a:solidFill>
+              </a:rPr>
+              <a:t>1. Hashing and K-V pair management </a:t>
+            </a:r>
+          </a:p>
+        </p:txBody>
+      </p:sp>
+      <p:sp>
+        <p:nvSpPr>
+          <p:cNvPr id="6" name="Rectangle 5">
+            <a:extLst>
+              <a:ext uri="{FF2B5EF4-FFF2-40B4-BE49-F238E27FC236}">
+                <a16:creationId xmlns:a16="http://schemas.microsoft.com/office/drawing/2014/main" id="{F5C7F060-78DB-AC42-6BFD-05BD50198440}"/>
+              </a:ext>
+            </a:extLst>
+          </p:cNvPr>
+          <p:cNvSpPr/>
+          <p:nvPr/>
+        </p:nvSpPr>
+        <p:spPr>
+          <a:xfrm>
+            <a:off x="3740233" y="2021536"/>
+            <a:ext cx="2157426" cy="1178239"/>
+          </a:xfrm>
+          <a:prstGeom prst="rect">
+            <a:avLst/>
+          </a:prstGeom>
+          <a:noFill/>
+          <a:ln w="19050">
+            <a:solidFill>
+              <a:schemeClr val="tx1"/>
+            </a:solidFill>
+          </a:ln>
+        </p:spPr>
+        <p:style>
+          <a:lnRef idx="2">
+            <a:schemeClr val="accent1">
+              <a:shade val="15000"/>
+            </a:schemeClr>
+          </a:lnRef>
+          <a:fillRef idx="1">
+            <a:schemeClr val="accent1"/>
+          </a:fillRef>
+          <a:effectRef idx="0">
+            <a:schemeClr val="accent1"/>
+          </a:effectRef>
+          <a:fontRef idx="minor">
+            <a:schemeClr val="lt1"/>
+          </a:fontRef>
+        </p:style>
+        <p:txBody>
+          <a:bodyPr rtlCol="0" anchor="ctr"/>
+          <a:lstStyle/>
+          <a:p>
+            <a:pPr algn="ctr"/>
+            <a:r>
+              <a:rPr lang="en-US" sz="2000" dirty="0">
+                <a:solidFill>
+                  <a:schemeClr val="tx1"/>
+                </a:solidFill>
+              </a:rPr>
+              <a:t>2. Distance and Similarity Metrics</a:t>
+            </a:r>
+          </a:p>
+        </p:txBody>
+      </p:sp>
+      <p:sp>
+        <p:nvSpPr>
+          <p:cNvPr id="7" name="Rectangle 6">
+            <a:extLst>
+              <a:ext uri="{FF2B5EF4-FFF2-40B4-BE49-F238E27FC236}">
+                <a16:creationId xmlns:a16="http://schemas.microsoft.com/office/drawing/2014/main" id="{F20B3888-4A09-E889-C7DE-5ECE32C17693}"/>
+              </a:ext>
+            </a:extLst>
+          </p:cNvPr>
+          <p:cNvSpPr/>
+          <p:nvPr/>
+        </p:nvSpPr>
+        <p:spPr>
+          <a:xfrm>
+            <a:off x="6408020" y="2037908"/>
+            <a:ext cx="2058805" cy="1213337"/>
+          </a:xfrm>
+          <a:prstGeom prst="rect">
+            <a:avLst/>
+          </a:prstGeom>
+          <a:noFill/>
+          <a:ln w="19050">
+            <a:solidFill>
+              <a:schemeClr val="tx1"/>
+            </a:solidFill>
+          </a:ln>
+        </p:spPr>
+        <p:style>
+          <a:lnRef idx="2">
+            <a:schemeClr val="accent1">
+              <a:shade val="15000"/>
+            </a:schemeClr>
+          </a:lnRef>
+          <a:fillRef idx="1">
+            <a:schemeClr val="accent1"/>
+          </a:fillRef>
+          <a:effectRef idx="0">
+            <a:schemeClr val="accent1"/>
+          </a:effectRef>
+          <a:fontRef idx="minor">
+            <a:schemeClr val="lt1"/>
+          </a:fontRef>
+        </p:style>
+        <p:txBody>
+          <a:bodyPr rtlCol="0" anchor="ctr"/>
+          <a:lstStyle/>
+          <a:p>
+            <a:pPr algn="ctr"/>
+            <a:r>
+              <a:rPr lang="en-US" sz="2000" dirty="0">
+                <a:solidFill>
+                  <a:schemeClr val="tx1"/>
+                </a:solidFill>
+              </a:rPr>
+              <a:t>3. Graph Algorithms</a:t>
+            </a:r>
+          </a:p>
+        </p:txBody>
+      </p:sp>
+      <p:sp>
+        <p:nvSpPr>
+          <p:cNvPr id="8" name="Rectangle 7">
+            <a:extLst>
+              <a:ext uri="{FF2B5EF4-FFF2-40B4-BE49-F238E27FC236}">
+                <a16:creationId xmlns:a16="http://schemas.microsoft.com/office/drawing/2014/main" id="{A234FC6E-068F-82BA-D948-0872902BF117}"/>
+              </a:ext>
+            </a:extLst>
+          </p:cNvPr>
+          <p:cNvSpPr/>
+          <p:nvPr/>
+        </p:nvSpPr>
+        <p:spPr>
+          <a:xfrm>
+            <a:off x="1215334" y="3591320"/>
+            <a:ext cx="2085982" cy="1074244"/>
+          </a:xfrm>
+          <a:prstGeom prst="rect">
+            <a:avLst/>
+          </a:prstGeom>
+          <a:noFill/>
+          <a:ln w="19050">
+            <a:solidFill>
+              <a:schemeClr val="tx1"/>
+            </a:solidFill>
+          </a:ln>
+        </p:spPr>
+        <p:style>
+          <a:lnRef idx="2">
+            <a:schemeClr val="accent1">
+              <a:shade val="15000"/>
+            </a:schemeClr>
+          </a:lnRef>
+          <a:fillRef idx="1">
+            <a:schemeClr val="accent1"/>
+          </a:fillRef>
+          <a:effectRef idx="0">
+            <a:schemeClr val="accent1"/>
+          </a:effectRef>
+          <a:fontRef idx="minor">
+            <a:schemeClr val="lt1"/>
+          </a:fontRef>
+        </p:style>
+        <p:txBody>
+          <a:bodyPr rtlCol="0" anchor="ctr"/>
+          <a:lstStyle/>
+          <a:p>
+            <a:pPr algn="ctr"/>
+            <a:r>
+              <a:rPr lang="en-US" sz="2000" dirty="0">
+                <a:solidFill>
+                  <a:schemeClr val="tx1"/>
+                </a:solidFill>
+              </a:rPr>
+              <a:t>2. Dimensionality Reduction</a:t>
+            </a:r>
+          </a:p>
+        </p:txBody>
+      </p:sp>
+      <p:sp>
+        <p:nvSpPr>
+          <p:cNvPr id="10" name="Left Brace 9">
+            <a:extLst>
+              <a:ext uri="{FF2B5EF4-FFF2-40B4-BE49-F238E27FC236}">
+                <a16:creationId xmlns:a16="http://schemas.microsoft.com/office/drawing/2014/main" id="{6B807C0C-B6B7-55FC-4A73-937C1A517C09}"/>
+              </a:ext>
+            </a:extLst>
+          </p:cNvPr>
+          <p:cNvSpPr/>
+          <p:nvPr/>
+        </p:nvSpPr>
+        <p:spPr>
+          <a:xfrm>
+            <a:off x="865089" y="3571535"/>
+            <a:ext cx="172578" cy="1094029"/>
+          </a:xfrm>
+          <a:prstGeom prst="leftBrace">
+            <a:avLst/>
+          </a:prstGeom>
+          <a:ln w="19050">
+            <a:solidFill>
+              <a:schemeClr val="tx1"/>
+            </a:solidFill>
+          </a:ln>
+        </p:spPr>
+        <p:style>
+          <a:lnRef idx="1">
+            <a:schemeClr val="accent1"/>
+          </a:lnRef>
+          <a:fillRef idx="0">
+            <a:schemeClr val="accent1"/>
+          </a:fillRef>
+          <a:effectRef idx="0">
+            <a:schemeClr val="accent1"/>
+          </a:effectRef>
+          <a:fontRef idx="minor">
+            <a:schemeClr val="tx1"/>
+          </a:fontRef>
+        </p:style>
+        <p:txBody>
+          <a:bodyPr rtlCol="0" anchor="ctr"/>
+          <a:lstStyle/>
+          <a:p>
+            <a:pPr algn="ctr"/>
+            <a:endParaRPr lang="en-US"/>
+          </a:p>
+        </p:txBody>
+      </p:sp>
+      <p:sp>
+        <p:nvSpPr>
+          <p:cNvPr id="11" name="TextBox 10">
+            <a:extLst>
+              <a:ext uri="{FF2B5EF4-FFF2-40B4-BE49-F238E27FC236}">
+                <a16:creationId xmlns:a16="http://schemas.microsoft.com/office/drawing/2014/main" id="{CD0513D5-3561-EC84-E71B-4706879A90A1}"/>
+              </a:ext>
+            </a:extLst>
+          </p:cNvPr>
+          <p:cNvSpPr txBox="1"/>
+          <p:nvPr/>
+        </p:nvSpPr>
+        <p:spPr>
+          <a:xfrm rot="16200000">
+            <a:off x="-286998" y="3724841"/>
+            <a:ext cx="1571596" cy="707886"/>
+          </a:xfrm>
+          <a:prstGeom prst="rect">
+            <a:avLst/>
+          </a:prstGeom>
+          <a:noFill/>
+        </p:spPr>
+        <p:txBody>
+          <a:bodyPr wrap="square" rtlCol="0">
+            <a:spAutoFit/>
+          </a:bodyPr>
+          <a:lstStyle/>
+          <a:p>
+            <a:pPr algn="ctr"/>
+            <a:r>
+              <a:rPr lang="en-US" sz="2000" dirty="0"/>
+              <a:t>Core Algorithms</a:t>
+            </a:r>
+          </a:p>
+        </p:txBody>
+      </p:sp>
+      <p:sp>
+        <p:nvSpPr>
+          <p:cNvPr id="12" name="Rectangle 11">
+            <a:extLst>
+              <a:ext uri="{FF2B5EF4-FFF2-40B4-BE49-F238E27FC236}">
+                <a16:creationId xmlns:a16="http://schemas.microsoft.com/office/drawing/2014/main" id="{B042D63B-E913-3364-5865-54C574ED22CD}"/>
+              </a:ext>
+            </a:extLst>
+          </p:cNvPr>
+          <p:cNvSpPr/>
+          <p:nvPr/>
+        </p:nvSpPr>
+        <p:spPr>
+          <a:xfrm>
+            <a:off x="1280175" y="5154275"/>
+            <a:ext cx="1961804" cy="1264023"/>
+          </a:xfrm>
+          <a:prstGeom prst="rect">
+            <a:avLst/>
+          </a:prstGeom>
+          <a:noFill/>
+          <a:ln w="19050">
+            <a:solidFill>
+              <a:schemeClr val="tx1"/>
+            </a:solidFill>
+          </a:ln>
+        </p:spPr>
+        <p:style>
+          <a:lnRef idx="2">
+            <a:schemeClr val="accent1">
+              <a:shade val="15000"/>
+            </a:schemeClr>
+          </a:lnRef>
+          <a:fillRef idx="1">
+            <a:schemeClr val="accent1"/>
+          </a:fillRef>
+          <a:effectRef idx="0">
+            <a:schemeClr val="accent1"/>
+          </a:effectRef>
+          <a:fontRef idx="minor">
+            <a:schemeClr val="lt1"/>
+          </a:fontRef>
+        </p:style>
+        <p:txBody>
+          <a:bodyPr rtlCol="0" anchor="ctr"/>
+          <a:lstStyle/>
+          <a:p>
+            <a:pPr algn="ctr"/>
+            <a:r>
+              <a:rPr lang="en-US" sz="2000" dirty="0">
+                <a:solidFill>
+                  <a:schemeClr val="tx1"/>
+                </a:solidFill>
+              </a:rPr>
+              <a:t>3. Social Network Analysis</a:t>
+            </a:r>
+          </a:p>
+        </p:txBody>
+      </p:sp>
+      <p:sp>
+        <p:nvSpPr>
+          <p:cNvPr id="14" name="Left Brace 13">
+            <a:extLst>
+              <a:ext uri="{FF2B5EF4-FFF2-40B4-BE49-F238E27FC236}">
+                <a16:creationId xmlns:a16="http://schemas.microsoft.com/office/drawing/2014/main" id="{35E5DEDA-5FFD-FC06-5888-EB758D78C155}"/>
+              </a:ext>
+            </a:extLst>
+          </p:cNvPr>
+          <p:cNvSpPr/>
+          <p:nvPr/>
+        </p:nvSpPr>
+        <p:spPr>
+          <a:xfrm>
+            <a:off x="858563" y="5154275"/>
+            <a:ext cx="164275" cy="1264024"/>
+          </a:xfrm>
+          <a:prstGeom prst="leftBrace">
+            <a:avLst/>
+          </a:prstGeom>
+          <a:ln w="19050">
+            <a:solidFill>
+              <a:schemeClr val="tx1"/>
+            </a:solidFill>
+          </a:ln>
+        </p:spPr>
+        <p:style>
+          <a:lnRef idx="1">
+            <a:schemeClr val="accent1"/>
+          </a:lnRef>
+          <a:fillRef idx="0">
+            <a:schemeClr val="accent1"/>
+          </a:fillRef>
+          <a:effectRef idx="0">
+            <a:schemeClr val="accent1"/>
+          </a:effectRef>
+          <a:fontRef idx="minor">
+            <a:schemeClr val="tx1"/>
+          </a:fontRef>
+        </p:style>
+        <p:txBody>
+          <a:bodyPr rtlCol="0" anchor="ctr"/>
+          <a:lstStyle/>
+          <a:p>
+            <a:pPr algn="ctr"/>
+            <a:endParaRPr lang="en-US"/>
+          </a:p>
+        </p:txBody>
+      </p:sp>
+      <p:sp>
+        <p:nvSpPr>
+          <p:cNvPr id="15" name="TextBox 14">
+            <a:extLst>
+              <a:ext uri="{FF2B5EF4-FFF2-40B4-BE49-F238E27FC236}">
+                <a16:creationId xmlns:a16="http://schemas.microsoft.com/office/drawing/2014/main" id="{3061D0C7-FA6D-00D7-CF2A-B875D7CF029B}"/>
+              </a:ext>
+            </a:extLst>
+          </p:cNvPr>
+          <p:cNvSpPr txBox="1"/>
+          <p:nvPr/>
+        </p:nvSpPr>
+        <p:spPr>
+          <a:xfrm rot="16200000">
+            <a:off x="-322189" y="5405146"/>
+            <a:ext cx="1571596" cy="707886"/>
+          </a:xfrm>
+          <a:prstGeom prst="rect">
+            <a:avLst/>
+          </a:prstGeom>
+          <a:noFill/>
+        </p:spPr>
+        <p:txBody>
+          <a:bodyPr wrap="square" rtlCol="0">
+            <a:spAutoFit/>
+          </a:bodyPr>
+          <a:lstStyle/>
+          <a:p>
+            <a:pPr algn="ctr"/>
+            <a:r>
+              <a:rPr lang="en-US" sz="2000" dirty="0"/>
+              <a:t>Taks </a:t>
+            </a:r>
+            <a:r>
+              <a:rPr lang="en-US" sz="2000"/>
+              <a:t>Speific </a:t>
+            </a:r>
+            <a:r>
+              <a:rPr lang="en-US" sz="2000" dirty="0"/>
+              <a:t>Algorithms</a:t>
+            </a:r>
+          </a:p>
+        </p:txBody>
+      </p:sp>
+      <p:sp>
+        <p:nvSpPr>
+          <p:cNvPr id="16" name="Rectangle 15">
+            <a:extLst>
+              <a:ext uri="{FF2B5EF4-FFF2-40B4-BE49-F238E27FC236}">
+                <a16:creationId xmlns:a16="http://schemas.microsoft.com/office/drawing/2014/main" id="{8BCB2792-FBF9-D76F-A378-7E6596D54E0F}"/>
+              </a:ext>
+            </a:extLst>
+          </p:cNvPr>
+          <p:cNvSpPr/>
+          <p:nvPr/>
+        </p:nvSpPr>
+        <p:spPr>
+          <a:xfrm>
+            <a:off x="3811677" y="3631085"/>
+            <a:ext cx="2085982" cy="1094029"/>
+          </a:xfrm>
+          <a:prstGeom prst="rect">
+            <a:avLst/>
+          </a:prstGeom>
+          <a:noFill/>
+          <a:ln w="19050">
+            <a:solidFill>
+              <a:schemeClr val="tx1"/>
+            </a:solidFill>
+          </a:ln>
+        </p:spPr>
+        <p:style>
+          <a:lnRef idx="2">
+            <a:schemeClr val="accent1">
+              <a:shade val="15000"/>
+            </a:schemeClr>
+          </a:lnRef>
+          <a:fillRef idx="1">
+            <a:schemeClr val="accent1"/>
+          </a:fillRef>
+          <a:effectRef idx="0">
+            <a:schemeClr val="accent1"/>
+          </a:effectRef>
+          <a:fontRef idx="minor">
+            <a:schemeClr val="lt1"/>
+          </a:fontRef>
+        </p:style>
+        <p:txBody>
+          <a:bodyPr rtlCol="0" anchor="ctr"/>
+          <a:lstStyle/>
+          <a:p>
+            <a:pPr algn="ctr"/>
+            <a:r>
+              <a:rPr lang="en-US" sz="2000" dirty="0">
+                <a:solidFill>
+                  <a:schemeClr val="tx1"/>
+                </a:solidFill>
+              </a:rPr>
+              <a:t>5. Similarity Search and NN Algorithms</a:t>
+            </a:r>
+          </a:p>
+        </p:txBody>
+      </p:sp>
+      <p:sp>
+        <p:nvSpPr>
+          <p:cNvPr id="17" name="Rectangle 16">
+            <a:extLst>
+              <a:ext uri="{FF2B5EF4-FFF2-40B4-BE49-F238E27FC236}">
+                <a16:creationId xmlns:a16="http://schemas.microsoft.com/office/drawing/2014/main" id="{9A8CAD2D-EC71-A5F3-683F-41BF65DE958F}"/>
+              </a:ext>
+            </a:extLst>
+          </p:cNvPr>
+          <p:cNvSpPr/>
+          <p:nvPr/>
+        </p:nvSpPr>
+        <p:spPr>
+          <a:xfrm>
+            <a:off x="6408020" y="3640978"/>
+            <a:ext cx="2038966" cy="1123564"/>
+          </a:xfrm>
+          <a:prstGeom prst="rect">
+            <a:avLst/>
+          </a:prstGeom>
+          <a:noFill/>
+          <a:ln w="19050">
+            <a:solidFill>
+              <a:schemeClr val="tx1"/>
+            </a:solidFill>
+          </a:ln>
+        </p:spPr>
+        <p:style>
+          <a:lnRef idx="2">
+            <a:schemeClr val="accent1">
+              <a:shade val="15000"/>
+            </a:schemeClr>
+          </a:lnRef>
+          <a:fillRef idx="1">
+            <a:schemeClr val="accent1"/>
+          </a:fillRef>
+          <a:effectRef idx="0">
+            <a:schemeClr val="accent1"/>
+          </a:effectRef>
+          <a:fontRef idx="minor">
+            <a:schemeClr val="lt1"/>
+          </a:fontRef>
+        </p:style>
+        <p:txBody>
+          <a:bodyPr rtlCol="0" anchor="ctr"/>
+          <a:lstStyle/>
+          <a:p>
+            <a:pPr algn="ctr"/>
+            <a:r>
+              <a:rPr lang="en-US" sz="2000" dirty="0">
+                <a:solidFill>
+                  <a:schemeClr val="tx1"/>
+                </a:solidFill>
+              </a:rPr>
+              <a:t>4. Online Algorithms</a:t>
+            </a:r>
+          </a:p>
+        </p:txBody>
+      </p:sp>
+      <p:sp>
+        <p:nvSpPr>
+          <p:cNvPr id="18" name="Rectangle 17">
+            <a:extLst>
+              <a:ext uri="{FF2B5EF4-FFF2-40B4-BE49-F238E27FC236}">
+                <a16:creationId xmlns:a16="http://schemas.microsoft.com/office/drawing/2014/main" id="{67EB3589-9BBE-D38D-C09A-C7A36757F4E1}"/>
+              </a:ext>
+            </a:extLst>
+          </p:cNvPr>
+          <p:cNvSpPr/>
+          <p:nvPr/>
+        </p:nvSpPr>
+        <p:spPr>
+          <a:xfrm>
+            <a:off x="8985680" y="5155489"/>
+            <a:ext cx="1894527" cy="1262809"/>
+          </a:xfrm>
+          <a:prstGeom prst="rect">
+            <a:avLst/>
+          </a:prstGeom>
+          <a:noFill/>
+          <a:ln w="19050">
+            <a:solidFill>
+              <a:schemeClr val="tx1"/>
+            </a:solidFill>
+          </a:ln>
+        </p:spPr>
+        <p:style>
+          <a:lnRef idx="2">
+            <a:schemeClr val="accent1">
+              <a:shade val="15000"/>
+            </a:schemeClr>
+          </a:lnRef>
+          <a:fillRef idx="1">
+            <a:schemeClr val="accent1"/>
+          </a:fillRef>
+          <a:effectRef idx="0">
+            <a:schemeClr val="accent1"/>
+          </a:effectRef>
+          <a:fontRef idx="minor">
+            <a:schemeClr val="lt1"/>
+          </a:fontRef>
+        </p:style>
+        <p:txBody>
+          <a:bodyPr rtlCol="0" anchor="ctr"/>
+          <a:lstStyle/>
+          <a:p>
+            <a:pPr algn="ctr"/>
+            <a:r>
+              <a:rPr lang="en-US" sz="2000" dirty="0">
+                <a:solidFill>
+                  <a:schemeClr val="tx1"/>
+                </a:solidFill>
+              </a:rPr>
+              <a:t>8. Clustering Algorithms</a:t>
+            </a:r>
+          </a:p>
+        </p:txBody>
+      </p:sp>
+      <p:sp>
+        <p:nvSpPr>
+          <p:cNvPr id="20" name="Rectangle 19">
+            <a:extLst>
+              <a:ext uri="{FF2B5EF4-FFF2-40B4-BE49-F238E27FC236}">
+                <a16:creationId xmlns:a16="http://schemas.microsoft.com/office/drawing/2014/main" id="{5C5EBFDB-140B-9B88-CE63-77419A11C6E4}"/>
+              </a:ext>
+            </a:extLst>
+          </p:cNvPr>
+          <p:cNvSpPr/>
+          <p:nvPr/>
+        </p:nvSpPr>
+        <p:spPr>
+          <a:xfrm>
+            <a:off x="6470354" y="5154275"/>
+            <a:ext cx="2016833" cy="1245689"/>
+          </a:xfrm>
+          <a:prstGeom prst="rect">
+            <a:avLst/>
+          </a:prstGeom>
+          <a:noFill/>
+          <a:ln w="19050">
+            <a:solidFill>
+              <a:schemeClr val="tx1"/>
+            </a:solidFill>
+          </a:ln>
+        </p:spPr>
+        <p:style>
+          <a:lnRef idx="2">
+            <a:schemeClr val="accent1">
+              <a:shade val="15000"/>
+            </a:schemeClr>
+          </a:lnRef>
+          <a:fillRef idx="1">
+            <a:schemeClr val="accent1"/>
+          </a:fillRef>
+          <a:effectRef idx="0">
+            <a:schemeClr val="accent1"/>
+          </a:effectRef>
+          <a:fontRef idx="minor">
+            <a:schemeClr val="lt1"/>
+          </a:fontRef>
+        </p:style>
+        <p:txBody>
+          <a:bodyPr rtlCol="0" anchor="ctr"/>
+          <a:lstStyle/>
+          <a:p>
+            <a:pPr algn="ctr"/>
+            <a:r>
+              <a:rPr lang="en-US" sz="2000" dirty="0">
+                <a:solidFill>
+                  <a:schemeClr val="tx1"/>
+                </a:solidFill>
+              </a:rPr>
+              <a:t>7. Recommender  Algorithms</a:t>
+            </a:r>
+          </a:p>
+        </p:txBody>
+      </p:sp>
+      <p:sp>
+        <p:nvSpPr>
+          <p:cNvPr id="21" name="Rectangle 20">
+            <a:extLst>
+              <a:ext uri="{FF2B5EF4-FFF2-40B4-BE49-F238E27FC236}">
+                <a16:creationId xmlns:a16="http://schemas.microsoft.com/office/drawing/2014/main" id="{69AB1FD0-27FA-3784-41E8-6432B45E080D}"/>
+              </a:ext>
+            </a:extLst>
+          </p:cNvPr>
+          <p:cNvSpPr/>
+          <p:nvPr/>
+        </p:nvSpPr>
+        <p:spPr>
+          <a:xfrm>
+            <a:off x="3760595" y="5172609"/>
+            <a:ext cx="2085981" cy="1245689"/>
+          </a:xfrm>
+          <a:prstGeom prst="rect">
+            <a:avLst/>
+          </a:prstGeom>
+          <a:noFill/>
+          <a:ln w="19050">
+            <a:solidFill>
+              <a:schemeClr val="tx1"/>
+            </a:solidFill>
+          </a:ln>
+        </p:spPr>
+        <p:style>
+          <a:lnRef idx="2">
+            <a:schemeClr val="accent1">
+              <a:shade val="15000"/>
+            </a:schemeClr>
+          </a:lnRef>
+          <a:fillRef idx="1">
+            <a:schemeClr val="accent1"/>
+          </a:fillRef>
+          <a:effectRef idx="0">
+            <a:schemeClr val="accent1"/>
+          </a:effectRef>
+          <a:fontRef idx="minor">
+            <a:schemeClr val="lt1"/>
+          </a:fontRef>
+        </p:style>
+        <p:txBody>
+          <a:bodyPr rtlCol="0" anchor="ctr"/>
+          <a:lstStyle/>
+          <a:p>
+            <a:pPr algn="ctr"/>
+            <a:r>
+              <a:rPr lang="en-US" sz="2000" dirty="0">
+                <a:solidFill>
+                  <a:schemeClr val="tx1"/>
+                </a:solidFill>
+              </a:rPr>
+              <a:t>6. Web/Document ranking and search</a:t>
+            </a:r>
+          </a:p>
+        </p:txBody>
+      </p:sp>
+      <p:sp>
+        <p:nvSpPr>
+          <p:cNvPr id="22" name="Content Placeholder 2">
+            <a:extLst>
+              <a:ext uri="{FF2B5EF4-FFF2-40B4-BE49-F238E27FC236}">
+                <a16:creationId xmlns:a16="http://schemas.microsoft.com/office/drawing/2014/main" id="{302608D4-DE73-B603-CD44-1D4BB221F2DE}"/>
+              </a:ext>
+            </a:extLst>
+          </p:cNvPr>
+          <p:cNvSpPr txBox="1">
+            <a:spLocks/>
+          </p:cNvSpPr>
+          <p:nvPr/>
+        </p:nvSpPr>
+        <p:spPr>
+          <a:xfrm>
+            <a:off x="865089" y="797597"/>
+            <a:ext cx="10515600" cy="850578"/>
+          </a:xfrm>
+          <a:prstGeom prst="rect">
+            <a:avLst/>
+          </a:prstGeom>
+        </p:spPr>
+        <p:txBody>
+          <a:bodyPr>
+            <a:noAutofit/>
+          </a:bodyPr>
+          <a:lstStyle>
+            <a:lvl1pPr marL="228600" indent="-228600" algn="l" defTabSz="914400" rtl="0" eaLnBrk="1" latinLnBrk="0" hangingPunct="1">
+              <a:lnSpc>
+                <a:spcPct val="90000"/>
+              </a:lnSpc>
+              <a:spcBef>
+                <a:spcPts val="1000"/>
+              </a:spcBef>
+              <a:buFont typeface="Arial" panose="020B0604020202020204" pitchFamily="34" charset="0"/>
+              <a:buChar char="•"/>
+              <a:defRPr sz="2800" kern="1200">
+                <a:solidFill>
+                  <a:schemeClr val="tx1"/>
+                </a:solidFill>
+                <a:latin typeface="+mn-lt"/>
+                <a:ea typeface="+mn-ea"/>
+                <a:cs typeface="+mn-cs"/>
+              </a:defRPr>
+            </a:lvl1pPr>
+            <a:lvl2pPr marL="685800" indent="-228600" algn="l" defTabSz="914400" rtl="0" eaLnBrk="1" latinLnBrk="0" hangingPunct="1">
+              <a:lnSpc>
+                <a:spcPct val="90000"/>
+              </a:lnSpc>
+              <a:spcBef>
+                <a:spcPts val="500"/>
+              </a:spcBef>
+              <a:buFont typeface="Arial" panose="020B0604020202020204" pitchFamily="34" charset="0"/>
+              <a:buChar char="•"/>
+              <a:defRPr sz="2400" kern="1200">
+                <a:solidFill>
+                  <a:schemeClr val="tx1"/>
+                </a:solidFill>
+                <a:latin typeface="+mn-lt"/>
+                <a:ea typeface="+mn-ea"/>
+                <a:cs typeface="+mn-cs"/>
+              </a:defRPr>
+            </a:lvl2pPr>
+            <a:lvl3pPr marL="1143000" indent="-228600" algn="l" defTabSz="914400" rtl="0" eaLnBrk="1" latinLnBrk="0" hangingPunct="1">
+              <a:lnSpc>
+                <a:spcPct val="90000"/>
+              </a:lnSpc>
+              <a:spcBef>
+                <a:spcPts val="500"/>
+              </a:spcBef>
+              <a:buFont typeface="Arial" panose="020B0604020202020204" pitchFamily="34" charset="0"/>
+              <a:buChar char="•"/>
+              <a:defRPr sz="2000" kern="1200">
+                <a:solidFill>
+                  <a:schemeClr val="tx1"/>
+                </a:solidFill>
+                <a:latin typeface="+mn-lt"/>
+                <a:ea typeface="+mn-ea"/>
+                <a:cs typeface="+mn-cs"/>
+              </a:defRPr>
+            </a:lvl3pPr>
+            <a:lvl4pPr marL="1600200" indent="-228600" algn="l" defTabSz="914400" rtl="0" eaLnBrk="1" latinLnBrk="0" hangingPunct="1">
+              <a:lnSpc>
+                <a:spcPct val="90000"/>
+              </a:lnSpc>
+              <a:spcBef>
+                <a:spcPts val="500"/>
+              </a:spcBef>
+              <a:buFont typeface="Arial" panose="020B0604020202020204" pitchFamily="34" charset="0"/>
+              <a:buChar char="•"/>
+              <a:defRPr sz="1800" kern="1200">
+                <a:solidFill>
+                  <a:schemeClr val="tx1"/>
+                </a:solidFill>
+                <a:latin typeface="+mn-lt"/>
+                <a:ea typeface="+mn-ea"/>
+                <a:cs typeface="+mn-cs"/>
+              </a:defRPr>
+            </a:lvl4pPr>
+            <a:lvl5pPr marL="2057400" indent="-228600" algn="l" defTabSz="914400" rtl="0" eaLnBrk="1" latinLnBrk="0" hangingPunct="1">
+              <a:lnSpc>
+                <a:spcPct val="90000"/>
+              </a:lnSpc>
+              <a:spcBef>
+                <a:spcPts val="500"/>
+              </a:spcBef>
+              <a:buFont typeface="Arial" panose="020B0604020202020204" pitchFamily="34" charset="0"/>
+              <a:buChar char="•"/>
+              <a:defRPr sz="1800" kern="1200">
+                <a:solidFill>
+                  <a:schemeClr val="tx1"/>
+                </a:solidFill>
+                <a:latin typeface="+mn-lt"/>
+                <a:ea typeface="+mn-ea"/>
+                <a:cs typeface="+mn-cs"/>
+              </a:defRPr>
+            </a:lvl5pPr>
+            <a:lvl6pPr marL="2514600" indent="-228600" algn="l" defTabSz="914400" rtl="0" eaLnBrk="1" latinLnBrk="0" hangingPunct="1">
+              <a:lnSpc>
+                <a:spcPct val="90000"/>
+              </a:lnSpc>
+              <a:spcBef>
+                <a:spcPts val="500"/>
+              </a:spcBef>
+              <a:buFont typeface="Arial" panose="020B0604020202020204" pitchFamily="34" charset="0"/>
+              <a:buChar char="•"/>
+              <a:defRPr sz="1800" kern="1200">
+                <a:solidFill>
+                  <a:schemeClr val="tx1"/>
+                </a:solidFill>
+                <a:latin typeface="+mn-lt"/>
+                <a:ea typeface="+mn-ea"/>
+                <a:cs typeface="+mn-cs"/>
+              </a:defRPr>
+            </a:lvl6pPr>
+            <a:lvl7pPr marL="2971800" indent="-228600" algn="l" defTabSz="914400" rtl="0" eaLnBrk="1" latinLnBrk="0" hangingPunct="1">
+              <a:lnSpc>
+                <a:spcPct val="90000"/>
+              </a:lnSpc>
+              <a:spcBef>
+                <a:spcPts val="500"/>
+              </a:spcBef>
+              <a:buFont typeface="Arial" panose="020B0604020202020204" pitchFamily="34" charset="0"/>
+              <a:buChar char="•"/>
+              <a:defRPr sz="1800" kern="1200">
+                <a:solidFill>
+                  <a:schemeClr val="tx1"/>
+                </a:solidFill>
+                <a:latin typeface="+mn-lt"/>
+                <a:ea typeface="+mn-ea"/>
+                <a:cs typeface="+mn-cs"/>
+              </a:defRPr>
+            </a:lvl7pPr>
+            <a:lvl8pPr marL="3429000" indent="-228600" algn="l" defTabSz="914400" rtl="0" eaLnBrk="1" latinLnBrk="0" hangingPunct="1">
+              <a:lnSpc>
+                <a:spcPct val="90000"/>
+              </a:lnSpc>
+              <a:spcBef>
+                <a:spcPts val="500"/>
+              </a:spcBef>
+              <a:buFont typeface="Arial" panose="020B0604020202020204" pitchFamily="34" charset="0"/>
+              <a:buChar char="•"/>
+              <a:defRPr sz="1800" kern="1200">
+                <a:solidFill>
+                  <a:schemeClr val="tx1"/>
+                </a:solidFill>
+                <a:latin typeface="+mn-lt"/>
+                <a:ea typeface="+mn-ea"/>
+                <a:cs typeface="+mn-cs"/>
+              </a:defRPr>
+            </a:lvl8pPr>
+            <a:lvl9pPr marL="3886200" indent="-228600" algn="l" defTabSz="914400" rtl="0" eaLnBrk="1" latinLnBrk="0" hangingPunct="1">
+              <a:lnSpc>
+                <a:spcPct val="90000"/>
+              </a:lnSpc>
+              <a:spcBef>
+                <a:spcPts val="500"/>
+              </a:spcBef>
+              <a:buFont typeface="Arial" panose="020B0604020202020204" pitchFamily="34" charset="0"/>
+              <a:buChar char="•"/>
+              <a:defRPr sz="1800" kern="1200">
+                <a:solidFill>
+                  <a:schemeClr val="tx1"/>
+                </a:solidFill>
+                <a:latin typeface="+mn-lt"/>
+                <a:ea typeface="+mn-ea"/>
+                <a:cs typeface="+mn-cs"/>
+              </a:defRPr>
+            </a:lvl9pPr>
+          </a:lstStyle>
+          <a:p>
+            <a:pPr marL="0" indent="0">
+              <a:buFont typeface="Arial" panose="020B0604020202020204" pitchFamily="34" charset="0"/>
+              <a:buNone/>
+            </a:pPr>
+            <a:r>
+              <a:rPr lang="en-US" dirty="0"/>
+              <a:t>The main topics in this course are interconnected and build on each other</a:t>
+            </a:r>
+          </a:p>
+        </p:txBody>
+      </p:sp>
+    </p:spTree>
+    <p:extLst>
+      <p:ext uri="{BB962C8B-B14F-4D97-AF65-F5344CB8AC3E}">
+        <p14:creationId xmlns:p14="http://schemas.microsoft.com/office/powerpoint/2010/main" val="581234857"/>
+      </p:ext>
+    </p:extLst>
+  </p:cSld>
+  <p:clrMapOvr>
+    <a:masterClrMapping/>
+  </p:clrMapOvr>
+</p:sld>
+</file>
+
+<file path=ppt/slides/slide31.xml><?xml version="1.0" encoding="utf-8"?>
+<p:sld xmlns:a="http://schemas.openxmlformats.org/drawingml/2006/main" xmlns:r="http://schemas.openxmlformats.org/officeDocument/2006/relationships" xmlns:p="http://schemas.openxmlformats.org/presentationml/2006/main">
+  <p:cSld>
+    <p:spTree>
+      <p:nvGrpSpPr>
         <p:cNvPr id="1" name=""/>
         <p:cNvGrpSpPr/>
         <p:nvPr/>
@@ -18406,7 +19524,7 @@
 </p:sld>
 </file>
 
-<file path=ppt/slides/slide31.xml><?xml version="1.0" encoding="utf-8"?>
+<file path=ppt/slides/slide32.xml><?xml version="1.0" encoding="utf-8"?>
 <p:sld xmlns:a="http://schemas.openxmlformats.org/drawingml/2006/main" xmlns:r="http://schemas.openxmlformats.org/officeDocument/2006/relationships" xmlns:p="http://schemas.openxmlformats.org/presentationml/2006/main">
   <p:cSld>
     <p:spTree>
@@ -18466,18 +19584,12 @@
 </p:sld>
 </file>
 
-<file path=ppt/slides/slide32.xml><?xml version="1.0" encoding="utf-8"?>
+<file path=ppt/slides/slide33.xml><?xml version="1.0" encoding="utf-8"?>
 <p:sld xmlns:a="http://schemas.openxmlformats.org/drawingml/2006/main" xmlns:r="http://schemas.openxmlformats.org/officeDocument/2006/relationships" xmlns:p="http://schemas.openxmlformats.org/presentationml/2006/main">
   <p:cSld>
     <p:spTree>
       <p:nvGrpSpPr>
-        <p:cNvPr id="1" name="">
-          <a:extLst>
-            <a:ext uri="{FF2B5EF4-FFF2-40B4-BE49-F238E27FC236}">
-              <a16:creationId xmlns:a16="http://schemas.microsoft.com/office/drawing/2014/main" id="{ED7A9242-6F04-0255-B6E4-003EE805CF99}"/>
-            </a:ext>
-          </a:extLst>
-        </p:cNvPr>
+        <p:cNvPr id="1" name=""/>
         <p:cNvGrpSpPr/>
         <p:nvPr/>
       </p:nvGrpSpPr>
@@ -18489,910 +19601,212 @@
           <a:chExt cx="0" cy="0"/>
         </a:xfrm>
       </p:grpSpPr>
+      <mc:AlternateContent xmlns:mc="http://schemas.openxmlformats.org/markup-compatibility/2006">
+        <mc:Choice xmlns:a14="http://schemas.microsoft.com/office/drawing/2010/main" Requires="a14">
+          <p:sp>
+            <p:nvSpPr>
+              <p:cNvPr id="3" name="Content Placeholder 2">
+                <a:extLst>
+                  <a:ext uri="{FF2B5EF4-FFF2-40B4-BE49-F238E27FC236}">
+                    <a16:creationId xmlns:a16="http://schemas.microsoft.com/office/drawing/2014/main" id="{258E6AF3-7615-4BD1-878E-A94C93E98F90}"/>
+                  </a:ext>
+                </a:extLst>
+              </p:cNvPr>
+              <p:cNvSpPr>
+                <a:spLocks noGrp="1"/>
+              </p:cNvSpPr>
+              <p:nvPr>
+                <p:ph idx="1"/>
+              </p:nvPr>
+            </p:nvSpPr>
+            <p:spPr>
+              <a:xfrm>
+                <a:off x="838200" y="1324927"/>
+                <a:ext cx="10515600" cy="4898217"/>
+              </a:xfrm>
+            </p:spPr>
+            <p:txBody>
+              <a:bodyPr>
+                <a:normAutofit/>
+              </a:bodyPr>
+              <a:lstStyle/>
+              <a:p>
+                <a:pPr marL="0" indent="0">
+                  <a:buNone/>
+                </a:pPr>
+                <a:r>
+                  <a:rPr lang="en-US" dirty="0"/>
+                  <a:t>Need to store and retrieve massive quantities of data  </a:t>
+                </a:r>
+              </a:p>
+              <a:p>
+                <a:r>
+                  <a:rPr lang="en-US" dirty="0"/>
+                  <a:t>Manage with key-value pairs as a tuple, </a:t>
+                </a:r>
+                <a14:m>
+                  <m:oMath xmlns:m="http://schemas.openxmlformats.org/officeDocument/2006/math">
+                    <m:r>
+                      <a:rPr lang="en-US" b="0" i="1" smtClean="0">
+                        <a:latin typeface="Cambria Math" panose="02040503050406030204" pitchFamily="18" charset="0"/>
+                      </a:rPr>
+                      <m:t>(</m:t>
+                    </m:r>
+                    <m:r>
+                      <a:rPr lang="en-US" b="0" i="1" smtClean="0">
+                        <a:latin typeface="Cambria Math" panose="02040503050406030204" pitchFamily="18" charset="0"/>
+                      </a:rPr>
+                      <m:t>𝐾</m:t>
+                    </m:r>
+                    <m:r>
+                      <a:rPr lang="en-US" b="0" i="1" smtClean="0">
+                        <a:latin typeface="Cambria Math" panose="02040503050406030204" pitchFamily="18" charset="0"/>
+                      </a:rPr>
+                      <m:t>,</m:t>
+                    </m:r>
+                    <m:r>
+                      <a:rPr lang="en-US" b="0" i="1" smtClean="0">
+                        <a:latin typeface="Cambria Math" panose="02040503050406030204" pitchFamily="18" charset="0"/>
+                      </a:rPr>
+                      <m:t>𝑉</m:t>
+                    </m:r>
+                    <m:r>
+                      <a:rPr lang="en-US" b="0" i="1" smtClean="0">
+                        <a:latin typeface="Cambria Math" panose="02040503050406030204" pitchFamily="18" charset="0"/>
+                      </a:rPr>
+                      <m:t>)</m:t>
+                    </m:r>
+                  </m:oMath>
+                </a14:m>
+                <a:r>
+                  <a:rPr lang="en-US" dirty="0"/>
+                  <a:t>  </a:t>
+                </a:r>
+              </a:p>
+              <a:p>
+                <a:r>
+                  <a:rPr lang="en-US" dirty="0"/>
+                  <a:t>The key, </a:t>
+                </a:r>
+                <a14:m>
+                  <m:oMath xmlns:m="http://schemas.openxmlformats.org/officeDocument/2006/math">
+                    <m:r>
+                      <a:rPr lang="en-US" b="0" i="1" smtClean="0">
+                        <a:latin typeface="Cambria Math" panose="02040503050406030204" pitchFamily="18" charset="0"/>
+                      </a:rPr>
+                      <m:t>𝐾</m:t>
+                    </m:r>
+                  </m:oMath>
+                </a14:m>
+                <a:r>
+                  <a:rPr lang="en-US" dirty="0"/>
+                  <a:t>, is index or identifier for the value, </a:t>
+                </a:r>
+                <a14:m>
+                  <m:oMath xmlns:m="http://schemas.openxmlformats.org/officeDocument/2006/math">
+                    <m:r>
+                      <a:rPr lang="en-US" b="0" i="1" smtClean="0">
+                        <a:latin typeface="Cambria Math" panose="02040503050406030204" pitchFamily="18" charset="0"/>
+                      </a:rPr>
+                      <m:t>𝑉</m:t>
+                    </m:r>
+                  </m:oMath>
+                </a14:m>
+                <a:r>
+                  <a:rPr lang="en-US" dirty="0"/>
+                  <a:t> </a:t>
+                </a:r>
+              </a:p>
+              <a:p>
+                <a:r>
+                  <a:rPr lang="en-US" dirty="0"/>
+                  <a:t>Key is a scalar, typically one of </a:t>
+                </a:r>
+              </a:p>
+              <a:p>
+                <a:pPr lvl="1"/>
+                <a:r>
+                  <a:rPr lang="en-US" sz="2800" dirty="0"/>
+                  <a:t>Binary string</a:t>
+                </a:r>
+              </a:p>
+              <a:p>
+                <a:pPr lvl="1"/>
+                <a:r>
+                  <a:rPr lang="en-US" sz="2800" dirty="0"/>
+                  <a:t>Integer </a:t>
+                </a:r>
+              </a:p>
+              <a:p>
+                <a:pPr lvl="1"/>
+                <a:r>
+                  <a:rPr lang="en-US" sz="2800" dirty="0"/>
+                  <a:t>Hexadecimal number</a:t>
+                </a:r>
+              </a:p>
+              <a:p>
+                <a:pPr lvl="1"/>
+                <a:r>
+                  <a:rPr lang="en-US" sz="2800" dirty="0"/>
+                  <a:t>Character string, often UTF encoded</a:t>
+                </a:r>
+              </a:p>
+              <a:p>
+                <a:endParaRPr lang="en-US" b="1" dirty="0"/>
+              </a:p>
+            </p:txBody>
+          </p:sp>
+        </mc:Choice>
+        <mc:Fallback>
+          <p:sp>
+            <p:nvSpPr>
+              <p:cNvPr id="3" name="Content Placeholder 2">
+                <a:extLst>
+                  <a:ext uri="{FF2B5EF4-FFF2-40B4-BE49-F238E27FC236}">
+                    <a16:creationId xmlns:a16="http://schemas.microsoft.com/office/drawing/2014/main" id="{258E6AF3-7615-4BD1-878E-A94C93E98F90}"/>
+                  </a:ext>
+                </a:extLst>
+              </p:cNvPr>
+              <p:cNvSpPr>
+                <a:spLocks noGrp="1" noRot="1" noChangeAspect="1" noMove="1" noResize="1" noEditPoints="1" noAdjustHandles="1" noChangeArrowheads="1" noChangeShapeType="1" noTextEdit="1"/>
+              </p:cNvSpPr>
+              <p:nvPr>
+                <p:ph idx="1"/>
+              </p:nvPr>
+            </p:nvSpPr>
+            <p:spPr>
+              <a:xfrm>
+                <a:off x="838200" y="1324927"/>
+                <a:ext cx="10515600" cy="4898217"/>
+              </a:xfrm>
+              <a:blipFill>
+                <a:blip r:embed="rId2"/>
+                <a:stretch>
+                  <a:fillRect l="-1217" t="-1990"/>
+                </a:stretch>
+              </a:blipFill>
+            </p:spPr>
+            <p:txBody>
+              <a:bodyPr/>
+              <a:lstStyle/>
+              <a:p>
+                <a:r>
+                  <a:rPr lang="en-US">
+                    <a:noFill/>
+                  </a:rPr>
+                  <a:t> </a:t>
+                </a:r>
+              </a:p>
+            </p:txBody>
+          </p:sp>
+        </mc:Fallback>
+      </mc:AlternateContent>
       <p:sp>
         <p:nvSpPr>
-          <p:cNvPr id="2" name="Title 1">
+          <p:cNvPr id="6" name="Title 1">
             <a:extLst>
               <a:ext uri="{FF2B5EF4-FFF2-40B4-BE49-F238E27FC236}">
-                <a16:creationId xmlns:a16="http://schemas.microsoft.com/office/drawing/2014/main" id="{97C0B4EF-F7E3-7E82-AE6D-66E8ED303FDB}"/>
-              </a:ext>
-            </a:extLst>
-          </p:cNvPr>
-          <p:cNvSpPr>
-            <a:spLocks noGrp="1"/>
-          </p:cNvSpPr>
-          <p:nvPr>
-            <p:ph type="title"/>
-          </p:nvPr>
-        </p:nvSpPr>
-        <p:spPr>
-          <a:xfrm>
-            <a:off x="916187" y="249623"/>
-            <a:ext cx="10515600" cy="662230"/>
-          </a:xfrm>
-        </p:spPr>
-        <p:txBody>
-          <a:bodyPr>
-            <a:normAutofit fontScale="90000"/>
-          </a:bodyPr>
-          <a:lstStyle/>
-          <a:p>
-            <a:r>
-              <a:rPr lang="en-US" sz="4900" dirty="0">
-                <a:latin typeface="+mn-lt"/>
-              </a:rPr>
-              <a:t>Main topics in this course</a:t>
-            </a:r>
-            <a:br>
-              <a:rPr lang="en-US" sz="4000" dirty="0">
-                <a:latin typeface="+mn-lt"/>
-              </a:rPr>
-            </a:br>
-            <a:endParaRPr lang="en-US" sz="4000" dirty="0">
-              <a:latin typeface="+mn-lt"/>
-            </a:endParaRPr>
-          </a:p>
-        </p:txBody>
-      </p:sp>
-      <p:sp>
-        <p:nvSpPr>
-          <p:cNvPr id="3" name="Left Brace 2">
-            <a:extLst>
-              <a:ext uri="{FF2B5EF4-FFF2-40B4-BE49-F238E27FC236}">
-                <a16:creationId xmlns:a16="http://schemas.microsoft.com/office/drawing/2014/main" id="{B43E0B5E-B811-4BBC-CEDF-97FC2AAC1766}"/>
-              </a:ext>
-            </a:extLst>
-          </p:cNvPr>
-          <p:cNvSpPr/>
-          <p:nvPr/>
-        </p:nvSpPr>
-        <p:spPr>
-          <a:xfrm>
-            <a:off x="756889" y="1964356"/>
-            <a:ext cx="225209" cy="1273261"/>
-          </a:xfrm>
-          <a:prstGeom prst="leftBrace">
-            <a:avLst/>
-          </a:prstGeom>
-          <a:ln w="19050">
-            <a:solidFill>
-              <a:schemeClr val="tx1"/>
-            </a:solidFill>
-          </a:ln>
-        </p:spPr>
-        <p:style>
-          <a:lnRef idx="1">
-            <a:schemeClr val="accent1"/>
-          </a:lnRef>
-          <a:fillRef idx="0">
-            <a:schemeClr val="accent1"/>
-          </a:fillRef>
-          <a:effectRef idx="0">
-            <a:schemeClr val="accent1"/>
-          </a:effectRef>
-          <a:fontRef idx="minor">
-            <a:schemeClr val="tx1"/>
-          </a:fontRef>
-        </p:style>
-        <p:txBody>
-          <a:bodyPr rtlCol="0" anchor="ctr"/>
-          <a:lstStyle/>
-          <a:p>
-            <a:pPr algn="ctr"/>
-            <a:endParaRPr lang="en-US"/>
-          </a:p>
-        </p:txBody>
-      </p:sp>
-      <p:sp>
-        <p:nvSpPr>
-          <p:cNvPr id="4" name="TextBox 3">
-            <a:extLst>
-              <a:ext uri="{FF2B5EF4-FFF2-40B4-BE49-F238E27FC236}">
-                <a16:creationId xmlns:a16="http://schemas.microsoft.com/office/drawing/2014/main" id="{77BB0425-4708-2E61-70FB-876C788A79E2}"/>
-              </a:ext>
-            </a:extLst>
-          </p:cNvPr>
-          <p:cNvSpPr txBox="1"/>
-          <p:nvPr/>
-        </p:nvSpPr>
-        <p:spPr>
-          <a:xfrm rot="16200000">
-            <a:off x="-238228" y="2251765"/>
-            <a:ext cx="1571596" cy="400110"/>
-          </a:xfrm>
-          <a:prstGeom prst="rect">
-            <a:avLst/>
-          </a:prstGeom>
-          <a:noFill/>
-        </p:spPr>
-        <p:txBody>
-          <a:bodyPr wrap="square" rtlCol="0">
-            <a:spAutoFit/>
-          </a:bodyPr>
-          <a:lstStyle/>
-          <a:p>
-            <a:pPr algn="ctr"/>
-            <a:r>
-              <a:rPr lang="en-US" sz="2000" dirty="0"/>
-              <a:t>Foundations </a:t>
-            </a:r>
-          </a:p>
-        </p:txBody>
-      </p:sp>
-      <p:sp>
-        <p:nvSpPr>
-          <p:cNvPr id="5" name="Rectangle 4">
-            <a:extLst>
-              <a:ext uri="{FF2B5EF4-FFF2-40B4-BE49-F238E27FC236}">
-                <a16:creationId xmlns:a16="http://schemas.microsoft.com/office/drawing/2014/main" id="{DAA42CDB-2EBC-28B2-6456-04829EC7EF48}"/>
-              </a:ext>
-            </a:extLst>
-          </p:cNvPr>
-          <p:cNvSpPr/>
-          <p:nvPr/>
-        </p:nvSpPr>
-        <p:spPr>
-          <a:xfrm>
-            <a:off x="1259812" y="1983695"/>
-            <a:ext cx="1951346" cy="1253922"/>
-          </a:xfrm>
-          <a:prstGeom prst="rect">
-            <a:avLst/>
-          </a:prstGeom>
-          <a:noFill/>
-          <a:ln w="38100">
-            <a:solidFill>
-              <a:srgbClr val="C00000"/>
-            </a:solidFill>
-          </a:ln>
-        </p:spPr>
-        <p:style>
-          <a:lnRef idx="2">
-            <a:schemeClr val="accent1">
-              <a:shade val="15000"/>
-            </a:schemeClr>
-          </a:lnRef>
-          <a:fillRef idx="1">
-            <a:schemeClr val="accent1"/>
-          </a:fillRef>
-          <a:effectRef idx="0">
-            <a:schemeClr val="accent1"/>
-          </a:effectRef>
-          <a:fontRef idx="minor">
-            <a:schemeClr val="lt1"/>
-          </a:fontRef>
-        </p:style>
-        <p:txBody>
-          <a:bodyPr rtlCol="0" anchor="ctr"/>
-          <a:lstStyle/>
-          <a:p>
-            <a:pPr algn="ctr"/>
-            <a:r>
-              <a:rPr lang="en-US" sz="2000" dirty="0">
-                <a:solidFill>
-                  <a:schemeClr val="tx1"/>
-                </a:solidFill>
-              </a:rPr>
-              <a:t>1. Hashing and K-V pair management </a:t>
-            </a:r>
-          </a:p>
-        </p:txBody>
-      </p:sp>
-      <p:sp>
-        <p:nvSpPr>
-          <p:cNvPr id="6" name="Rectangle 5">
-            <a:extLst>
-              <a:ext uri="{FF2B5EF4-FFF2-40B4-BE49-F238E27FC236}">
-                <a16:creationId xmlns:a16="http://schemas.microsoft.com/office/drawing/2014/main" id="{F5C7F060-78DB-AC42-6BFD-05BD50198440}"/>
-              </a:ext>
-            </a:extLst>
-          </p:cNvPr>
-          <p:cNvSpPr/>
-          <p:nvPr/>
-        </p:nvSpPr>
-        <p:spPr>
-          <a:xfrm>
-            <a:off x="3740233" y="2021536"/>
-            <a:ext cx="2157426" cy="1178239"/>
-          </a:xfrm>
-          <a:prstGeom prst="rect">
-            <a:avLst/>
-          </a:prstGeom>
-          <a:noFill/>
-          <a:ln w="19050">
-            <a:solidFill>
-              <a:schemeClr val="tx1"/>
-            </a:solidFill>
-          </a:ln>
-        </p:spPr>
-        <p:style>
-          <a:lnRef idx="2">
-            <a:schemeClr val="accent1">
-              <a:shade val="15000"/>
-            </a:schemeClr>
-          </a:lnRef>
-          <a:fillRef idx="1">
-            <a:schemeClr val="accent1"/>
-          </a:fillRef>
-          <a:effectRef idx="0">
-            <a:schemeClr val="accent1"/>
-          </a:effectRef>
-          <a:fontRef idx="minor">
-            <a:schemeClr val="lt1"/>
-          </a:fontRef>
-        </p:style>
-        <p:txBody>
-          <a:bodyPr rtlCol="0" anchor="ctr"/>
-          <a:lstStyle/>
-          <a:p>
-            <a:pPr algn="ctr"/>
-            <a:r>
-              <a:rPr lang="en-US" sz="2000" dirty="0">
-                <a:solidFill>
-                  <a:schemeClr val="tx1"/>
-                </a:solidFill>
-              </a:rPr>
-              <a:t>2. Distance and Similarity Metrics</a:t>
-            </a:r>
-          </a:p>
-        </p:txBody>
-      </p:sp>
-      <p:sp>
-        <p:nvSpPr>
-          <p:cNvPr id="7" name="Rectangle 6">
-            <a:extLst>
-              <a:ext uri="{FF2B5EF4-FFF2-40B4-BE49-F238E27FC236}">
-                <a16:creationId xmlns:a16="http://schemas.microsoft.com/office/drawing/2014/main" id="{F20B3888-4A09-E889-C7DE-5ECE32C17693}"/>
-              </a:ext>
-            </a:extLst>
-          </p:cNvPr>
-          <p:cNvSpPr/>
-          <p:nvPr/>
-        </p:nvSpPr>
-        <p:spPr>
-          <a:xfrm>
-            <a:off x="6408020" y="2037908"/>
-            <a:ext cx="2058805" cy="1213337"/>
-          </a:xfrm>
-          <a:prstGeom prst="rect">
-            <a:avLst/>
-          </a:prstGeom>
-          <a:noFill/>
-          <a:ln w="19050">
-            <a:solidFill>
-              <a:schemeClr val="tx1"/>
-            </a:solidFill>
-          </a:ln>
-        </p:spPr>
-        <p:style>
-          <a:lnRef idx="2">
-            <a:schemeClr val="accent1">
-              <a:shade val="15000"/>
-            </a:schemeClr>
-          </a:lnRef>
-          <a:fillRef idx="1">
-            <a:schemeClr val="accent1"/>
-          </a:fillRef>
-          <a:effectRef idx="0">
-            <a:schemeClr val="accent1"/>
-          </a:effectRef>
-          <a:fontRef idx="minor">
-            <a:schemeClr val="lt1"/>
-          </a:fontRef>
-        </p:style>
-        <p:txBody>
-          <a:bodyPr rtlCol="0" anchor="ctr"/>
-          <a:lstStyle/>
-          <a:p>
-            <a:pPr algn="ctr"/>
-            <a:r>
-              <a:rPr lang="en-US" sz="2000" dirty="0">
-                <a:solidFill>
-                  <a:schemeClr val="tx1"/>
-                </a:solidFill>
-              </a:rPr>
-              <a:t>3. Graph Algorithms</a:t>
-            </a:r>
-          </a:p>
-        </p:txBody>
-      </p:sp>
-      <p:sp>
-        <p:nvSpPr>
-          <p:cNvPr id="8" name="Rectangle 7">
-            <a:extLst>
-              <a:ext uri="{FF2B5EF4-FFF2-40B4-BE49-F238E27FC236}">
-                <a16:creationId xmlns:a16="http://schemas.microsoft.com/office/drawing/2014/main" id="{A234FC6E-068F-82BA-D948-0872902BF117}"/>
-              </a:ext>
-            </a:extLst>
-          </p:cNvPr>
-          <p:cNvSpPr/>
-          <p:nvPr/>
-        </p:nvSpPr>
-        <p:spPr>
-          <a:xfrm>
-            <a:off x="1215334" y="3591320"/>
-            <a:ext cx="2085982" cy="1074244"/>
-          </a:xfrm>
-          <a:prstGeom prst="rect">
-            <a:avLst/>
-          </a:prstGeom>
-          <a:noFill/>
-          <a:ln w="19050">
-            <a:solidFill>
-              <a:schemeClr val="tx1"/>
-            </a:solidFill>
-          </a:ln>
-        </p:spPr>
-        <p:style>
-          <a:lnRef idx="2">
-            <a:schemeClr val="accent1">
-              <a:shade val="15000"/>
-            </a:schemeClr>
-          </a:lnRef>
-          <a:fillRef idx="1">
-            <a:schemeClr val="accent1"/>
-          </a:fillRef>
-          <a:effectRef idx="0">
-            <a:schemeClr val="accent1"/>
-          </a:effectRef>
-          <a:fontRef idx="minor">
-            <a:schemeClr val="lt1"/>
-          </a:fontRef>
-        </p:style>
-        <p:txBody>
-          <a:bodyPr rtlCol="0" anchor="ctr"/>
-          <a:lstStyle/>
-          <a:p>
-            <a:pPr algn="ctr"/>
-            <a:r>
-              <a:rPr lang="en-US" sz="2000" dirty="0">
-                <a:solidFill>
-                  <a:schemeClr val="tx1"/>
-                </a:solidFill>
-              </a:rPr>
-              <a:t>2. Dimensionality Reduction</a:t>
-            </a:r>
-          </a:p>
-        </p:txBody>
-      </p:sp>
-      <p:sp>
-        <p:nvSpPr>
-          <p:cNvPr id="10" name="Left Brace 9">
-            <a:extLst>
-              <a:ext uri="{FF2B5EF4-FFF2-40B4-BE49-F238E27FC236}">
-                <a16:creationId xmlns:a16="http://schemas.microsoft.com/office/drawing/2014/main" id="{6B807C0C-B6B7-55FC-4A73-937C1A517C09}"/>
-              </a:ext>
-            </a:extLst>
-          </p:cNvPr>
-          <p:cNvSpPr/>
-          <p:nvPr/>
-        </p:nvSpPr>
-        <p:spPr>
-          <a:xfrm>
-            <a:off x="865089" y="3571535"/>
-            <a:ext cx="172578" cy="1094029"/>
-          </a:xfrm>
-          <a:prstGeom prst="leftBrace">
-            <a:avLst/>
-          </a:prstGeom>
-          <a:ln w="19050">
-            <a:solidFill>
-              <a:schemeClr val="tx1"/>
-            </a:solidFill>
-          </a:ln>
-        </p:spPr>
-        <p:style>
-          <a:lnRef idx="1">
-            <a:schemeClr val="accent1"/>
-          </a:lnRef>
-          <a:fillRef idx="0">
-            <a:schemeClr val="accent1"/>
-          </a:fillRef>
-          <a:effectRef idx="0">
-            <a:schemeClr val="accent1"/>
-          </a:effectRef>
-          <a:fontRef idx="minor">
-            <a:schemeClr val="tx1"/>
-          </a:fontRef>
-        </p:style>
-        <p:txBody>
-          <a:bodyPr rtlCol="0" anchor="ctr"/>
-          <a:lstStyle/>
-          <a:p>
-            <a:pPr algn="ctr"/>
-            <a:endParaRPr lang="en-US"/>
-          </a:p>
-        </p:txBody>
-      </p:sp>
-      <p:sp>
-        <p:nvSpPr>
-          <p:cNvPr id="11" name="TextBox 10">
-            <a:extLst>
-              <a:ext uri="{FF2B5EF4-FFF2-40B4-BE49-F238E27FC236}">
-                <a16:creationId xmlns:a16="http://schemas.microsoft.com/office/drawing/2014/main" id="{CD0513D5-3561-EC84-E71B-4706879A90A1}"/>
-              </a:ext>
-            </a:extLst>
-          </p:cNvPr>
-          <p:cNvSpPr txBox="1"/>
-          <p:nvPr/>
-        </p:nvSpPr>
-        <p:spPr>
-          <a:xfrm rot="16200000">
-            <a:off x="-286998" y="3724841"/>
-            <a:ext cx="1571596" cy="707886"/>
-          </a:xfrm>
-          <a:prstGeom prst="rect">
-            <a:avLst/>
-          </a:prstGeom>
-          <a:noFill/>
-        </p:spPr>
-        <p:txBody>
-          <a:bodyPr wrap="square" rtlCol="0">
-            <a:spAutoFit/>
-          </a:bodyPr>
-          <a:lstStyle/>
-          <a:p>
-            <a:pPr algn="ctr"/>
-            <a:r>
-              <a:rPr lang="en-US" sz="2000" dirty="0"/>
-              <a:t>Core Algorithms</a:t>
-            </a:r>
-          </a:p>
-        </p:txBody>
-      </p:sp>
-      <p:sp>
-        <p:nvSpPr>
-          <p:cNvPr id="12" name="Rectangle 11">
-            <a:extLst>
-              <a:ext uri="{FF2B5EF4-FFF2-40B4-BE49-F238E27FC236}">
-                <a16:creationId xmlns:a16="http://schemas.microsoft.com/office/drawing/2014/main" id="{B042D63B-E913-3364-5865-54C574ED22CD}"/>
-              </a:ext>
-            </a:extLst>
-          </p:cNvPr>
-          <p:cNvSpPr/>
-          <p:nvPr/>
-        </p:nvSpPr>
-        <p:spPr>
-          <a:xfrm>
-            <a:off x="1280175" y="5154275"/>
-            <a:ext cx="1961804" cy="1264023"/>
-          </a:xfrm>
-          <a:prstGeom prst="rect">
-            <a:avLst/>
-          </a:prstGeom>
-          <a:noFill/>
-          <a:ln w="19050">
-            <a:solidFill>
-              <a:schemeClr val="tx1"/>
-            </a:solidFill>
-          </a:ln>
-        </p:spPr>
-        <p:style>
-          <a:lnRef idx="2">
-            <a:schemeClr val="accent1">
-              <a:shade val="15000"/>
-            </a:schemeClr>
-          </a:lnRef>
-          <a:fillRef idx="1">
-            <a:schemeClr val="accent1"/>
-          </a:fillRef>
-          <a:effectRef idx="0">
-            <a:schemeClr val="accent1"/>
-          </a:effectRef>
-          <a:fontRef idx="minor">
-            <a:schemeClr val="lt1"/>
-          </a:fontRef>
-        </p:style>
-        <p:txBody>
-          <a:bodyPr rtlCol="0" anchor="ctr"/>
-          <a:lstStyle/>
-          <a:p>
-            <a:pPr algn="ctr"/>
-            <a:r>
-              <a:rPr lang="en-US" sz="2000" dirty="0">
-                <a:solidFill>
-                  <a:schemeClr val="tx1"/>
-                </a:solidFill>
-              </a:rPr>
-              <a:t>3. Social Network Analysis</a:t>
-            </a:r>
-          </a:p>
-        </p:txBody>
-      </p:sp>
-      <p:sp>
-        <p:nvSpPr>
-          <p:cNvPr id="14" name="Left Brace 13">
-            <a:extLst>
-              <a:ext uri="{FF2B5EF4-FFF2-40B4-BE49-F238E27FC236}">
-                <a16:creationId xmlns:a16="http://schemas.microsoft.com/office/drawing/2014/main" id="{35E5DEDA-5FFD-FC06-5888-EB758D78C155}"/>
-              </a:ext>
-            </a:extLst>
-          </p:cNvPr>
-          <p:cNvSpPr/>
-          <p:nvPr/>
-        </p:nvSpPr>
-        <p:spPr>
-          <a:xfrm>
-            <a:off x="858563" y="5154275"/>
-            <a:ext cx="164275" cy="1264024"/>
-          </a:xfrm>
-          <a:prstGeom prst="leftBrace">
-            <a:avLst/>
-          </a:prstGeom>
-          <a:ln w="19050">
-            <a:solidFill>
-              <a:schemeClr val="tx1"/>
-            </a:solidFill>
-          </a:ln>
-        </p:spPr>
-        <p:style>
-          <a:lnRef idx="1">
-            <a:schemeClr val="accent1"/>
-          </a:lnRef>
-          <a:fillRef idx="0">
-            <a:schemeClr val="accent1"/>
-          </a:fillRef>
-          <a:effectRef idx="0">
-            <a:schemeClr val="accent1"/>
-          </a:effectRef>
-          <a:fontRef idx="minor">
-            <a:schemeClr val="tx1"/>
-          </a:fontRef>
-        </p:style>
-        <p:txBody>
-          <a:bodyPr rtlCol="0" anchor="ctr"/>
-          <a:lstStyle/>
-          <a:p>
-            <a:pPr algn="ctr"/>
-            <a:endParaRPr lang="en-US"/>
-          </a:p>
-        </p:txBody>
-      </p:sp>
-      <p:sp>
-        <p:nvSpPr>
-          <p:cNvPr id="15" name="TextBox 14">
-            <a:extLst>
-              <a:ext uri="{FF2B5EF4-FFF2-40B4-BE49-F238E27FC236}">
-                <a16:creationId xmlns:a16="http://schemas.microsoft.com/office/drawing/2014/main" id="{3061D0C7-FA6D-00D7-CF2A-B875D7CF029B}"/>
-              </a:ext>
-            </a:extLst>
-          </p:cNvPr>
-          <p:cNvSpPr txBox="1"/>
-          <p:nvPr/>
-        </p:nvSpPr>
-        <p:spPr>
-          <a:xfrm rot="16200000">
-            <a:off x="-322189" y="5405146"/>
-            <a:ext cx="1571596" cy="707886"/>
-          </a:xfrm>
-          <a:prstGeom prst="rect">
-            <a:avLst/>
-          </a:prstGeom>
-          <a:noFill/>
-        </p:spPr>
-        <p:txBody>
-          <a:bodyPr wrap="square" rtlCol="0">
-            <a:spAutoFit/>
-          </a:bodyPr>
-          <a:lstStyle/>
-          <a:p>
-            <a:pPr algn="ctr"/>
-            <a:r>
-              <a:rPr lang="en-US" sz="2000" dirty="0"/>
-              <a:t>Taks </a:t>
-            </a:r>
-            <a:r>
-              <a:rPr lang="en-US" sz="2000"/>
-              <a:t>Speific </a:t>
-            </a:r>
-            <a:r>
-              <a:rPr lang="en-US" sz="2000" dirty="0"/>
-              <a:t>Algorithms</a:t>
-            </a:r>
-          </a:p>
-        </p:txBody>
-      </p:sp>
-      <p:sp>
-        <p:nvSpPr>
-          <p:cNvPr id="16" name="Rectangle 15">
-            <a:extLst>
-              <a:ext uri="{FF2B5EF4-FFF2-40B4-BE49-F238E27FC236}">
-                <a16:creationId xmlns:a16="http://schemas.microsoft.com/office/drawing/2014/main" id="{8BCB2792-FBF9-D76F-A378-7E6596D54E0F}"/>
-              </a:ext>
-            </a:extLst>
-          </p:cNvPr>
-          <p:cNvSpPr/>
-          <p:nvPr/>
-        </p:nvSpPr>
-        <p:spPr>
-          <a:xfrm>
-            <a:off x="3811677" y="3631085"/>
-            <a:ext cx="2085982" cy="1094029"/>
-          </a:xfrm>
-          <a:prstGeom prst="rect">
-            <a:avLst/>
-          </a:prstGeom>
-          <a:noFill/>
-          <a:ln w="19050">
-            <a:solidFill>
-              <a:schemeClr val="tx1"/>
-            </a:solidFill>
-          </a:ln>
-        </p:spPr>
-        <p:style>
-          <a:lnRef idx="2">
-            <a:schemeClr val="accent1">
-              <a:shade val="15000"/>
-            </a:schemeClr>
-          </a:lnRef>
-          <a:fillRef idx="1">
-            <a:schemeClr val="accent1"/>
-          </a:fillRef>
-          <a:effectRef idx="0">
-            <a:schemeClr val="accent1"/>
-          </a:effectRef>
-          <a:fontRef idx="minor">
-            <a:schemeClr val="lt1"/>
-          </a:fontRef>
-        </p:style>
-        <p:txBody>
-          <a:bodyPr rtlCol="0" anchor="ctr"/>
-          <a:lstStyle/>
-          <a:p>
-            <a:pPr algn="ctr"/>
-            <a:r>
-              <a:rPr lang="en-US" sz="2000" dirty="0">
-                <a:solidFill>
-                  <a:schemeClr val="tx1"/>
-                </a:solidFill>
-              </a:rPr>
-              <a:t>5. Similarity Search and NN Algorithms</a:t>
-            </a:r>
-          </a:p>
-        </p:txBody>
-      </p:sp>
-      <p:sp>
-        <p:nvSpPr>
-          <p:cNvPr id="17" name="Rectangle 16">
-            <a:extLst>
-              <a:ext uri="{FF2B5EF4-FFF2-40B4-BE49-F238E27FC236}">
-                <a16:creationId xmlns:a16="http://schemas.microsoft.com/office/drawing/2014/main" id="{9A8CAD2D-EC71-A5F3-683F-41BF65DE958F}"/>
-              </a:ext>
-            </a:extLst>
-          </p:cNvPr>
-          <p:cNvSpPr/>
-          <p:nvPr/>
-        </p:nvSpPr>
-        <p:spPr>
-          <a:xfrm>
-            <a:off x="6408020" y="3640978"/>
-            <a:ext cx="2038966" cy="1123564"/>
-          </a:xfrm>
-          <a:prstGeom prst="rect">
-            <a:avLst/>
-          </a:prstGeom>
-          <a:noFill/>
-          <a:ln w="19050">
-            <a:solidFill>
-              <a:schemeClr val="tx1"/>
-            </a:solidFill>
-          </a:ln>
-        </p:spPr>
-        <p:style>
-          <a:lnRef idx="2">
-            <a:schemeClr val="accent1">
-              <a:shade val="15000"/>
-            </a:schemeClr>
-          </a:lnRef>
-          <a:fillRef idx="1">
-            <a:schemeClr val="accent1"/>
-          </a:fillRef>
-          <a:effectRef idx="0">
-            <a:schemeClr val="accent1"/>
-          </a:effectRef>
-          <a:fontRef idx="minor">
-            <a:schemeClr val="lt1"/>
-          </a:fontRef>
-        </p:style>
-        <p:txBody>
-          <a:bodyPr rtlCol="0" anchor="ctr"/>
-          <a:lstStyle/>
-          <a:p>
-            <a:pPr algn="ctr"/>
-            <a:r>
-              <a:rPr lang="en-US" sz="2000" dirty="0">
-                <a:solidFill>
-                  <a:schemeClr val="tx1"/>
-                </a:solidFill>
-              </a:rPr>
-              <a:t>4. Online Algorithms</a:t>
-            </a:r>
-          </a:p>
-        </p:txBody>
-      </p:sp>
-      <p:sp>
-        <p:nvSpPr>
-          <p:cNvPr id="18" name="Rectangle 17">
-            <a:extLst>
-              <a:ext uri="{FF2B5EF4-FFF2-40B4-BE49-F238E27FC236}">
-                <a16:creationId xmlns:a16="http://schemas.microsoft.com/office/drawing/2014/main" id="{67EB3589-9BBE-D38D-C09A-C7A36757F4E1}"/>
-              </a:ext>
-            </a:extLst>
-          </p:cNvPr>
-          <p:cNvSpPr/>
-          <p:nvPr/>
-        </p:nvSpPr>
-        <p:spPr>
-          <a:xfrm>
-            <a:off x="8985680" y="5155489"/>
-            <a:ext cx="1894527" cy="1262809"/>
-          </a:xfrm>
-          <a:prstGeom prst="rect">
-            <a:avLst/>
-          </a:prstGeom>
-          <a:noFill/>
-          <a:ln w="19050">
-            <a:solidFill>
-              <a:schemeClr val="tx1"/>
-            </a:solidFill>
-          </a:ln>
-        </p:spPr>
-        <p:style>
-          <a:lnRef idx="2">
-            <a:schemeClr val="accent1">
-              <a:shade val="15000"/>
-            </a:schemeClr>
-          </a:lnRef>
-          <a:fillRef idx="1">
-            <a:schemeClr val="accent1"/>
-          </a:fillRef>
-          <a:effectRef idx="0">
-            <a:schemeClr val="accent1"/>
-          </a:effectRef>
-          <a:fontRef idx="minor">
-            <a:schemeClr val="lt1"/>
-          </a:fontRef>
-        </p:style>
-        <p:txBody>
-          <a:bodyPr rtlCol="0" anchor="ctr"/>
-          <a:lstStyle/>
-          <a:p>
-            <a:pPr algn="ctr"/>
-            <a:r>
-              <a:rPr lang="en-US" sz="2000" dirty="0">
-                <a:solidFill>
-                  <a:schemeClr val="tx1"/>
-                </a:solidFill>
-              </a:rPr>
-              <a:t>8. Clustering Algorithms</a:t>
-            </a:r>
-          </a:p>
-        </p:txBody>
-      </p:sp>
-      <p:sp>
-        <p:nvSpPr>
-          <p:cNvPr id="20" name="Rectangle 19">
-            <a:extLst>
-              <a:ext uri="{FF2B5EF4-FFF2-40B4-BE49-F238E27FC236}">
-                <a16:creationId xmlns:a16="http://schemas.microsoft.com/office/drawing/2014/main" id="{5C5EBFDB-140B-9B88-CE63-77419A11C6E4}"/>
-              </a:ext>
-            </a:extLst>
-          </p:cNvPr>
-          <p:cNvSpPr/>
-          <p:nvPr/>
-        </p:nvSpPr>
-        <p:spPr>
-          <a:xfrm>
-            <a:off x="6470354" y="5154275"/>
-            <a:ext cx="2016833" cy="1245689"/>
-          </a:xfrm>
-          <a:prstGeom prst="rect">
-            <a:avLst/>
-          </a:prstGeom>
-          <a:noFill/>
-          <a:ln w="19050">
-            <a:solidFill>
-              <a:schemeClr val="tx1"/>
-            </a:solidFill>
-          </a:ln>
-        </p:spPr>
-        <p:style>
-          <a:lnRef idx="2">
-            <a:schemeClr val="accent1">
-              <a:shade val="15000"/>
-            </a:schemeClr>
-          </a:lnRef>
-          <a:fillRef idx="1">
-            <a:schemeClr val="accent1"/>
-          </a:fillRef>
-          <a:effectRef idx="0">
-            <a:schemeClr val="accent1"/>
-          </a:effectRef>
-          <a:fontRef idx="minor">
-            <a:schemeClr val="lt1"/>
-          </a:fontRef>
-        </p:style>
-        <p:txBody>
-          <a:bodyPr rtlCol="0" anchor="ctr"/>
-          <a:lstStyle/>
-          <a:p>
-            <a:pPr algn="ctr"/>
-            <a:r>
-              <a:rPr lang="en-US" sz="2000" dirty="0">
-                <a:solidFill>
-                  <a:schemeClr val="tx1"/>
-                </a:solidFill>
-              </a:rPr>
-              <a:t>7. Recommender  Algorithms</a:t>
-            </a:r>
-          </a:p>
-        </p:txBody>
-      </p:sp>
-      <p:sp>
-        <p:nvSpPr>
-          <p:cNvPr id="21" name="Rectangle 20">
-            <a:extLst>
-              <a:ext uri="{FF2B5EF4-FFF2-40B4-BE49-F238E27FC236}">
-                <a16:creationId xmlns:a16="http://schemas.microsoft.com/office/drawing/2014/main" id="{69AB1FD0-27FA-3784-41E8-6432B45E080D}"/>
-              </a:ext>
-            </a:extLst>
-          </p:cNvPr>
-          <p:cNvSpPr/>
-          <p:nvPr/>
-        </p:nvSpPr>
-        <p:spPr>
-          <a:xfrm>
-            <a:off x="3760595" y="5172609"/>
-            <a:ext cx="2085981" cy="1245689"/>
-          </a:xfrm>
-          <a:prstGeom prst="rect">
-            <a:avLst/>
-          </a:prstGeom>
-          <a:noFill/>
-          <a:ln w="19050">
-            <a:solidFill>
-              <a:schemeClr val="tx1"/>
-            </a:solidFill>
-          </a:ln>
-        </p:spPr>
-        <p:style>
-          <a:lnRef idx="2">
-            <a:schemeClr val="accent1">
-              <a:shade val="15000"/>
-            </a:schemeClr>
-          </a:lnRef>
-          <a:fillRef idx="1">
-            <a:schemeClr val="accent1"/>
-          </a:fillRef>
-          <a:effectRef idx="0">
-            <a:schemeClr val="accent1"/>
-          </a:effectRef>
-          <a:fontRef idx="minor">
-            <a:schemeClr val="lt1"/>
-          </a:fontRef>
-        </p:style>
-        <p:txBody>
-          <a:bodyPr rtlCol="0" anchor="ctr"/>
-          <a:lstStyle/>
-          <a:p>
-            <a:pPr algn="ctr"/>
-            <a:r>
-              <a:rPr lang="en-US" sz="2000" dirty="0">
-                <a:solidFill>
-                  <a:schemeClr val="tx1"/>
-                </a:solidFill>
-              </a:rPr>
-              <a:t>6. Web/Document ranking and search</a:t>
-            </a:r>
-          </a:p>
-        </p:txBody>
-      </p:sp>
-      <p:sp>
-        <p:nvSpPr>
-          <p:cNvPr id="22" name="Content Placeholder 2">
-            <a:extLst>
-              <a:ext uri="{FF2B5EF4-FFF2-40B4-BE49-F238E27FC236}">
-                <a16:creationId xmlns:a16="http://schemas.microsoft.com/office/drawing/2014/main" id="{302608D4-DE73-B603-CD44-1D4BB221F2DE}"/>
+                <a16:creationId xmlns:a16="http://schemas.microsoft.com/office/drawing/2014/main" id="{CD29F70F-B868-451B-A65D-8721F4C7A2D9}"/>
               </a:ext>
             </a:extLst>
           </p:cNvPr>
@@ -19403,189 +19817,42 @@
         </p:nvSpPr>
         <p:spPr>
           <a:xfrm>
-            <a:off x="865089" y="797597"/>
-            <a:ext cx="10515600" cy="850578"/>
+            <a:off x="838200" y="-635"/>
+            <a:ext cx="10515600" cy="1325563"/>
           </a:xfrm>
           <a:prstGeom prst="rect">
             <a:avLst/>
           </a:prstGeom>
         </p:spPr>
         <p:txBody>
-          <a:bodyPr>
-            <a:noAutofit/>
+          <a:bodyPr vert="horz" lIns="91440" tIns="45720" rIns="91440" bIns="45720" rtlCol="0" anchor="ctr">
+            <a:normAutofit/>
           </a:bodyPr>
           <a:lstStyle>
-            <a:lvl1pPr marL="228600" indent="-228600" algn="l" defTabSz="914400" rtl="0" eaLnBrk="1" latinLnBrk="0" hangingPunct="1">
+            <a:lvl1pPr algn="l" defTabSz="914400" rtl="0" eaLnBrk="1" latinLnBrk="0" hangingPunct="1">
               <a:lnSpc>
                 <a:spcPct val="90000"/>
               </a:lnSpc>
               <a:spcBef>
-                <a:spcPts val="1000"/>
+                <a:spcPct val="0"/>
               </a:spcBef>
-              <a:buFont typeface="Arial" panose="020B0604020202020204" pitchFamily="34" charset="0"/>
-              <a:buChar char="•"/>
-              <a:defRPr sz="2800" kern="1200">
+              <a:buNone/>
+              <a:defRPr sz="4400" kern="1200">
                 <a:solidFill>
                   <a:schemeClr val="tx1"/>
                 </a:solidFill>
-                <a:latin typeface="+mn-lt"/>
-                <a:ea typeface="+mn-ea"/>
-                <a:cs typeface="+mn-cs"/>
+                <a:latin typeface="+mj-lt"/>
+                <a:ea typeface="+mj-ea"/>
+                <a:cs typeface="+mj-cs"/>
               </a:defRPr>
             </a:lvl1pPr>
-            <a:lvl2pPr marL="685800" indent="-228600" algn="l" defTabSz="914400" rtl="0" eaLnBrk="1" latinLnBrk="0" hangingPunct="1">
-              <a:lnSpc>
-                <a:spcPct val="90000"/>
-              </a:lnSpc>
-              <a:spcBef>
-                <a:spcPts val="500"/>
-              </a:spcBef>
-              <a:buFont typeface="Arial" panose="020B0604020202020204" pitchFamily="34" charset="0"/>
-              <a:buChar char="•"/>
-              <a:defRPr sz="2400" kern="1200">
-                <a:solidFill>
-                  <a:schemeClr val="tx1"/>
-                </a:solidFill>
+          </a:lstStyle>
+          <a:p>
+            <a:r>
+              <a:rPr lang="en-US" dirty="0">
                 <a:latin typeface="+mn-lt"/>
-                <a:ea typeface="+mn-ea"/>
-                <a:cs typeface="+mn-cs"/>
-              </a:defRPr>
-            </a:lvl2pPr>
-            <a:lvl3pPr marL="1143000" indent="-228600" algn="l" defTabSz="914400" rtl="0" eaLnBrk="1" latinLnBrk="0" hangingPunct="1">
-              <a:lnSpc>
-                <a:spcPct val="90000"/>
-              </a:lnSpc>
-              <a:spcBef>
-                <a:spcPts val="500"/>
-              </a:spcBef>
-              <a:buFont typeface="Arial" panose="020B0604020202020204" pitchFamily="34" charset="0"/>
-              <a:buChar char="•"/>
-              <a:defRPr sz="2000" kern="1200">
-                <a:solidFill>
-                  <a:schemeClr val="tx1"/>
-                </a:solidFill>
-                <a:latin typeface="+mn-lt"/>
-                <a:ea typeface="+mn-ea"/>
-                <a:cs typeface="+mn-cs"/>
-              </a:defRPr>
-            </a:lvl3pPr>
-            <a:lvl4pPr marL="1600200" indent="-228600" algn="l" defTabSz="914400" rtl="0" eaLnBrk="1" latinLnBrk="0" hangingPunct="1">
-              <a:lnSpc>
-                <a:spcPct val="90000"/>
-              </a:lnSpc>
-              <a:spcBef>
-                <a:spcPts val="500"/>
-              </a:spcBef>
-              <a:buFont typeface="Arial" panose="020B0604020202020204" pitchFamily="34" charset="0"/>
-              <a:buChar char="•"/>
-              <a:defRPr sz="1800" kern="1200">
-                <a:solidFill>
-                  <a:schemeClr val="tx1"/>
-                </a:solidFill>
-                <a:latin typeface="+mn-lt"/>
-                <a:ea typeface="+mn-ea"/>
-                <a:cs typeface="+mn-cs"/>
-              </a:defRPr>
-            </a:lvl4pPr>
-            <a:lvl5pPr marL="2057400" indent="-228600" algn="l" defTabSz="914400" rtl="0" eaLnBrk="1" latinLnBrk="0" hangingPunct="1">
-              <a:lnSpc>
-                <a:spcPct val="90000"/>
-              </a:lnSpc>
-              <a:spcBef>
-                <a:spcPts val="500"/>
-              </a:spcBef>
-              <a:buFont typeface="Arial" panose="020B0604020202020204" pitchFamily="34" charset="0"/>
-              <a:buChar char="•"/>
-              <a:defRPr sz="1800" kern="1200">
-                <a:solidFill>
-                  <a:schemeClr val="tx1"/>
-                </a:solidFill>
-                <a:latin typeface="+mn-lt"/>
-                <a:ea typeface="+mn-ea"/>
-                <a:cs typeface="+mn-cs"/>
-              </a:defRPr>
-            </a:lvl5pPr>
-            <a:lvl6pPr marL="2514600" indent="-228600" algn="l" defTabSz="914400" rtl="0" eaLnBrk="1" latinLnBrk="0" hangingPunct="1">
-              <a:lnSpc>
-                <a:spcPct val="90000"/>
-              </a:lnSpc>
-              <a:spcBef>
-                <a:spcPts val="500"/>
-              </a:spcBef>
-              <a:buFont typeface="Arial" panose="020B0604020202020204" pitchFamily="34" charset="0"/>
-              <a:buChar char="•"/>
-              <a:defRPr sz="1800" kern="1200">
-                <a:solidFill>
-                  <a:schemeClr val="tx1"/>
-                </a:solidFill>
-                <a:latin typeface="+mn-lt"/>
-                <a:ea typeface="+mn-ea"/>
-                <a:cs typeface="+mn-cs"/>
-              </a:defRPr>
-            </a:lvl6pPr>
-            <a:lvl7pPr marL="2971800" indent="-228600" algn="l" defTabSz="914400" rtl="0" eaLnBrk="1" latinLnBrk="0" hangingPunct="1">
-              <a:lnSpc>
-                <a:spcPct val="90000"/>
-              </a:lnSpc>
-              <a:spcBef>
-                <a:spcPts val="500"/>
-              </a:spcBef>
-              <a:buFont typeface="Arial" panose="020B0604020202020204" pitchFamily="34" charset="0"/>
-              <a:buChar char="•"/>
-              <a:defRPr sz="1800" kern="1200">
-                <a:solidFill>
-                  <a:schemeClr val="tx1"/>
-                </a:solidFill>
-                <a:latin typeface="+mn-lt"/>
-                <a:ea typeface="+mn-ea"/>
-                <a:cs typeface="+mn-cs"/>
-              </a:defRPr>
-            </a:lvl7pPr>
-            <a:lvl8pPr marL="3429000" indent="-228600" algn="l" defTabSz="914400" rtl="0" eaLnBrk="1" latinLnBrk="0" hangingPunct="1">
-              <a:lnSpc>
-                <a:spcPct val="90000"/>
-              </a:lnSpc>
-              <a:spcBef>
-                <a:spcPts val="500"/>
-              </a:spcBef>
-              <a:buFont typeface="Arial" panose="020B0604020202020204" pitchFamily="34" charset="0"/>
-              <a:buChar char="•"/>
-              <a:defRPr sz="1800" kern="1200">
-                <a:solidFill>
-                  <a:schemeClr val="tx1"/>
-                </a:solidFill>
-                <a:latin typeface="+mn-lt"/>
-                <a:ea typeface="+mn-ea"/>
-                <a:cs typeface="+mn-cs"/>
-              </a:defRPr>
-            </a:lvl8pPr>
-            <a:lvl9pPr marL="3886200" indent="-228600" algn="l" defTabSz="914400" rtl="0" eaLnBrk="1" latinLnBrk="0" hangingPunct="1">
-              <a:lnSpc>
-                <a:spcPct val="90000"/>
-              </a:lnSpc>
-              <a:spcBef>
-                <a:spcPts val="500"/>
-              </a:spcBef>
-              <a:buFont typeface="Arial" panose="020B0604020202020204" pitchFamily="34" charset="0"/>
-              <a:buChar char="•"/>
-              <a:defRPr sz="1800" kern="1200">
-                <a:solidFill>
-                  <a:schemeClr val="tx1"/>
-                </a:solidFill>
-                <a:latin typeface="+mn-lt"/>
-                <a:ea typeface="+mn-ea"/>
-                <a:cs typeface="+mn-cs"/>
-              </a:defRPr>
-            </a:lvl9pPr>
-          </a:lstStyle>
-          <a:p>
-            <a:pPr marL="0" indent="0">
-              <a:buFont typeface="Arial" panose="020B0604020202020204" pitchFamily="34" charset="0"/>
-              <a:buNone/>
-            </a:pPr>
-            <a:r>
-              <a:rPr lang="en-US" dirty="0"/>
-              <a:t>The main topics in this course are interconnected and build on each other</a:t>
+              </a:rPr>
+              <a:t>Introduction to key-value indexing</a:t>
             </a:r>
           </a:p>
         </p:txBody>
@@ -19593,22 +19860,329 @@
     </p:spTree>
     <p:extLst>
       <p:ext uri="{BB962C8B-B14F-4D97-AF65-F5344CB8AC3E}">
-        <p14:creationId xmlns:p14="http://schemas.microsoft.com/office/powerpoint/2010/main" val="581234857"/>
+        <p14:creationId xmlns:p14="http://schemas.microsoft.com/office/powerpoint/2010/main" val="2786196533"/>
       </p:ext>
     </p:extLst>
   </p:cSld>
   <p:clrMapOvr>
     <a:masterClrMapping/>
   </p:clrMapOvr>
+  <p:timing>
+    <p:tnLst>
+      <p:par>
+        <p:cTn id="1" dur="indefinite" restart="never" nodeType="tmRoot">
+          <p:childTnLst>
+            <p:seq concurrent="1" nextAc="seek">
+              <p:cTn id="2" dur="indefinite" nodeType="mainSeq">
+                <p:childTnLst>
+                  <p:par>
+                    <p:cTn id="3" fill="hold">
+                      <p:stCondLst>
+                        <p:cond delay="indefinite"/>
+                      </p:stCondLst>
+                      <p:childTnLst>
+                        <p:par>
+                          <p:cTn id="4" fill="hold">
+                            <p:stCondLst>
+                              <p:cond delay="0"/>
+                            </p:stCondLst>
+                            <p:childTnLst>
+                              <p:par>
+                                <p:cTn id="5" presetID="1" presetClass="entr" presetSubtype="0" fill="hold" nodeType="clickEffect">
+                                  <p:stCondLst>
+                                    <p:cond delay="0"/>
+                                  </p:stCondLst>
+                                  <p:childTnLst>
+                                    <p:set>
+                                      <p:cBhvr>
+                                        <p:cTn id="6" dur="1" fill="hold">
+                                          <p:stCondLst>
+                                            <p:cond delay="0"/>
+                                          </p:stCondLst>
+                                        </p:cTn>
+                                        <p:tgtEl>
+                                          <p:spTgt spid="3">
+                                            <p:txEl>
+                                              <p:pRg st="1" end="1"/>
+                                            </p:txEl>
+                                          </p:spTgt>
+                                        </p:tgtEl>
+                                        <p:attrNameLst>
+                                          <p:attrName>style.visibility</p:attrName>
+                                        </p:attrNameLst>
+                                      </p:cBhvr>
+                                      <p:to>
+                                        <p:strVal val="visible"/>
+                                      </p:to>
+                                    </p:set>
+                                  </p:childTnLst>
+                                </p:cTn>
+                              </p:par>
+                            </p:childTnLst>
+                          </p:cTn>
+                        </p:par>
+                      </p:childTnLst>
+                    </p:cTn>
+                  </p:par>
+                  <p:par>
+                    <p:cTn id="7" fill="hold">
+                      <p:stCondLst>
+                        <p:cond delay="indefinite"/>
+                      </p:stCondLst>
+                      <p:childTnLst>
+                        <p:par>
+                          <p:cTn id="8" fill="hold">
+                            <p:stCondLst>
+                              <p:cond delay="0"/>
+                            </p:stCondLst>
+                            <p:childTnLst>
+                              <p:par>
+                                <p:cTn id="9" presetID="1" presetClass="entr" presetSubtype="0" fill="hold" nodeType="clickEffect">
+                                  <p:stCondLst>
+                                    <p:cond delay="0"/>
+                                  </p:stCondLst>
+                                  <p:childTnLst>
+                                    <p:set>
+                                      <p:cBhvr>
+                                        <p:cTn id="10" dur="1" fill="hold">
+                                          <p:stCondLst>
+                                            <p:cond delay="0"/>
+                                          </p:stCondLst>
+                                        </p:cTn>
+                                        <p:tgtEl>
+                                          <p:spTgt spid="3">
+                                            <p:txEl>
+                                              <p:pRg st="2" end="2"/>
+                                            </p:txEl>
+                                          </p:spTgt>
+                                        </p:tgtEl>
+                                        <p:attrNameLst>
+                                          <p:attrName>style.visibility</p:attrName>
+                                        </p:attrNameLst>
+                                      </p:cBhvr>
+                                      <p:to>
+                                        <p:strVal val="visible"/>
+                                      </p:to>
+                                    </p:set>
+                                  </p:childTnLst>
+                                </p:cTn>
+                              </p:par>
+                            </p:childTnLst>
+                          </p:cTn>
+                        </p:par>
+                      </p:childTnLst>
+                    </p:cTn>
+                  </p:par>
+                  <p:par>
+                    <p:cTn id="11" fill="hold">
+                      <p:stCondLst>
+                        <p:cond delay="indefinite"/>
+                      </p:stCondLst>
+                      <p:childTnLst>
+                        <p:par>
+                          <p:cTn id="12" fill="hold">
+                            <p:stCondLst>
+                              <p:cond delay="0"/>
+                            </p:stCondLst>
+                            <p:childTnLst>
+                              <p:par>
+                                <p:cTn id="13" presetID="1" presetClass="entr" presetSubtype="0" fill="hold" nodeType="clickEffect">
+                                  <p:stCondLst>
+                                    <p:cond delay="0"/>
+                                  </p:stCondLst>
+                                  <p:childTnLst>
+                                    <p:set>
+                                      <p:cBhvr>
+                                        <p:cTn id="14" dur="1" fill="hold">
+                                          <p:stCondLst>
+                                            <p:cond delay="0"/>
+                                          </p:stCondLst>
+                                        </p:cTn>
+                                        <p:tgtEl>
+                                          <p:spTgt spid="3">
+                                            <p:txEl>
+                                              <p:pRg st="3" end="3"/>
+                                            </p:txEl>
+                                          </p:spTgt>
+                                        </p:tgtEl>
+                                        <p:attrNameLst>
+                                          <p:attrName>style.visibility</p:attrName>
+                                        </p:attrNameLst>
+                                      </p:cBhvr>
+                                      <p:to>
+                                        <p:strVal val="visible"/>
+                                      </p:to>
+                                    </p:set>
+                                  </p:childTnLst>
+                                </p:cTn>
+                              </p:par>
+                              <p:par>
+                                <p:cTn id="15" presetID="1" presetClass="entr" presetSubtype="0" fill="hold" nodeType="withEffect">
+                                  <p:stCondLst>
+                                    <p:cond delay="0"/>
+                                  </p:stCondLst>
+                                  <p:childTnLst>
+                                    <p:set>
+                                      <p:cBhvr>
+                                        <p:cTn id="16" dur="1" fill="hold">
+                                          <p:stCondLst>
+                                            <p:cond delay="0"/>
+                                          </p:stCondLst>
+                                        </p:cTn>
+                                        <p:tgtEl>
+                                          <p:spTgt spid="3">
+                                            <p:txEl>
+                                              <p:pRg st="4" end="4"/>
+                                            </p:txEl>
+                                          </p:spTgt>
+                                        </p:tgtEl>
+                                        <p:attrNameLst>
+                                          <p:attrName>style.visibility</p:attrName>
+                                        </p:attrNameLst>
+                                      </p:cBhvr>
+                                      <p:to>
+                                        <p:strVal val="visible"/>
+                                      </p:to>
+                                    </p:set>
+                                  </p:childTnLst>
+                                </p:cTn>
+                              </p:par>
+                              <p:par>
+                                <p:cTn id="17" presetID="1" presetClass="entr" presetSubtype="0" fill="hold" nodeType="withEffect">
+                                  <p:stCondLst>
+                                    <p:cond delay="0"/>
+                                  </p:stCondLst>
+                                  <p:childTnLst>
+                                    <p:set>
+                                      <p:cBhvr>
+                                        <p:cTn id="18" dur="1" fill="hold">
+                                          <p:stCondLst>
+                                            <p:cond delay="0"/>
+                                          </p:stCondLst>
+                                        </p:cTn>
+                                        <p:tgtEl>
+                                          <p:spTgt spid="3">
+                                            <p:txEl>
+                                              <p:pRg st="5" end="5"/>
+                                            </p:txEl>
+                                          </p:spTgt>
+                                        </p:tgtEl>
+                                        <p:attrNameLst>
+                                          <p:attrName>style.visibility</p:attrName>
+                                        </p:attrNameLst>
+                                      </p:cBhvr>
+                                      <p:to>
+                                        <p:strVal val="visible"/>
+                                      </p:to>
+                                    </p:set>
+                                  </p:childTnLst>
+                                </p:cTn>
+                              </p:par>
+                              <p:par>
+                                <p:cTn id="19" presetID="1" presetClass="entr" presetSubtype="0" fill="hold" nodeType="withEffect">
+                                  <p:stCondLst>
+                                    <p:cond delay="0"/>
+                                  </p:stCondLst>
+                                  <p:childTnLst>
+                                    <p:set>
+                                      <p:cBhvr>
+                                        <p:cTn id="20" dur="1" fill="hold">
+                                          <p:stCondLst>
+                                            <p:cond delay="0"/>
+                                          </p:stCondLst>
+                                        </p:cTn>
+                                        <p:tgtEl>
+                                          <p:spTgt spid="3">
+                                            <p:txEl>
+                                              <p:pRg st="6" end="6"/>
+                                            </p:txEl>
+                                          </p:spTgt>
+                                        </p:tgtEl>
+                                        <p:attrNameLst>
+                                          <p:attrName>style.visibility</p:attrName>
+                                        </p:attrNameLst>
+                                      </p:cBhvr>
+                                      <p:to>
+                                        <p:strVal val="visible"/>
+                                      </p:to>
+                                    </p:set>
+                                  </p:childTnLst>
+                                </p:cTn>
+                              </p:par>
+                              <p:par>
+                                <p:cTn id="21" presetID="1" presetClass="entr" presetSubtype="0" fill="hold" nodeType="withEffect">
+                                  <p:stCondLst>
+                                    <p:cond delay="0"/>
+                                  </p:stCondLst>
+                                  <p:childTnLst>
+                                    <p:set>
+                                      <p:cBhvr>
+                                        <p:cTn id="22" dur="1" fill="hold">
+                                          <p:stCondLst>
+                                            <p:cond delay="0"/>
+                                          </p:stCondLst>
+                                        </p:cTn>
+                                        <p:tgtEl>
+                                          <p:spTgt spid="3">
+                                            <p:txEl>
+                                              <p:pRg st="7" end="7"/>
+                                            </p:txEl>
+                                          </p:spTgt>
+                                        </p:tgtEl>
+                                        <p:attrNameLst>
+                                          <p:attrName>style.visibility</p:attrName>
+                                        </p:attrNameLst>
+                                      </p:cBhvr>
+                                      <p:to>
+                                        <p:strVal val="visible"/>
+                                      </p:to>
+                                    </p:set>
+                                  </p:childTnLst>
+                                </p:cTn>
+                              </p:par>
+                            </p:childTnLst>
+                          </p:cTn>
+                        </p:par>
+                      </p:childTnLst>
+                    </p:cTn>
+                  </p:par>
+                </p:childTnLst>
+              </p:cTn>
+              <p:prevCondLst>
+                <p:cond evt="onPrev" delay="0">
+                  <p:tgtEl>
+                    <p:sldTgt/>
+                  </p:tgtEl>
+                </p:cond>
+              </p:prevCondLst>
+              <p:nextCondLst>
+                <p:cond evt="onNext" delay="0">
+                  <p:tgtEl>
+                    <p:sldTgt/>
+                  </p:tgtEl>
+                </p:cond>
+              </p:nextCondLst>
+            </p:seq>
+          </p:childTnLst>
+        </p:cTn>
+      </p:par>
+    </p:tnLst>
+  </p:timing>
 </p:sld>
 </file>
 
-<file path=ppt/slides/slide33.xml><?xml version="1.0" encoding="utf-8"?>
+<file path=ppt/slides/slide34.xml><?xml version="1.0" encoding="utf-8"?>
 <p:sld xmlns:a="http://schemas.openxmlformats.org/drawingml/2006/main" xmlns:r="http://schemas.openxmlformats.org/officeDocument/2006/relationships" xmlns:p="http://schemas.openxmlformats.org/presentationml/2006/main">
   <p:cSld>
     <p:spTree>
       <p:nvGrpSpPr>
-        <p:cNvPr id="1" name=""/>
+        <p:cNvPr id="1" name="">
+          <a:extLst>
+            <a:ext uri="{FF2B5EF4-FFF2-40B4-BE49-F238E27FC236}">
+              <a16:creationId xmlns:a16="http://schemas.microsoft.com/office/drawing/2014/main" id="{F06338BD-3218-FB67-58C9-525CC2AA542F}"/>
+            </a:ext>
+          </a:extLst>
+        </p:cNvPr>
         <p:cNvGrpSpPr/>
         <p:nvPr/>
       </p:nvGrpSpPr>
@@ -19627,7 +20201,7 @@
               <p:cNvPr id="3" name="Content Placeholder 2">
                 <a:extLst>
                   <a:ext uri="{FF2B5EF4-FFF2-40B4-BE49-F238E27FC236}">
-                    <a16:creationId xmlns:a16="http://schemas.microsoft.com/office/drawing/2014/main" id="{258E6AF3-7615-4BD1-878E-A94C93E98F90}"/>
+                    <a16:creationId xmlns:a16="http://schemas.microsoft.com/office/drawing/2014/main" id="{0E9DA594-FA8E-AFF0-BC71-4343BB479A15}"/>
                   </a:ext>
                 </a:extLst>
               </p:cNvPr>
@@ -19803,7 +20377,7 @@
               <p:cNvPr id="3" name="Content Placeholder 2">
                 <a:extLst>
                   <a:ext uri="{FF2B5EF4-FFF2-40B4-BE49-F238E27FC236}">
-                    <a16:creationId xmlns:a16="http://schemas.microsoft.com/office/drawing/2014/main" id="{258E6AF3-7615-4BD1-878E-A94C93E98F90}"/>
+                    <a16:creationId xmlns:a16="http://schemas.microsoft.com/office/drawing/2014/main" id="{0E9DA594-FA8E-AFF0-BC71-4343BB479A15}"/>
                   </a:ext>
                 </a:extLst>
               </p:cNvPr>
@@ -19846,7 +20420,7 @@
           <p:cNvPr id="6" name="Title 1">
             <a:extLst>
               <a:ext uri="{FF2B5EF4-FFF2-40B4-BE49-F238E27FC236}">
-                <a16:creationId xmlns:a16="http://schemas.microsoft.com/office/drawing/2014/main" id="{CD29F70F-B868-451B-A65D-8721F4C7A2D9}"/>
+                <a16:creationId xmlns:a16="http://schemas.microsoft.com/office/drawing/2014/main" id="{5B3478C9-9FBE-BB6A-F1F0-2413227DA6E1}"/>
               </a:ext>
             </a:extLst>
           </p:cNvPr>
@@ -19900,7 +20474,7 @@
     </p:spTree>
     <p:extLst>
       <p:ext uri="{BB962C8B-B14F-4D97-AF65-F5344CB8AC3E}">
-        <p14:creationId xmlns:p14="http://schemas.microsoft.com/office/powerpoint/2010/main" val="2786196533"/>
+        <p14:creationId xmlns:p14="http://schemas.microsoft.com/office/powerpoint/2010/main" val="2096130958"/>
       </p:ext>
     </p:extLst>
   </p:cSld>
@@ -20304,7 +20878,7 @@
 </p:sld>
 </file>
 
-<file path=ppt/slides/slide34.xml><?xml version="1.0" encoding="utf-8"?>
+<file path=ppt/slides/slide35.xml><?xml version="1.0" encoding="utf-8"?>
 <p:sld xmlns:a="http://schemas.openxmlformats.org/drawingml/2006/main" xmlns:r="http://schemas.openxmlformats.org/officeDocument/2006/relationships" xmlns:p="http://schemas.openxmlformats.org/presentationml/2006/main">
   <p:cSld>
     <p:spTree>
@@ -20919,7 +21493,7 @@
 </p:sld>
 </file>
 
-<file path=ppt/slides/slide35.xml><?xml version="1.0" encoding="utf-8"?>
+<file path=ppt/slides/slide36.xml><?xml version="1.0" encoding="utf-8"?>
 <p:sld xmlns:a="http://schemas.openxmlformats.org/drawingml/2006/main" xmlns:r="http://schemas.openxmlformats.org/officeDocument/2006/relationships" xmlns:p="http://schemas.openxmlformats.org/presentationml/2006/main">
   <p:cSld>
     <p:spTree>
@@ -21406,7 +21980,7 @@
 </p:sld>
 </file>
 
-<file path=ppt/slides/slide36.xml><?xml version="1.0" encoding="utf-8"?>
+<file path=ppt/slides/slide37.xml><?xml version="1.0" encoding="utf-8"?>
 <p:sld xmlns:a="http://schemas.openxmlformats.org/drawingml/2006/main" xmlns:r="http://schemas.openxmlformats.org/officeDocument/2006/relationships" xmlns:p="http://schemas.openxmlformats.org/presentationml/2006/main">
   <p:cSld>
     <p:spTree>
@@ -21931,7 +22505,7 @@
 </p:sld>
 </file>
 
-<file path=ppt/slides/slide37.xml><?xml version="1.0" encoding="utf-8"?>
+<file path=ppt/slides/slide38.xml><?xml version="1.0" encoding="utf-8"?>
 <p:sld xmlns:a="http://schemas.openxmlformats.org/drawingml/2006/main" xmlns:r="http://schemas.openxmlformats.org/officeDocument/2006/relationships" xmlns:p="http://schemas.openxmlformats.org/presentationml/2006/main">
   <p:cSld>
     <p:spTree>
@@ -22515,7 +23089,7 @@
 </p:sld>
 </file>
 
-<file path=ppt/slides/slide38.xml><?xml version="1.0" encoding="utf-8"?>
+<file path=ppt/slides/slide39.xml><?xml version="1.0" encoding="utf-8"?>
 <p:sld xmlns:a="http://schemas.openxmlformats.org/drawingml/2006/main" xmlns:r="http://schemas.openxmlformats.org/officeDocument/2006/relationships" xmlns:p="http://schemas.openxmlformats.org/presentationml/2006/main">
   <p:cSld>
     <p:spTree>
@@ -24926,66 +25500,6 @@
 </p:sld>
 </file>
 
-<file path=ppt/slides/slide39.xml><?xml version="1.0" encoding="utf-8"?>
-<p:sld xmlns:a="http://schemas.openxmlformats.org/drawingml/2006/main" xmlns:r="http://schemas.openxmlformats.org/officeDocument/2006/relationships" xmlns:p="http://schemas.openxmlformats.org/presentationml/2006/main">
-  <p:cSld>
-    <p:spTree>
-      <p:nvGrpSpPr>
-        <p:cNvPr id="1" name=""/>
-        <p:cNvGrpSpPr/>
-        <p:nvPr/>
-      </p:nvGrpSpPr>
-      <p:grpSpPr>
-        <a:xfrm>
-          <a:off x="0" y="0"/>
-          <a:ext cx="0" cy="0"/>
-          <a:chOff x="0" y="0"/>
-          <a:chExt cx="0" cy="0"/>
-        </a:xfrm>
-      </p:grpSpPr>
-      <p:sp>
-        <p:nvSpPr>
-          <p:cNvPr id="2" name="Title 1">
-            <a:extLst>
-              <a:ext uri="{FF2B5EF4-FFF2-40B4-BE49-F238E27FC236}">
-                <a16:creationId xmlns:a16="http://schemas.microsoft.com/office/drawing/2014/main" id="{F8A33362-6456-0F5B-5570-FA2A30C5C24B}"/>
-              </a:ext>
-            </a:extLst>
-          </p:cNvPr>
-          <p:cNvSpPr>
-            <a:spLocks noGrp="1"/>
-          </p:cNvSpPr>
-          <p:nvPr>
-            <p:ph type="ctrTitle"/>
-          </p:nvPr>
-        </p:nvSpPr>
-        <p:spPr/>
-        <p:txBody>
-          <a:bodyPr>
-            <a:normAutofit/>
-          </a:bodyPr>
-          <a:lstStyle/>
-          <a:p>
-            <a:r>
-              <a:rPr lang="en-US" sz="4400" dirty="0"/>
-              <a:t>Introduction to Hashing</a:t>
-            </a:r>
-          </a:p>
-        </p:txBody>
-      </p:sp>
-    </p:spTree>
-    <p:extLst>
-      <p:ext uri="{BB962C8B-B14F-4D97-AF65-F5344CB8AC3E}">
-        <p14:creationId xmlns:p14="http://schemas.microsoft.com/office/powerpoint/2010/main" val="3957708175"/>
-      </p:ext>
-    </p:extLst>
-  </p:cSld>
-  <p:clrMapOvr>
-    <a:masterClrMapping/>
-  </p:clrMapOvr>
-</p:sld>
-</file>
-
 <file path=ppt/slides/slide4.xml><?xml version="1.0" encoding="utf-8"?>
 <p:sld xmlns:a="http://schemas.openxmlformats.org/drawingml/2006/main" xmlns:r="http://schemas.openxmlformats.org/officeDocument/2006/relationships" xmlns:p="http://schemas.openxmlformats.org/presentationml/2006/main">
   <p:cSld>
@@ -25492,6 +26006,66 @@
           <a:chExt cx="0" cy="0"/>
         </a:xfrm>
       </p:grpSpPr>
+      <p:sp>
+        <p:nvSpPr>
+          <p:cNvPr id="2" name="Title 1">
+            <a:extLst>
+              <a:ext uri="{FF2B5EF4-FFF2-40B4-BE49-F238E27FC236}">
+                <a16:creationId xmlns:a16="http://schemas.microsoft.com/office/drawing/2014/main" id="{F8A33362-6456-0F5B-5570-FA2A30C5C24B}"/>
+              </a:ext>
+            </a:extLst>
+          </p:cNvPr>
+          <p:cNvSpPr>
+            <a:spLocks noGrp="1"/>
+          </p:cNvSpPr>
+          <p:nvPr>
+            <p:ph type="ctrTitle"/>
+          </p:nvPr>
+        </p:nvSpPr>
+        <p:spPr/>
+        <p:txBody>
+          <a:bodyPr>
+            <a:normAutofit/>
+          </a:bodyPr>
+          <a:lstStyle/>
+          <a:p>
+            <a:r>
+              <a:rPr lang="en-US" sz="4400" dirty="0"/>
+              <a:t>Introduction to Hashing</a:t>
+            </a:r>
+          </a:p>
+        </p:txBody>
+      </p:sp>
+    </p:spTree>
+    <p:extLst>
+      <p:ext uri="{BB962C8B-B14F-4D97-AF65-F5344CB8AC3E}">
+        <p14:creationId xmlns:p14="http://schemas.microsoft.com/office/powerpoint/2010/main" val="3957708175"/>
+      </p:ext>
+    </p:extLst>
+  </p:cSld>
+  <p:clrMapOvr>
+    <a:masterClrMapping/>
+  </p:clrMapOvr>
+</p:sld>
+</file>
+
+<file path=ppt/slides/slide41.xml><?xml version="1.0" encoding="utf-8"?>
+<p:sld xmlns:a="http://schemas.openxmlformats.org/drawingml/2006/main" xmlns:r="http://schemas.openxmlformats.org/officeDocument/2006/relationships" xmlns:p="http://schemas.openxmlformats.org/presentationml/2006/main">
+  <p:cSld>
+    <p:spTree>
+      <p:nvGrpSpPr>
+        <p:cNvPr id="1" name=""/>
+        <p:cNvGrpSpPr/>
+        <p:nvPr/>
+      </p:nvGrpSpPr>
+      <p:grpSpPr>
+        <a:xfrm>
+          <a:off x="0" y="0"/>
+          <a:ext cx="0" cy="0"/>
+          <a:chOff x="0" y="0"/>
+          <a:chExt cx="0" cy="0"/>
+        </a:xfrm>
+      </p:grpSpPr>
       <mc:AlternateContent xmlns:mc="http://schemas.openxmlformats.org/markup-compatibility/2006" xmlns:a14="http://schemas.microsoft.com/office/drawing/2010/main">
         <mc:Choice Requires="a14">
           <p:sp>
@@ -26112,7 +26686,7 @@
 </p:sld>
 </file>
 
-<file path=ppt/slides/slide41.xml><?xml version="1.0" encoding="utf-8"?>
+<file path=ppt/slides/slide42.xml><?xml version="1.0" encoding="utf-8"?>
 <p:sld xmlns:a="http://schemas.openxmlformats.org/drawingml/2006/main" xmlns:r="http://schemas.openxmlformats.org/officeDocument/2006/relationships" xmlns:p="http://schemas.openxmlformats.org/presentationml/2006/main">
   <p:cSld>
     <p:spTree>
@@ -26585,7 +27159,7 @@
 </p:sld>
 </file>
 
-<file path=ppt/slides/slide42.xml><?xml version="1.0" encoding="utf-8"?>
+<file path=ppt/slides/slide43.xml><?xml version="1.0" encoding="utf-8"?>
 <p:sld xmlns:a="http://schemas.openxmlformats.org/drawingml/2006/main" xmlns:r="http://schemas.openxmlformats.org/officeDocument/2006/relationships" xmlns:p="http://schemas.openxmlformats.org/presentationml/2006/main">
   <p:cSld>
     <p:spTree>
@@ -29513,7 +30087,7 @@
 </p:sld>
 </file>
 
-<file path=ppt/slides/slide43.xml><?xml version="1.0" encoding="utf-8"?>
+<file path=ppt/slides/slide44.xml><?xml version="1.0" encoding="utf-8"?>
 <p:sld xmlns:a="http://schemas.openxmlformats.org/drawingml/2006/main" xmlns:r="http://schemas.openxmlformats.org/officeDocument/2006/relationships" xmlns:p="http://schemas.openxmlformats.org/presentationml/2006/main">
   <p:cSld>
     <p:spTree>
@@ -32388,7 +32962,7 @@
 </p:sld>
 </file>
 
-<file path=ppt/slides/slide44.xml><?xml version="1.0" encoding="utf-8"?>
+<file path=ppt/slides/slide45.xml><?xml version="1.0" encoding="utf-8"?>
 <p:sld xmlns:a="http://schemas.openxmlformats.org/drawingml/2006/main" xmlns:r="http://schemas.openxmlformats.org/officeDocument/2006/relationships" xmlns:p="http://schemas.openxmlformats.org/presentationml/2006/main">
   <p:cSld>
     <p:spTree>
@@ -32454,7 +33028,7 @@
 </p:sld>
 </file>
 
-<file path=ppt/slides/slide45.xml><?xml version="1.0" encoding="utf-8"?>
+<file path=ppt/slides/slide46.xml><?xml version="1.0" encoding="utf-8"?>
 <p:sld xmlns:a="http://schemas.openxmlformats.org/drawingml/2006/main" xmlns:r="http://schemas.openxmlformats.org/officeDocument/2006/relationships" xmlns:p="http://schemas.openxmlformats.org/presentationml/2006/main">
   <p:cSld>
     <p:spTree>
@@ -32858,7 +33432,7 @@
 </p:sld>
 </file>
 
-<file path=ppt/slides/slide46.xml><?xml version="1.0" encoding="utf-8"?>
+<file path=ppt/slides/slide47.xml><?xml version="1.0" encoding="utf-8"?>
 <p:sld xmlns:a="http://schemas.openxmlformats.org/drawingml/2006/main" xmlns:r="http://schemas.openxmlformats.org/officeDocument/2006/relationships" xmlns:p="http://schemas.openxmlformats.org/presentationml/2006/main">
   <p:cSld>
     <p:spTree>
@@ -33380,7 +33954,7 @@
 </p:sld>
 </file>
 
-<file path=ppt/slides/slide47.xml><?xml version="1.0" encoding="utf-8"?>
+<file path=ppt/slides/slide48.xml><?xml version="1.0" encoding="utf-8"?>
 <p:sld xmlns:a="http://schemas.openxmlformats.org/drawingml/2006/main" xmlns:r="http://schemas.openxmlformats.org/officeDocument/2006/relationships" xmlns:p="http://schemas.openxmlformats.org/presentationml/2006/main">
   <p:cSld>
     <p:spTree>
@@ -34519,7 +35093,7 @@
 </p:sld>
 </file>
 
-<file path=ppt/slides/slide48.xml><?xml version="1.0" encoding="utf-8"?>
+<file path=ppt/slides/slide49.xml><?xml version="1.0" encoding="utf-8"?>
 <p:sld xmlns:a="http://schemas.openxmlformats.org/drawingml/2006/main" xmlns:r="http://schemas.openxmlformats.org/officeDocument/2006/relationships" xmlns:p="http://schemas.openxmlformats.org/presentationml/2006/main">
   <p:cSld>
     <p:spTree>
@@ -34592,7 +35166,401 @@
 </p:sld>
 </file>
 
-<file path=ppt/slides/slide49.xml><?xml version="1.0" encoding="utf-8"?>
+<file path=ppt/slides/slide5.xml><?xml version="1.0" encoding="utf-8"?>
+<p:sld xmlns:a="http://schemas.openxmlformats.org/drawingml/2006/main" xmlns:r="http://schemas.openxmlformats.org/officeDocument/2006/relationships" xmlns:p="http://schemas.openxmlformats.org/presentationml/2006/main">
+  <p:cSld>
+    <p:spTree>
+      <p:nvGrpSpPr>
+        <p:cNvPr id="1" name=""/>
+        <p:cNvGrpSpPr/>
+        <p:nvPr/>
+      </p:nvGrpSpPr>
+      <p:grpSpPr>
+        <a:xfrm>
+          <a:off x="0" y="0"/>
+          <a:ext cx="0" cy="0"/>
+          <a:chOff x="0" y="0"/>
+          <a:chExt cx="0" cy="0"/>
+        </a:xfrm>
+      </p:grpSpPr>
+      <p:sp>
+        <p:nvSpPr>
+          <p:cNvPr id="3" name="Content Placeholder 2">
+            <a:extLst>
+              <a:ext uri="{FF2B5EF4-FFF2-40B4-BE49-F238E27FC236}">
+                <a16:creationId xmlns:a16="http://schemas.microsoft.com/office/drawing/2014/main" id="{258E6AF3-7615-4BD1-878E-A94C93E98F90}"/>
+              </a:ext>
+            </a:extLst>
+          </p:cNvPr>
+          <p:cNvSpPr>
+            <a:spLocks noGrp="1"/>
+          </p:cNvSpPr>
+          <p:nvPr>
+            <p:ph idx="1"/>
+          </p:nvPr>
+        </p:nvSpPr>
+        <p:spPr>
+          <a:xfrm>
+            <a:off x="838200" y="1217458"/>
+            <a:ext cx="10515600" cy="5640542"/>
+          </a:xfrm>
+        </p:spPr>
+        <p:txBody>
+          <a:bodyPr>
+            <a:normAutofit fontScale="92500" lnSpcReduction="10000"/>
+          </a:bodyPr>
+          <a:lstStyle/>
+          <a:p>
+            <a:pPr marL="0" indent="0">
+              <a:buNone/>
+            </a:pPr>
+            <a:r>
+              <a:rPr lang="en-US" sz="3200" dirty="0"/>
+              <a:t>What is the KDD process?   </a:t>
+            </a:r>
+          </a:p>
+          <a:p>
+            <a:pPr marL="0" indent="0">
+              <a:buNone/>
+            </a:pPr>
+            <a:endParaRPr lang="en-US" dirty="0"/>
+          </a:p>
+          <a:p>
+            <a:pPr marL="0" indent="0">
+              <a:buNone/>
+            </a:pPr>
+            <a:endParaRPr lang="en-US" dirty="0"/>
+          </a:p>
+          <a:p>
+            <a:pPr marL="0" indent="0">
+              <a:buNone/>
+            </a:pPr>
+            <a:endParaRPr lang="en-US" dirty="0"/>
+          </a:p>
+          <a:p>
+            <a:pPr marL="0" indent="0">
+              <a:buNone/>
+            </a:pPr>
+            <a:endParaRPr lang="en-US" dirty="0"/>
+          </a:p>
+          <a:p>
+            <a:pPr marL="0" indent="0">
+              <a:buNone/>
+            </a:pPr>
+            <a:endParaRPr lang="en-US" dirty="0"/>
+          </a:p>
+          <a:p>
+            <a:pPr marL="0" indent="0">
+              <a:buNone/>
+            </a:pPr>
+            <a:endParaRPr lang="en-US" dirty="0"/>
+          </a:p>
+          <a:p>
+            <a:pPr marL="0" indent="0">
+              <a:buNone/>
+            </a:pPr>
+            <a:endParaRPr lang="en-US" dirty="0"/>
+          </a:p>
+          <a:p>
+            <a:pPr marL="0" indent="0">
+              <a:buNone/>
+            </a:pPr>
+            <a:endParaRPr lang="en-US" dirty="0">
+              <a:solidFill>
+                <a:schemeClr val="accent1"/>
+              </a:solidFill>
+            </a:endParaRPr>
+          </a:p>
+          <a:p>
+            <a:pPr marL="0" indent="0">
+              <a:buNone/>
+            </a:pPr>
+            <a:endParaRPr lang="en-US" dirty="0">
+              <a:solidFill>
+                <a:schemeClr val="accent1"/>
+              </a:solidFill>
+            </a:endParaRPr>
+          </a:p>
+          <a:p>
+            <a:pPr marL="0" indent="0">
+              <a:buNone/>
+            </a:pPr>
+            <a:endParaRPr lang="en-US" dirty="0">
+              <a:solidFill>
+                <a:schemeClr val="accent1"/>
+              </a:solidFill>
+            </a:endParaRPr>
+          </a:p>
+          <a:p>
+            <a:pPr marL="0" indent="0">
+              <a:buNone/>
+            </a:pPr>
+            <a:r>
+              <a:rPr lang="en-US" dirty="0">
+                <a:solidFill>
+                  <a:schemeClr val="accent1"/>
+                </a:solidFill>
+              </a:rPr>
+              <a:t>Is this old diagram representative?  - e.g. Fayyad et.al. 1996 </a:t>
+            </a:r>
+          </a:p>
+        </p:txBody>
+      </p:sp>
+      <p:sp>
+        <p:nvSpPr>
+          <p:cNvPr id="6" name="Title 1">
+            <a:extLst>
+              <a:ext uri="{FF2B5EF4-FFF2-40B4-BE49-F238E27FC236}">
+                <a16:creationId xmlns:a16="http://schemas.microsoft.com/office/drawing/2014/main" id="{CD29F70F-B868-451B-A65D-8721F4C7A2D9}"/>
+              </a:ext>
+            </a:extLst>
+          </p:cNvPr>
+          <p:cNvSpPr txBox="1">
+            <a:spLocks/>
+          </p:cNvSpPr>
+          <p:nvPr/>
+        </p:nvSpPr>
+        <p:spPr>
+          <a:xfrm>
+            <a:off x="838200" y="-635"/>
+            <a:ext cx="10515600" cy="1325563"/>
+          </a:xfrm>
+          <a:prstGeom prst="rect">
+            <a:avLst/>
+          </a:prstGeom>
+        </p:spPr>
+        <p:txBody>
+          <a:bodyPr vert="horz" lIns="91440" tIns="45720" rIns="91440" bIns="45720" rtlCol="0" anchor="ctr">
+            <a:normAutofit/>
+          </a:bodyPr>
+          <a:lstStyle>
+            <a:lvl1pPr algn="l" defTabSz="914400" rtl="0" eaLnBrk="1" latinLnBrk="0" hangingPunct="1">
+              <a:lnSpc>
+                <a:spcPct val="90000"/>
+              </a:lnSpc>
+              <a:spcBef>
+                <a:spcPct val="0"/>
+              </a:spcBef>
+              <a:buNone/>
+              <a:defRPr sz="4400" kern="1200">
+                <a:solidFill>
+                  <a:schemeClr val="tx1"/>
+                </a:solidFill>
+                <a:latin typeface="+mj-lt"/>
+                <a:ea typeface="+mj-ea"/>
+                <a:cs typeface="+mj-cs"/>
+              </a:defRPr>
+            </a:lvl1pPr>
+          </a:lstStyle>
+          <a:p>
+            <a:r>
+              <a:rPr lang="en-US" dirty="0">
+                <a:latin typeface="+mn-lt"/>
+              </a:rPr>
+              <a:t>KDD process</a:t>
+            </a:r>
+          </a:p>
+        </p:txBody>
+      </p:sp>
+      <p:pic>
+        <p:nvPicPr>
+          <p:cNvPr id="4" name="Picture 3">
+            <a:extLst>
+              <a:ext uri="{FF2B5EF4-FFF2-40B4-BE49-F238E27FC236}">
+                <a16:creationId xmlns:a16="http://schemas.microsoft.com/office/drawing/2014/main" id="{41A10601-345E-4A04-878A-28FFF71506B5}"/>
+              </a:ext>
+            </a:extLst>
+          </p:cNvPr>
+          <p:cNvPicPr>
+            <a:picLocks noChangeAspect="1"/>
+          </p:cNvPicPr>
+          <p:nvPr/>
+        </p:nvPicPr>
+        <p:blipFill>
+          <a:blip r:embed="rId2"/>
+          <a:stretch>
+            <a:fillRect/>
+          </a:stretch>
+        </p:blipFill>
+        <p:spPr>
+          <a:xfrm>
+            <a:off x="951375" y="1651145"/>
+            <a:ext cx="8488232" cy="4404795"/>
+          </a:xfrm>
+          <a:prstGeom prst="rect">
+            <a:avLst/>
+          </a:prstGeom>
+        </p:spPr>
+      </p:pic>
+    </p:spTree>
+    <p:extLst>
+      <p:ext uri="{BB962C8B-B14F-4D97-AF65-F5344CB8AC3E}">
+        <p14:creationId xmlns:p14="http://schemas.microsoft.com/office/powerpoint/2010/main" val="2011350768"/>
+      </p:ext>
+    </p:extLst>
+  </p:cSld>
+  <p:clrMapOvr>
+    <a:masterClrMapping/>
+  </p:clrMapOvr>
+  <p:timing>
+    <p:tnLst>
+      <p:par>
+        <p:cTn id="1" dur="indefinite" restart="never" nodeType="tmRoot">
+          <p:childTnLst>
+            <p:seq concurrent="1" nextAc="seek">
+              <p:cTn id="2" dur="indefinite" nodeType="mainSeq">
+                <p:childTnLst>
+                  <p:par>
+                    <p:cTn id="3" fill="hold">
+                      <p:stCondLst>
+                        <p:cond delay="indefinite"/>
+                      </p:stCondLst>
+                      <p:childTnLst>
+                        <p:par>
+                          <p:cTn id="4" fill="hold">
+                            <p:stCondLst>
+                              <p:cond delay="0"/>
+                            </p:stCondLst>
+                            <p:childTnLst>
+                              <p:par>
+                                <p:cTn id="5" presetID="1" presetClass="entr" presetSubtype="0" fill="hold" nodeType="clickEffect">
+                                  <p:stCondLst>
+                                    <p:cond delay="0"/>
+                                  </p:stCondLst>
+                                  <p:childTnLst>
+                                    <p:set>
+                                      <p:cBhvr>
+                                        <p:cTn id="6" dur="1" fill="hold">
+                                          <p:stCondLst>
+                                            <p:cond delay="0"/>
+                                          </p:stCondLst>
+                                        </p:cTn>
+                                        <p:tgtEl>
+                                          <p:spTgt spid="3">
+                                            <p:txEl>
+                                              <p:pRg st="0" end="0"/>
+                                            </p:txEl>
+                                          </p:spTgt>
+                                        </p:tgtEl>
+                                        <p:attrNameLst>
+                                          <p:attrName>style.visibility</p:attrName>
+                                        </p:attrNameLst>
+                                      </p:cBhvr>
+                                      <p:to>
+                                        <p:strVal val="visible"/>
+                                      </p:to>
+                                    </p:set>
+                                  </p:childTnLst>
+                                </p:cTn>
+                              </p:par>
+                            </p:childTnLst>
+                          </p:cTn>
+                        </p:par>
+                      </p:childTnLst>
+                    </p:cTn>
+                  </p:par>
+                  <p:par>
+                    <p:cTn id="7" fill="hold">
+                      <p:stCondLst>
+                        <p:cond delay="indefinite"/>
+                      </p:stCondLst>
+                      <p:childTnLst>
+                        <p:par>
+                          <p:cTn id="8" fill="hold">
+                            <p:stCondLst>
+                              <p:cond delay="0"/>
+                            </p:stCondLst>
+                            <p:childTnLst>
+                              <p:par>
+                                <p:cTn id="9" presetID="1" presetClass="entr" presetSubtype="0" fill="hold" nodeType="clickEffect">
+                                  <p:stCondLst>
+                                    <p:cond delay="0"/>
+                                  </p:stCondLst>
+                                  <p:childTnLst>
+                                    <p:set>
+                                      <p:cBhvr>
+                                        <p:cTn id="10" dur="1" fill="hold">
+                                          <p:stCondLst>
+                                            <p:cond delay="0"/>
+                                          </p:stCondLst>
+                                        </p:cTn>
+                                        <p:tgtEl>
+                                          <p:spTgt spid="3">
+                                            <p:txEl>
+                                              <p:pRg st="11" end="11"/>
+                                            </p:txEl>
+                                          </p:spTgt>
+                                        </p:tgtEl>
+                                        <p:attrNameLst>
+                                          <p:attrName>style.visibility</p:attrName>
+                                        </p:attrNameLst>
+                                      </p:cBhvr>
+                                      <p:to>
+                                        <p:strVal val="visible"/>
+                                      </p:to>
+                                    </p:set>
+                                  </p:childTnLst>
+                                </p:cTn>
+                              </p:par>
+                              <p:par>
+                                <p:cTn id="11" presetID="1" presetClass="entr" presetSubtype="0" fill="hold" nodeType="withEffect">
+                                  <p:stCondLst>
+                                    <p:cond delay="0"/>
+                                  </p:stCondLst>
+                                  <p:childTnLst>
+                                    <p:set>
+                                      <p:cBhvr>
+                                        <p:cTn id="12" dur="1" fill="hold">
+                                          <p:stCondLst>
+                                            <p:cond delay="0"/>
+                                          </p:stCondLst>
+                                        </p:cTn>
+                                        <p:tgtEl>
+                                          <p:spTgt spid="4"/>
+                                        </p:tgtEl>
+                                        <p:attrNameLst>
+                                          <p:attrName>style.visibility</p:attrName>
+                                        </p:attrNameLst>
+                                      </p:cBhvr>
+                                      <p:to>
+                                        <p:strVal val="visible"/>
+                                      </p:to>
+                                    </p:set>
+                                  </p:childTnLst>
+                                </p:cTn>
+                              </p:par>
+                            </p:childTnLst>
+                          </p:cTn>
+                        </p:par>
+                      </p:childTnLst>
+                    </p:cTn>
+                  </p:par>
+                </p:childTnLst>
+              </p:cTn>
+              <p:prevCondLst>
+                <p:cond evt="onPrev" delay="0">
+                  <p:tgtEl>
+                    <p:sldTgt/>
+                  </p:tgtEl>
+                </p:cond>
+              </p:prevCondLst>
+              <p:nextCondLst>
+                <p:cond evt="onNext" delay="0">
+                  <p:tgtEl>
+                    <p:sldTgt/>
+                  </p:tgtEl>
+                </p:cond>
+              </p:nextCondLst>
+            </p:seq>
+          </p:childTnLst>
+        </p:cTn>
+      </p:par>
+    </p:tnLst>
+  </p:timing>
+</p:sld>
+</file>
+
+<file path=ppt/slides/slide50.xml><?xml version="1.0" encoding="utf-8"?>
 <p:sld xmlns:a="http://schemas.openxmlformats.org/drawingml/2006/main" xmlns:r="http://schemas.openxmlformats.org/officeDocument/2006/relationships" xmlns:p="http://schemas.openxmlformats.org/presentationml/2006/main">
   <p:cSld>
     <p:spTree>
@@ -35409,401 +36377,7 @@
 </p:sld>
 </file>
 
-<file path=ppt/slides/slide5.xml><?xml version="1.0" encoding="utf-8"?>
-<p:sld xmlns:a="http://schemas.openxmlformats.org/drawingml/2006/main" xmlns:r="http://schemas.openxmlformats.org/officeDocument/2006/relationships" xmlns:p="http://schemas.openxmlformats.org/presentationml/2006/main">
-  <p:cSld>
-    <p:spTree>
-      <p:nvGrpSpPr>
-        <p:cNvPr id="1" name=""/>
-        <p:cNvGrpSpPr/>
-        <p:nvPr/>
-      </p:nvGrpSpPr>
-      <p:grpSpPr>
-        <a:xfrm>
-          <a:off x="0" y="0"/>
-          <a:ext cx="0" cy="0"/>
-          <a:chOff x="0" y="0"/>
-          <a:chExt cx="0" cy="0"/>
-        </a:xfrm>
-      </p:grpSpPr>
-      <p:sp>
-        <p:nvSpPr>
-          <p:cNvPr id="3" name="Content Placeholder 2">
-            <a:extLst>
-              <a:ext uri="{FF2B5EF4-FFF2-40B4-BE49-F238E27FC236}">
-                <a16:creationId xmlns:a16="http://schemas.microsoft.com/office/drawing/2014/main" id="{258E6AF3-7615-4BD1-878E-A94C93E98F90}"/>
-              </a:ext>
-            </a:extLst>
-          </p:cNvPr>
-          <p:cNvSpPr>
-            <a:spLocks noGrp="1"/>
-          </p:cNvSpPr>
-          <p:nvPr>
-            <p:ph idx="1"/>
-          </p:nvPr>
-        </p:nvSpPr>
-        <p:spPr>
-          <a:xfrm>
-            <a:off x="838200" y="1217458"/>
-            <a:ext cx="10515600" cy="5640542"/>
-          </a:xfrm>
-        </p:spPr>
-        <p:txBody>
-          <a:bodyPr>
-            <a:normAutofit fontScale="92500" lnSpcReduction="10000"/>
-          </a:bodyPr>
-          <a:lstStyle/>
-          <a:p>
-            <a:pPr marL="0" indent="0">
-              <a:buNone/>
-            </a:pPr>
-            <a:r>
-              <a:rPr lang="en-US" sz="3200" dirty="0"/>
-              <a:t>What is the KDD process?   </a:t>
-            </a:r>
-          </a:p>
-          <a:p>
-            <a:pPr marL="0" indent="0">
-              <a:buNone/>
-            </a:pPr>
-            <a:endParaRPr lang="en-US" dirty="0"/>
-          </a:p>
-          <a:p>
-            <a:pPr marL="0" indent="0">
-              <a:buNone/>
-            </a:pPr>
-            <a:endParaRPr lang="en-US" dirty="0"/>
-          </a:p>
-          <a:p>
-            <a:pPr marL="0" indent="0">
-              <a:buNone/>
-            </a:pPr>
-            <a:endParaRPr lang="en-US" dirty="0"/>
-          </a:p>
-          <a:p>
-            <a:pPr marL="0" indent="0">
-              <a:buNone/>
-            </a:pPr>
-            <a:endParaRPr lang="en-US" dirty="0"/>
-          </a:p>
-          <a:p>
-            <a:pPr marL="0" indent="0">
-              <a:buNone/>
-            </a:pPr>
-            <a:endParaRPr lang="en-US" dirty="0"/>
-          </a:p>
-          <a:p>
-            <a:pPr marL="0" indent="0">
-              <a:buNone/>
-            </a:pPr>
-            <a:endParaRPr lang="en-US" dirty="0"/>
-          </a:p>
-          <a:p>
-            <a:pPr marL="0" indent="0">
-              <a:buNone/>
-            </a:pPr>
-            <a:endParaRPr lang="en-US" dirty="0"/>
-          </a:p>
-          <a:p>
-            <a:pPr marL="0" indent="0">
-              <a:buNone/>
-            </a:pPr>
-            <a:endParaRPr lang="en-US" dirty="0">
-              <a:solidFill>
-                <a:schemeClr val="accent1"/>
-              </a:solidFill>
-            </a:endParaRPr>
-          </a:p>
-          <a:p>
-            <a:pPr marL="0" indent="0">
-              <a:buNone/>
-            </a:pPr>
-            <a:endParaRPr lang="en-US" dirty="0">
-              <a:solidFill>
-                <a:schemeClr val="accent1"/>
-              </a:solidFill>
-            </a:endParaRPr>
-          </a:p>
-          <a:p>
-            <a:pPr marL="0" indent="0">
-              <a:buNone/>
-            </a:pPr>
-            <a:endParaRPr lang="en-US" dirty="0">
-              <a:solidFill>
-                <a:schemeClr val="accent1"/>
-              </a:solidFill>
-            </a:endParaRPr>
-          </a:p>
-          <a:p>
-            <a:pPr marL="0" indent="0">
-              <a:buNone/>
-            </a:pPr>
-            <a:r>
-              <a:rPr lang="en-US" dirty="0">
-                <a:solidFill>
-                  <a:schemeClr val="accent1"/>
-                </a:solidFill>
-              </a:rPr>
-              <a:t>Is this old diagram representative?  - e.g. Fayyad et.al. 1996 </a:t>
-            </a:r>
-          </a:p>
-        </p:txBody>
-      </p:sp>
-      <p:sp>
-        <p:nvSpPr>
-          <p:cNvPr id="6" name="Title 1">
-            <a:extLst>
-              <a:ext uri="{FF2B5EF4-FFF2-40B4-BE49-F238E27FC236}">
-                <a16:creationId xmlns:a16="http://schemas.microsoft.com/office/drawing/2014/main" id="{CD29F70F-B868-451B-A65D-8721F4C7A2D9}"/>
-              </a:ext>
-            </a:extLst>
-          </p:cNvPr>
-          <p:cNvSpPr txBox="1">
-            <a:spLocks/>
-          </p:cNvSpPr>
-          <p:nvPr/>
-        </p:nvSpPr>
-        <p:spPr>
-          <a:xfrm>
-            <a:off x="838200" y="-635"/>
-            <a:ext cx="10515600" cy="1325563"/>
-          </a:xfrm>
-          <a:prstGeom prst="rect">
-            <a:avLst/>
-          </a:prstGeom>
-        </p:spPr>
-        <p:txBody>
-          <a:bodyPr vert="horz" lIns="91440" tIns="45720" rIns="91440" bIns="45720" rtlCol="0" anchor="ctr">
-            <a:normAutofit/>
-          </a:bodyPr>
-          <a:lstStyle>
-            <a:lvl1pPr algn="l" defTabSz="914400" rtl="0" eaLnBrk="1" latinLnBrk="0" hangingPunct="1">
-              <a:lnSpc>
-                <a:spcPct val="90000"/>
-              </a:lnSpc>
-              <a:spcBef>
-                <a:spcPct val="0"/>
-              </a:spcBef>
-              <a:buNone/>
-              <a:defRPr sz="4400" kern="1200">
-                <a:solidFill>
-                  <a:schemeClr val="tx1"/>
-                </a:solidFill>
-                <a:latin typeface="+mj-lt"/>
-                <a:ea typeface="+mj-ea"/>
-                <a:cs typeface="+mj-cs"/>
-              </a:defRPr>
-            </a:lvl1pPr>
-          </a:lstStyle>
-          <a:p>
-            <a:r>
-              <a:rPr lang="en-US" dirty="0">
-                <a:latin typeface="+mn-lt"/>
-              </a:rPr>
-              <a:t>KDD process</a:t>
-            </a:r>
-          </a:p>
-        </p:txBody>
-      </p:sp>
-      <p:pic>
-        <p:nvPicPr>
-          <p:cNvPr id="4" name="Picture 3">
-            <a:extLst>
-              <a:ext uri="{FF2B5EF4-FFF2-40B4-BE49-F238E27FC236}">
-                <a16:creationId xmlns:a16="http://schemas.microsoft.com/office/drawing/2014/main" id="{41A10601-345E-4A04-878A-28FFF71506B5}"/>
-              </a:ext>
-            </a:extLst>
-          </p:cNvPr>
-          <p:cNvPicPr>
-            <a:picLocks noChangeAspect="1"/>
-          </p:cNvPicPr>
-          <p:nvPr/>
-        </p:nvPicPr>
-        <p:blipFill>
-          <a:blip r:embed="rId2"/>
-          <a:stretch>
-            <a:fillRect/>
-          </a:stretch>
-        </p:blipFill>
-        <p:spPr>
-          <a:xfrm>
-            <a:off x="951375" y="1651145"/>
-            <a:ext cx="8488232" cy="4404795"/>
-          </a:xfrm>
-          <a:prstGeom prst="rect">
-            <a:avLst/>
-          </a:prstGeom>
-        </p:spPr>
-      </p:pic>
-    </p:spTree>
-    <p:extLst>
-      <p:ext uri="{BB962C8B-B14F-4D97-AF65-F5344CB8AC3E}">
-        <p14:creationId xmlns:p14="http://schemas.microsoft.com/office/powerpoint/2010/main" val="2011350768"/>
-      </p:ext>
-    </p:extLst>
-  </p:cSld>
-  <p:clrMapOvr>
-    <a:masterClrMapping/>
-  </p:clrMapOvr>
-  <p:timing>
-    <p:tnLst>
-      <p:par>
-        <p:cTn id="1" dur="indefinite" restart="never" nodeType="tmRoot">
-          <p:childTnLst>
-            <p:seq concurrent="1" nextAc="seek">
-              <p:cTn id="2" dur="indefinite" nodeType="mainSeq">
-                <p:childTnLst>
-                  <p:par>
-                    <p:cTn id="3" fill="hold">
-                      <p:stCondLst>
-                        <p:cond delay="indefinite"/>
-                      </p:stCondLst>
-                      <p:childTnLst>
-                        <p:par>
-                          <p:cTn id="4" fill="hold">
-                            <p:stCondLst>
-                              <p:cond delay="0"/>
-                            </p:stCondLst>
-                            <p:childTnLst>
-                              <p:par>
-                                <p:cTn id="5" presetID="1" presetClass="entr" presetSubtype="0" fill="hold" nodeType="clickEffect">
-                                  <p:stCondLst>
-                                    <p:cond delay="0"/>
-                                  </p:stCondLst>
-                                  <p:childTnLst>
-                                    <p:set>
-                                      <p:cBhvr>
-                                        <p:cTn id="6" dur="1" fill="hold">
-                                          <p:stCondLst>
-                                            <p:cond delay="0"/>
-                                          </p:stCondLst>
-                                        </p:cTn>
-                                        <p:tgtEl>
-                                          <p:spTgt spid="3">
-                                            <p:txEl>
-                                              <p:pRg st="0" end="0"/>
-                                            </p:txEl>
-                                          </p:spTgt>
-                                        </p:tgtEl>
-                                        <p:attrNameLst>
-                                          <p:attrName>style.visibility</p:attrName>
-                                        </p:attrNameLst>
-                                      </p:cBhvr>
-                                      <p:to>
-                                        <p:strVal val="visible"/>
-                                      </p:to>
-                                    </p:set>
-                                  </p:childTnLst>
-                                </p:cTn>
-                              </p:par>
-                            </p:childTnLst>
-                          </p:cTn>
-                        </p:par>
-                      </p:childTnLst>
-                    </p:cTn>
-                  </p:par>
-                  <p:par>
-                    <p:cTn id="7" fill="hold">
-                      <p:stCondLst>
-                        <p:cond delay="indefinite"/>
-                      </p:stCondLst>
-                      <p:childTnLst>
-                        <p:par>
-                          <p:cTn id="8" fill="hold">
-                            <p:stCondLst>
-                              <p:cond delay="0"/>
-                            </p:stCondLst>
-                            <p:childTnLst>
-                              <p:par>
-                                <p:cTn id="9" presetID="1" presetClass="entr" presetSubtype="0" fill="hold" nodeType="clickEffect">
-                                  <p:stCondLst>
-                                    <p:cond delay="0"/>
-                                  </p:stCondLst>
-                                  <p:childTnLst>
-                                    <p:set>
-                                      <p:cBhvr>
-                                        <p:cTn id="10" dur="1" fill="hold">
-                                          <p:stCondLst>
-                                            <p:cond delay="0"/>
-                                          </p:stCondLst>
-                                        </p:cTn>
-                                        <p:tgtEl>
-                                          <p:spTgt spid="3">
-                                            <p:txEl>
-                                              <p:pRg st="11" end="11"/>
-                                            </p:txEl>
-                                          </p:spTgt>
-                                        </p:tgtEl>
-                                        <p:attrNameLst>
-                                          <p:attrName>style.visibility</p:attrName>
-                                        </p:attrNameLst>
-                                      </p:cBhvr>
-                                      <p:to>
-                                        <p:strVal val="visible"/>
-                                      </p:to>
-                                    </p:set>
-                                  </p:childTnLst>
-                                </p:cTn>
-                              </p:par>
-                              <p:par>
-                                <p:cTn id="11" presetID="1" presetClass="entr" presetSubtype="0" fill="hold" nodeType="withEffect">
-                                  <p:stCondLst>
-                                    <p:cond delay="0"/>
-                                  </p:stCondLst>
-                                  <p:childTnLst>
-                                    <p:set>
-                                      <p:cBhvr>
-                                        <p:cTn id="12" dur="1" fill="hold">
-                                          <p:stCondLst>
-                                            <p:cond delay="0"/>
-                                          </p:stCondLst>
-                                        </p:cTn>
-                                        <p:tgtEl>
-                                          <p:spTgt spid="4"/>
-                                        </p:tgtEl>
-                                        <p:attrNameLst>
-                                          <p:attrName>style.visibility</p:attrName>
-                                        </p:attrNameLst>
-                                      </p:cBhvr>
-                                      <p:to>
-                                        <p:strVal val="visible"/>
-                                      </p:to>
-                                    </p:set>
-                                  </p:childTnLst>
-                                </p:cTn>
-                              </p:par>
-                            </p:childTnLst>
-                          </p:cTn>
-                        </p:par>
-                      </p:childTnLst>
-                    </p:cTn>
-                  </p:par>
-                </p:childTnLst>
-              </p:cTn>
-              <p:prevCondLst>
-                <p:cond evt="onPrev" delay="0">
-                  <p:tgtEl>
-                    <p:sldTgt/>
-                  </p:tgtEl>
-                </p:cond>
-              </p:prevCondLst>
-              <p:nextCondLst>
-                <p:cond evt="onNext" delay="0">
-                  <p:tgtEl>
-                    <p:sldTgt/>
-                  </p:tgtEl>
-                </p:cond>
-              </p:nextCondLst>
-            </p:seq>
-          </p:childTnLst>
-        </p:cTn>
-      </p:par>
-    </p:tnLst>
-  </p:timing>
-</p:sld>
-</file>
-
-<file path=ppt/slides/slide50.xml><?xml version="1.0" encoding="utf-8"?>
+<file path=ppt/slides/slide51.xml><?xml version="1.0" encoding="utf-8"?>
 <p:sld xmlns:a="http://schemas.openxmlformats.org/drawingml/2006/main" xmlns:r="http://schemas.openxmlformats.org/officeDocument/2006/relationships" xmlns:p="http://schemas.openxmlformats.org/presentationml/2006/main">
   <p:cSld>
     <p:spTree>
@@ -36350,7 +36924,7 @@
 </p:sld>
 </file>
 
-<file path=ppt/slides/slide51.xml><?xml version="1.0" encoding="utf-8"?>
+<file path=ppt/slides/slide52.xml><?xml version="1.0" encoding="utf-8"?>
 <p:sld xmlns:a="http://schemas.openxmlformats.org/drawingml/2006/main" xmlns:r="http://schemas.openxmlformats.org/officeDocument/2006/relationships" xmlns:p="http://schemas.openxmlformats.org/presentationml/2006/main">
   <p:cSld>
     <p:spTree>
@@ -36949,7 +37523,7 @@
 </p:sld>
 </file>
 
-<file path=ppt/slides/slide52.xml><?xml version="1.0" encoding="utf-8"?>
+<file path=ppt/slides/slide53.xml><?xml version="1.0" encoding="utf-8"?>
 <p:sld xmlns:a="http://schemas.openxmlformats.org/drawingml/2006/main" xmlns:r="http://schemas.openxmlformats.org/officeDocument/2006/relationships" xmlns:p="http://schemas.openxmlformats.org/presentationml/2006/main">
   <p:cSld>
     <p:spTree>
@@ -37538,7 +38112,7 @@
 </p:sld>
 </file>
 
-<file path=ppt/slides/slide53.xml><?xml version="1.0" encoding="utf-8"?>
+<file path=ppt/slides/slide54.xml><?xml version="1.0" encoding="utf-8"?>
 <p:sld xmlns:a="http://schemas.openxmlformats.org/drawingml/2006/main" xmlns:r="http://schemas.openxmlformats.org/officeDocument/2006/relationships" xmlns:p="http://schemas.openxmlformats.org/presentationml/2006/main">
   <p:cSld>
     <p:spTree>
@@ -38471,7 +39045,7 @@
 </p:sld>
 </file>
 
-<file path=ppt/slides/slide54.xml><?xml version="1.0" encoding="utf-8"?>
+<file path=ppt/slides/slide55.xml><?xml version="1.0" encoding="utf-8"?>
 <p:sld xmlns:a="http://schemas.openxmlformats.org/drawingml/2006/main" xmlns:r="http://schemas.openxmlformats.org/officeDocument/2006/relationships" xmlns:p="http://schemas.openxmlformats.org/presentationml/2006/main">
   <p:cSld>
     <p:spTree>
@@ -39070,7 +39644,7 @@
 </p:sld>
 </file>
 
-<file path=ppt/slides/slide55.xml><?xml version="1.0" encoding="utf-8"?>
+<file path=ppt/slides/slide56.xml><?xml version="1.0" encoding="utf-8"?>
 <p:sld xmlns:a="http://schemas.openxmlformats.org/drawingml/2006/main" xmlns:r="http://schemas.openxmlformats.org/officeDocument/2006/relationships" xmlns:p="http://schemas.openxmlformats.org/presentationml/2006/main">
   <p:cSld>
     <p:spTree>
@@ -39588,7 +40162,7 @@
 </p:sld>
 </file>
 
-<file path=ppt/slides/slide56.xml><?xml version="1.0" encoding="utf-8"?>
+<file path=ppt/slides/slide57.xml><?xml version="1.0" encoding="utf-8"?>
 <p:sld xmlns:a="http://schemas.openxmlformats.org/drawingml/2006/main" xmlns:r="http://schemas.openxmlformats.org/officeDocument/2006/relationships" xmlns:p="http://schemas.openxmlformats.org/presentationml/2006/main">
   <p:cSld>
     <p:spTree>
@@ -40314,7 +40888,7 @@
 </p:sld>
 </file>
 
-<file path=ppt/slides/slide57.xml><?xml version="1.0" encoding="utf-8"?>
+<file path=ppt/slides/slide58.xml><?xml version="1.0" encoding="utf-8"?>
 <p:sld xmlns:a="http://schemas.openxmlformats.org/drawingml/2006/main" xmlns:r="http://schemas.openxmlformats.org/officeDocument/2006/relationships" xmlns:p="http://schemas.openxmlformats.org/presentationml/2006/main">
   <p:cSld>
     <p:spTree>
@@ -40380,7 +40954,7 @@
 </p:sld>
 </file>
 
-<file path=ppt/slides/slide58.xml><?xml version="1.0" encoding="utf-8"?>
+<file path=ppt/slides/slide59.xml><?xml version="1.0" encoding="utf-8"?>
 <p:sld xmlns:a="http://schemas.openxmlformats.org/drawingml/2006/main" xmlns:r="http://schemas.openxmlformats.org/officeDocument/2006/relationships" xmlns:p="http://schemas.openxmlformats.org/presentationml/2006/main">
   <p:cSld>
     <p:spTree>

</xml_diff>

<commit_message>
Initial commit of first assignment notebook
</commit_message>
<xml_diff>
--- a/slides/1_Introduction.pptx
+++ b/slides/1_Introduction.pptx
@@ -16,7 +16,7 @@
     <p:sldId id="356" r:id="rId7"/>
     <p:sldId id="782" r:id="rId8"/>
     <p:sldId id="712" r:id="rId9"/>
-    <p:sldId id="288" r:id="rId10"/>
+    <p:sldId id="794" r:id="rId10"/>
     <p:sldId id="733" r:id="rId11"/>
     <p:sldId id="788" r:id="rId12"/>
     <p:sldId id="724" r:id="rId13"/>
@@ -259,7 +259,7 @@
           <a:p>
             <a:fld id="{2F3ABF1A-8818-4472-8518-E71DC7B5D2F7}" type="datetimeFigureOut">
               <a:rPr lang="en-US" smtClean="0"/>
-              <a:t>6/21/2026</a:t>
+              <a:t>6/23/2026</a:t>
             </a:fld>
             <a:endParaRPr lang="en-US"/>
           </a:p>
@@ -891,7 +891,7 @@
           <a:p>
             <a:fld id="{6E4A31BF-7266-4BEB-918B-ADC21C630A6F}" type="datetimeFigureOut">
               <a:rPr lang="en-US" smtClean="0"/>
-              <a:t>6/21/2026</a:t>
+              <a:t>6/23/2026</a:t>
             </a:fld>
             <a:endParaRPr lang="en-US"/>
           </a:p>
@@ -1089,7 +1089,7 @@
           <a:p>
             <a:fld id="{6E4A31BF-7266-4BEB-918B-ADC21C630A6F}" type="datetimeFigureOut">
               <a:rPr lang="en-US" smtClean="0"/>
-              <a:t>6/21/2026</a:t>
+              <a:t>6/23/2026</a:t>
             </a:fld>
             <a:endParaRPr lang="en-US"/>
           </a:p>
@@ -1297,7 +1297,7 @@
           <a:p>
             <a:fld id="{6E4A31BF-7266-4BEB-918B-ADC21C630A6F}" type="datetimeFigureOut">
               <a:rPr lang="en-US" smtClean="0"/>
-              <a:t>6/21/2026</a:t>
+              <a:t>6/23/2026</a:t>
             </a:fld>
             <a:endParaRPr lang="en-US"/>
           </a:p>
@@ -1841,7 +1841,7 @@
           <a:p>
             <a:fld id="{6E4A31BF-7266-4BEB-918B-ADC21C630A6F}" type="datetimeFigureOut">
               <a:rPr lang="en-US" smtClean="0"/>
-              <a:t>6/21/2026</a:t>
+              <a:t>6/23/2026</a:t>
             </a:fld>
             <a:endParaRPr lang="en-US"/>
           </a:p>
@@ -2116,7 +2116,7 @@
           <a:p>
             <a:fld id="{6E4A31BF-7266-4BEB-918B-ADC21C630A6F}" type="datetimeFigureOut">
               <a:rPr lang="en-US" smtClean="0"/>
-              <a:t>6/21/2026</a:t>
+              <a:t>6/23/2026</a:t>
             </a:fld>
             <a:endParaRPr lang="en-US"/>
           </a:p>
@@ -2381,7 +2381,7 @@
           <a:p>
             <a:fld id="{6E4A31BF-7266-4BEB-918B-ADC21C630A6F}" type="datetimeFigureOut">
               <a:rPr lang="en-US" smtClean="0"/>
-              <a:t>6/21/2026</a:t>
+              <a:t>6/23/2026</a:t>
             </a:fld>
             <a:endParaRPr lang="en-US"/>
           </a:p>
@@ -2793,7 +2793,7 @@
           <a:p>
             <a:fld id="{6E4A31BF-7266-4BEB-918B-ADC21C630A6F}" type="datetimeFigureOut">
               <a:rPr lang="en-US" smtClean="0"/>
-              <a:t>6/21/2026</a:t>
+              <a:t>6/23/2026</a:t>
             </a:fld>
             <a:endParaRPr lang="en-US"/>
           </a:p>
@@ -2934,7 +2934,7 @@
           <a:p>
             <a:fld id="{6E4A31BF-7266-4BEB-918B-ADC21C630A6F}" type="datetimeFigureOut">
               <a:rPr lang="en-US" smtClean="0"/>
-              <a:t>6/21/2026</a:t>
+              <a:t>6/23/2026</a:t>
             </a:fld>
             <a:endParaRPr lang="en-US"/>
           </a:p>
@@ -3047,7 +3047,7 @@
           <a:p>
             <a:fld id="{6E4A31BF-7266-4BEB-918B-ADC21C630A6F}" type="datetimeFigureOut">
               <a:rPr lang="en-US" smtClean="0"/>
-              <a:t>6/21/2026</a:t>
+              <a:t>6/23/2026</a:t>
             </a:fld>
             <a:endParaRPr lang="en-US"/>
           </a:p>
@@ -3358,7 +3358,7 @@
           <a:p>
             <a:fld id="{6E4A31BF-7266-4BEB-918B-ADC21C630A6F}" type="datetimeFigureOut">
               <a:rPr lang="en-US" smtClean="0"/>
-              <a:t>6/21/2026</a:t>
+              <a:t>6/23/2026</a:t>
             </a:fld>
             <a:endParaRPr lang="en-US"/>
           </a:p>
@@ -3646,7 +3646,7 @@
           <a:p>
             <a:fld id="{6E4A31BF-7266-4BEB-918B-ADC21C630A6F}" type="datetimeFigureOut">
               <a:rPr lang="en-US" smtClean="0"/>
-              <a:t>6/21/2026</a:t>
+              <a:t>6/23/2026</a:t>
             </a:fld>
             <a:endParaRPr lang="en-US"/>
           </a:p>
@@ -3887,7 +3887,7 @@
           <a:p>
             <a:fld id="{6E4A31BF-7266-4BEB-918B-ADC21C630A6F}" type="datetimeFigureOut">
               <a:rPr lang="en-US" smtClean="0"/>
-              <a:t>6/21/2026</a:t>
+              <a:t>6/23/2026</a:t>
             </a:fld>
             <a:endParaRPr lang="en-US"/>
           </a:p>
@@ -5609,7 +5609,7 @@
             <a:pPr lvl="1"/>
             <a:r>
               <a:rPr lang="en-US" dirty="0"/>
-              <a:t>Scalable approximate algorithms analytic algorithms </a:t>
+              <a:t>Scalable approximate analytic algorithms </a:t>
             </a:r>
           </a:p>
           <a:p>
@@ -6770,8 +6770,8 @@
           <a:chExt cx="0" cy="0"/>
         </a:xfrm>
       </p:grpSpPr>
-      <mc:AlternateContent xmlns:mc="http://schemas.openxmlformats.org/markup-compatibility/2006">
-        <mc:Choice xmlns:a14="http://schemas.microsoft.com/office/drawing/2010/main" Requires="a14">
+      <mc:AlternateContent xmlns:mc="http://schemas.openxmlformats.org/markup-compatibility/2006" xmlns:a14="http://schemas.microsoft.com/office/drawing/2010/main">
+        <mc:Choice Requires="a14">
           <p:sp>
             <p:nvSpPr>
               <p:cNvPr id="3" name="Content Placeholder 2">
@@ -6898,7 +6898,7 @@
             </p:txBody>
           </p:sp>
         </mc:Choice>
-        <mc:Fallback>
+        <mc:Fallback xmlns="">
           <p:sp>
             <p:nvSpPr>
               <p:cNvPr id="3" name="Content Placeholder 2">
@@ -12002,7 +12002,7 @@
           <a:p>
             <a:r>
               <a:rPr lang="en-US" dirty="0"/>
-              <a:t>Data mining often uses massive data sets</a:t>
+              <a:t>Data mining uses massive data sets</a:t>
             </a:r>
           </a:p>
           <a:p>
@@ -13296,12 +13296,17 @@
             </a:r>
             <a:r>
               <a:rPr lang="en-US" b="1" dirty="0"/>
-              <a:t>9 assignments </a:t>
+              <a:t>8 assignments </a:t>
             </a:r>
             <a:r>
               <a:rPr lang="en-US" dirty="0"/>
-              <a:t>plus online discussion questions</a:t>
-            </a:r>
+              <a:t>plus online discussion questions and projects for </a:t>
+            </a:r>
+            <a:r>
+              <a:rPr lang="en-US"/>
+              <a:t>graduate credit</a:t>
+            </a:r>
+            <a:endParaRPr lang="en-US" dirty="0"/>
           </a:p>
           <a:p>
             <a:r>
@@ -16995,7 +17000,7 @@
             <a:pPr lvl="1"/>
             <a:r>
               <a:rPr lang="en-US" dirty="0"/>
-              <a:t>Many steps</a:t>
+              <a:t>Iteratively apply many approaches</a:t>
             </a:r>
           </a:p>
           <a:p>
@@ -22261,11 +22266,11 @@
             </a:pPr>
             <a:r>
               <a:rPr lang="en-US" dirty="0"/>
-              <a:t>Data mining (KDD) is generally performed at </a:t>
+              <a:t>Data mining (KDD) focuses on analytics at a </a:t>
             </a:r>
             <a:r>
               <a:rPr lang="en-US" b="1" dirty="0"/>
-              <a:t>large scale </a:t>
+              <a:t>massive scale </a:t>
             </a:r>
           </a:p>
           <a:p>
@@ -42910,7 +42915,7 @@
               <a:rPr lang="en-US" dirty="0">
                 <a:latin typeface="+mn-lt"/>
               </a:rPr>
-              <a:t>Accuracy?? – hard to quantify </a:t>
+              <a:t>High accuracy?? – hard to quantify </a:t>
             </a:r>
           </a:p>
           <a:p>
@@ -42931,10 +42936,118 @@
       </p:sp>
       <p:sp>
         <p:nvSpPr>
-          <p:cNvPr id="4" name="Isosceles Triangle 3">
+          <p:cNvPr id="5" name="TextBox 4">
             <a:extLst>
               <a:ext uri="{FF2B5EF4-FFF2-40B4-BE49-F238E27FC236}">
-                <a16:creationId xmlns:a16="http://schemas.microsoft.com/office/drawing/2014/main" id="{9725A6CF-0B0D-044D-B5B6-DE9B7965339A}"/>
+                <a16:creationId xmlns:a16="http://schemas.microsoft.com/office/drawing/2014/main" id="{B16EA804-9933-F229-12BD-74D194299BD8}"/>
+              </a:ext>
+            </a:extLst>
+          </p:cNvPr>
+          <p:cNvSpPr txBox="1"/>
+          <p:nvPr/>
+        </p:nvSpPr>
+        <p:spPr>
+          <a:xfrm>
+            <a:off x="9002152" y="1814407"/>
+            <a:ext cx="1877786" cy="830997"/>
+          </a:xfrm>
+          <a:prstGeom prst="rect">
+            <a:avLst/>
+          </a:prstGeom>
+          <a:noFill/>
+        </p:spPr>
+        <p:txBody>
+          <a:bodyPr wrap="square" rtlCol="0">
+            <a:spAutoFit/>
+          </a:bodyPr>
+          <a:lstStyle/>
+          <a:p>
+            <a:pPr algn="ctr"/>
+            <a:r>
+              <a:rPr lang="en-US" sz="2400" dirty="0"/>
+              <a:t>Low Memory -Scalable</a:t>
+            </a:r>
+          </a:p>
+        </p:txBody>
+      </p:sp>
+      <p:sp>
+        <p:nvSpPr>
+          <p:cNvPr id="6" name="TextBox 5">
+            <a:extLst>
+              <a:ext uri="{FF2B5EF4-FFF2-40B4-BE49-F238E27FC236}">
+                <a16:creationId xmlns:a16="http://schemas.microsoft.com/office/drawing/2014/main" id="{422A55F2-3C05-63F7-9CF9-01D795678EB1}"/>
+              </a:ext>
+            </a:extLst>
+          </p:cNvPr>
+          <p:cNvSpPr txBox="1"/>
+          <p:nvPr/>
+        </p:nvSpPr>
+        <p:spPr>
+          <a:xfrm>
+            <a:off x="7179129" y="5577562"/>
+            <a:ext cx="2661557" cy="1200329"/>
+          </a:xfrm>
+          <a:prstGeom prst="rect">
+            <a:avLst/>
+          </a:prstGeom>
+          <a:noFill/>
+        </p:spPr>
+        <p:txBody>
+          <a:bodyPr wrap="square" rtlCol="0">
+            <a:spAutoFit/>
+          </a:bodyPr>
+          <a:lstStyle/>
+          <a:p>
+            <a:pPr algn="ctr"/>
+            <a:r>
+              <a:rPr lang="en-US" sz="2400" dirty="0"/>
+              <a:t>Low Computational Complexity-Scalable</a:t>
+            </a:r>
+          </a:p>
+        </p:txBody>
+      </p:sp>
+      <p:sp>
+        <p:nvSpPr>
+          <p:cNvPr id="7" name="TextBox 6">
+            <a:extLst>
+              <a:ext uri="{FF2B5EF4-FFF2-40B4-BE49-F238E27FC236}">
+                <a16:creationId xmlns:a16="http://schemas.microsoft.com/office/drawing/2014/main" id="{002E1CDF-2012-FB77-C632-1BA165B1028C}"/>
+              </a:ext>
+            </a:extLst>
+          </p:cNvPr>
+          <p:cNvSpPr txBox="1"/>
+          <p:nvPr/>
+        </p:nvSpPr>
+        <p:spPr>
+          <a:xfrm>
+            <a:off x="10510157" y="5577562"/>
+            <a:ext cx="1681843" cy="830997"/>
+          </a:xfrm>
+          <a:prstGeom prst="rect">
+            <a:avLst/>
+          </a:prstGeom>
+          <a:noFill/>
+        </p:spPr>
+        <p:txBody>
+          <a:bodyPr wrap="square" rtlCol="0">
+            <a:spAutoFit/>
+          </a:bodyPr>
+          <a:lstStyle/>
+          <a:p>
+            <a:pPr algn="ctr"/>
+            <a:r>
+              <a:rPr lang="en-US" sz="2400" dirty="0"/>
+              <a:t>High Accuracy</a:t>
+            </a:r>
+          </a:p>
+        </p:txBody>
+      </p:sp>
+      <p:sp>
+        <p:nvSpPr>
+          <p:cNvPr id="8" name="Isosceles Triangle 7">
+            <a:extLst>
+              <a:ext uri="{FF2B5EF4-FFF2-40B4-BE49-F238E27FC236}">
+                <a16:creationId xmlns:a16="http://schemas.microsoft.com/office/drawing/2014/main" id="{7ADCB176-2C73-258E-E558-49D81DC3D17B}"/>
               </a:ext>
             </a:extLst>
           </p:cNvPr>
@@ -42983,10 +43096,10 @@
       </p:sp>
       <p:sp>
         <p:nvSpPr>
-          <p:cNvPr id="5" name="TextBox 4">
+          <p:cNvPr id="9" name="TextBox 8">
             <a:extLst>
               <a:ext uri="{FF2B5EF4-FFF2-40B4-BE49-F238E27FC236}">
-                <a16:creationId xmlns:a16="http://schemas.microsoft.com/office/drawing/2014/main" id="{B16EA804-9933-F229-12BD-74D194299BD8}"/>
+                <a16:creationId xmlns:a16="http://schemas.microsoft.com/office/drawing/2014/main" id="{D9A9467D-C382-809A-7C02-4A9437E9793F}"/>
               </a:ext>
             </a:extLst>
           </p:cNvPr>
@@ -42995,8 +43108,8 @@
         </p:nvSpPr>
         <p:spPr>
           <a:xfrm>
-            <a:off x="9002152" y="1814407"/>
-            <a:ext cx="1877786" cy="830997"/>
+            <a:off x="10466985" y="4937425"/>
+            <a:ext cx="1000667" cy="461665"/>
           </a:xfrm>
           <a:prstGeom prst="rect">
             <a:avLst/>
@@ -43011,18 +43124,18 @@
           <a:p>
             <a:pPr algn="ctr"/>
             <a:r>
-              <a:rPr lang="en-US" sz="2400" dirty="0"/>
-              <a:t>Low Memory -Scalable</a:t>
+              <a:rPr lang="en-US" sz="2400" b="1" dirty="0"/>
+              <a:t>LLMs</a:t>
             </a:r>
           </a:p>
         </p:txBody>
       </p:sp>
       <p:sp>
         <p:nvSpPr>
-          <p:cNvPr id="6" name="TextBox 5">
+          <p:cNvPr id="10" name="TextBox 9">
             <a:extLst>
               <a:ext uri="{FF2B5EF4-FFF2-40B4-BE49-F238E27FC236}">
-                <a16:creationId xmlns:a16="http://schemas.microsoft.com/office/drawing/2014/main" id="{422A55F2-3C05-63F7-9CF9-01D795678EB1}"/>
+                <a16:creationId xmlns:a16="http://schemas.microsoft.com/office/drawing/2014/main" id="{CED37EB6-D985-47B6-5752-1BDE773DF71A}"/>
               </a:ext>
             </a:extLst>
           </p:cNvPr>
@@ -43030,9 +43143,9 @@
           <p:nvPr/>
         </p:nvSpPr>
         <p:spPr>
-          <a:xfrm>
-            <a:off x="7179129" y="5577562"/>
-            <a:ext cx="2661557" cy="1200329"/>
+          <a:xfrm rot="18030204">
+            <a:off x="7765821" y="3906540"/>
+            <a:ext cx="3177092" cy="830997"/>
           </a:xfrm>
           <a:prstGeom prst="rect">
             <a:avLst/>
@@ -43047,44 +43160,8 @@
           <a:p>
             <a:pPr algn="ctr"/>
             <a:r>
-              <a:rPr lang="en-US" sz="2400" dirty="0"/>
-              <a:t>Low Computational Complexity-Scalable</a:t>
-            </a:r>
-          </a:p>
-        </p:txBody>
-      </p:sp>
-      <p:sp>
-        <p:nvSpPr>
-          <p:cNvPr id="7" name="TextBox 6">
-            <a:extLst>
-              <a:ext uri="{FF2B5EF4-FFF2-40B4-BE49-F238E27FC236}">
-                <a16:creationId xmlns:a16="http://schemas.microsoft.com/office/drawing/2014/main" id="{002E1CDF-2012-FB77-C632-1BA165B1028C}"/>
-              </a:ext>
-            </a:extLst>
-          </p:cNvPr>
-          <p:cNvSpPr txBox="1"/>
-          <p:nvPr/>
-        </p:nvSpPr>
-        <p:spPr>
-          <a:xfrm>
-            <a:off x="10510157" y="5577562"/>
-            <a:ext cx="1681843" cy="830997"/>
-          </a:xfrm>
-          <a:prstGeom prst="rect">
-            <a:avLst/>
-          </a:prstGeom>
-          <a:noFill/>
-        </p:spPr>
-        <p:txBody>
-          <a:bodyPr wrap="square" rtlCol="0">
-            <a:spAutoFit/>
-          </a:bodyPr>
-          <a:lstStyle/>
-          <a:p>
-            <a:pPr algn="ctr"/>
-            <a:r>
-              <a:rPr lang="en-US" sz="2400" dirty="0"/>
-              <a:t>High Accuracy</a:t>
+              <a:rPr lang="en-US" sz="2400" b="1" dirty="0"/>
+              <a:t>Focus of Data Mining Algorithms</a:t>
             </a:r>
           </a:p>
         </p:txBody>
@@ -43213,7 +43290,7 @@
                                           </p:stCondLst>
                                         </p:cTn>
                                         <p:tgtEl>
-                                          <p:spTgt spid="4"/>
+                                          <p:spTgt spid="8"/>
                                         </p:tgtEl>
                                         <p:attrNameLst>
                                           <p:attrName>style.visibility</p:attrName>
@@ -43454,43 +43531,21 @@
                                   </p:childTnLst>
                                 </p:cTn>
                               </p:par>
-                            </p:childTnLst>
-                          </p:cTn>
-                        </p:par>
-                      </p:childTnLst>
-                    </p:cTn>
-                  </p:par>
-                  <p:par>
-                    <p:cTn id="31" fill="hold">
-                      <p:stCondLst>
-                        <p:cond delay="indefinite"/>
-                      </p:stCondLst>
-                      <p:childTnLst>
-                        <p:par>
-                          <p:cTn id="32" fill="hold">
-                            <p:stCondLst>
-                              <p:cond delay="0"/>
-                            </p:stCondLst>
-                            <p:childTnLst>
                               <p:par>
-                                <p:cTn id="33" presetID="1" presetClass="entr" presetSubtype="0" fill="hold" nodeType="clickEffect">
+                                <p:cTn id="31" presetID="1" presetClass="entr" presetSubtype="0" fill="hold" grpId="0" nodeType="withEffect">
                                   <p:stCondLst>
                                     <p:cond delay="0"/>
                                   </p:stCondLst>
                                   <p:childTnLst>
                                     <p:set>
                                       <p:cBhvr>
-                                        <p:cTn id="34" dur="1" fill="hold">
+                                        <p:cTn id="32" dur="1" fill="hold">
                                           <p:stCondLst>
                                             <p:cond delay="0"/>
                                           </p:stCondLst>
                                         </p:cTn>
                                         <p:tgtEl>
-                                          <p:spTgt spid="3">
-                                            <p:txEl>
-                                              <p:pRg st="6" end="6"/>
-                                            </p:txEl>
-                                          </p:spTgt>
+                                          <p:spTgt spid="10"/>
                                         </p:tgtEl>
                                         <p:attrNameLst>
                                           <p:attrName>style.visibility</p:attrName>
@@ -43503,8 +43558,26 @@
                                   </p:childTnLst>
                                 </p:cTn>
                               </p:par>
+                            </p:childTnLst>
+                          </p:cTn>
+                        </p:par>
+                      </p:childTnLst>
+                    </p:cTn>
+                  </p:par>
+                  <p:par>
+                    <p:cTn id="33" fill="hold">
+                      <p:stCondLst>
+                        <p:cond delay="indefinite"/>
+                      </p:stCondLst>
+                      <p:childTnLst>
+                        <p:par>
+                          <p:cTn id="34" fill="hold">
+                            <p:stCondLst>
+                              <p:cond delay="0"/>
+                            </p:stCondLst>
+                            <p:childTnLst>
                               <p:par>
-                                <p:cTn id="35" presetID="1" presetClass="entr" presetSubtype="0" fill="hold" nodeType="withEffect">
+                                <p:cTn id="35" presetID="1" presetClass="entr" presetSubtype="0" fill="hold" nodeType="clickEffect">
                                   <p:stCondLst>
                                     <p:cond delay="0"/>
                                   </p:stCondLst>
@@ -43519,7 +43592,7 @@
                                         <p:tgtEl>
                                           <p:spTgt spid="3">
                                             <p:txEl>
-                                              <p:pRg st="7" end="7"/>
+                                              <p:pRg st="6" end="6"/>
                                             </p:txEl>
                                           </p:spTgt>
                                         </p:tgtEl>
@@ -43550,7 +43623,7 @@
                                         <p:tgtEl>
                                           <p:spTgt spid="3">
                                             <p:txEl>
-                                              <p:pRg st="8" end="8"/>
+                                              <p:pRg st="7" end="7"/>
                                             </p:txEl>
                                           </p:spTgt>
                                         </p:tgtEl>
@@ -43581,9 +43654,67 @@
                                         <p:tgtEl>
                                           <p:spTgt spid="3">
                                             <p:txEl>
+                                              <p:pRg st="8" end="8"/>
+                                            </p:txEl>
+                                          </p:spTgt>
+                                        </p:tgtEl>
+                                        <p:attrNameLst>
+                                          <p:attrName>style.visibility</p:attrName>
+                                        </p:attrNameLst>
+                                      </p:cBhvr>
+                                      <p:to>
+                                        <p:strVal val="visible"/>
+                                      </p:to>
+                                    </p:set>
+                                  </p:childTnLst>
+                                </p:cTn>
+                              </p:par>
+                              <p:par>
+                                <p:cTn id="41" presetID="1" presetClass="entr" presetSubtype="0" fill="hold" nodeType="withEffect">
+                                  <p:stCondLst>
+                                    <p:cond delay="0"/>
+                                  </p:stCondLst>
+                                  <p:childTnLst>
+                                    <p:set>
+                                      <p:cBhvr>
+                                        <p:cTn id="42" dur="1" fill="hold">
+                                          <p:stCondLst>
+                                            <p:cond delay="0"/>
+                                          </p:stCondLst>
+                                        </p:cTn>
+                                        <p:tgtEl>
+                                          <p:spTgt spid="3">
+                                            <p:txEl>
                                               <p:pRg st="9" end="9"/>
                                             </p:txEl>
                                           </p:spTgt>
+                                        </p:tgtEl>
+                                        <p:attrNameLst>
+                                          <p:attrName>style.visibility</p:attrName>
+                                        </p:attrNameLst>
+                                      </p:cBhvr>
+                                      <p:to>
+                                        <p:strVal val="visible"/>
+                                      </p:to>
+                                    </p:set>
+                                  </p:childTnLst>
+                                </p:cTn>
+                              </p:par>
+                              <p:par>
+                                <p:cTn id="43" presetID="1" presetClass="entr" presetSubtype="0" fill="hold" grpId="0" nodeType="withEffect">
+                                  <p:stCondLst>
+                                    <p:cond delay="0"/>
+                                  </p:stCondLst>
+                                  <p:childTnLst>
+                                    <p:set>
+                                      <p:cBhvr>
+                                        <p:cTn id="44" dur="1" fill="hold">
+                                          <p:stCondLst>
+                                            <p:cond delay="0"/>
+                                          </p:stCondLst>
+                                        </p:cTn>
+                                        <p:tgtEl>
+                                          <p:spTgt spid="9"/>
                                         </p:tgtEl>
                                         <p:attrNameLst>
                                           <p:attrName>style.visibility</p:attrName>
@@ -43624,10 +43755,12 @@
       </p:par>
     </p:tnLst>
     <p:bldLst>
-      <p:bldP spid="4" grpId="0" animBg="1"/>
       <p:bldP spid="5" grpId="0"/>
       <p:bldP spid="6" grpId="0"/>
       <p:bldP spid="7" grpId="0"/>
+      <p:bldP spid="8" grpId="0" animBg="1"/>
+      <p:bldP spid="9" grpId="0"/>
+      <p:bldP spid="10" grpId="0"/>
     </p:bldLst>
   </p:timing>
 </p:sld>
@@ -43765,15 +43898,29 @@
         </p:nvSpPr>
         <p:spPr>
           <a:xfrm>
-            <a:off x="672105" y="1478300"/>
-            <a:ext cx="10515600" cy="4814924"/>
+            <a:off x="672107" y="1295835"/>
+            <a:ext cx="8168835" cy="5355772"/>
           </a:xfrm>
         </p:spPr>
         <p:txBody>
           <a:bodyPr>
-            <a:normAutofit lnSpcReduction="10000"/>
+            <a:normAutofit fontScale="92500" lnSpcReduction="10000"/>
           </a:bodyPr>
           <a:lstStyle/>
+          <a:p>
+            <a:pPr marL="0" indent="0">
+              <a:spcBef>
+                <a:spcPts val="300"/>
+              </a:spcBef>
+              <a:buNone/>
+            </a:pPr>
+            <a:r>
+              <a:rPr lang="en-US" sz="2800" b="0" dirty="0">
+                <a:cs typeface="Arial" panose="020B0604020202020204" pitchFamily="34" charset="0"/>
+              </a:rPr>
+              <a:t>Instructor for Harvard since 2017</a:t>
+            </a:r>
+          </a:p>
           <a:p>
             <a:pPr>
               <a:spcBef>
@@ -43784,7 +43931,7 @@
               <a:rPr lang="en-US" sz="2800" b="0" dirty="0">
                 <a:cs typeface="Arial" panose="020B0604020202020204" pitchFamily="34" charset="0"/>
               </a:rPr>
-              <a:t>Instructor for Harvard since 2017</a:t>
+              <a:t>Data science consultant with several decades of experience</a:t>
             </a:r>
           </a:p>
           <a:p>
@@ -43797,7 +43944,7 @@
               <a:rPr lang="en-US" sz="2800" b="0" dirty="0">
                 <a:cs typeface="Arial" panose="020B0604020202020204" pitchFamily="34" charset="0"/>
               </a:rPr>
-              <a:t>Data science consultant with several decades of experience</a:t>
+              <a:t>Lead team that commercialized Bell Labs S, now opensource R</a:t>
             </a:r>
           </a:p>
           <a:p>
@@ -43810,7 +43957,7 @@
               <a:rPr lang="en-US" sz="2800" b="0" dirty="0">
                 <a:cs typeface="Arial" panose="020B0604020202020204" pitchFamily="34" charset="0"/>
               </a:rPr>
-              <a:t>Lead team that commercialized Bell Labs S, now open-source R</a:t>
+              <a:t>Company co-founder and held executive positions in several industries </a:t>
             </a:r>
           </a:p>
           <a:p>
@@ -43823,7 +43970,7 @@
               <a:rPr lang="en-US" sz="2800" b="0" dirty="0">
                 <a:cs typeface="Arial" panose="020B0604020202020204" pitchFamily="34" charset="0"/>
               </a:rPr>
-              <a:t>Company co-founder and held executive positions in several industries </a:t>
+              <a:t>Creator of multiple edX courses, author of books and articles </a:t>
             </a:r>
           </a:p>
           <a:p>
@@ -43833,10 +43980,28 @@
               </a:spcBef>
             </a:pPr>
             <a:r>
+              <a:rPr lang="en-US" dirty="0">
+                <a:cs typeface="Arial" panose="020B0604020202020204" pitchFamily="34" charset="0"/>
+              </a:rPr>
+              <a:t>Inventor on</a:t>
+            </a:r>
+            <a:r>
               <a:rPr lang="en-US" sz="2800" b="0" dirty="0">
                 <a:cs typeface="Arial" panose="020B0604020202020204" pitchFamily="34" charset="0"/>
               </a:rPr>
-              <a:t>Creator of multiple edX courses, author of books and articles </a:t>
+              <a:t> </a:t>
+            </a:r>
+            <a:r>
+              <a:rPr lang="en-US" dirty="0">
+                <a:cs typeface="Arial" panose="020B0604020202020204" pitchFamily="34" charset="0"/>
+              </a:rPr>
+              <a:t>5</a:t>
+            </a:r>
+            <a:r>
+              <a:rPr lang="en-US" sz="2800" b="0" dirty="0">
+                <a:cs typeface="Arial" panose="020B0604020202020204" pitchFamily="34" charset="0"/>
+              </a:rPr>
+              <a:t> patents</a:t>
             </a:r>
           </a:p>
           <a:p>
@@ -43849,7 +44014,7 @@
               <a:rPr lang="en-US" sz="2800" b="0" dirty="0">
                 <a:cs typeface="Arial" panose="020B0604020202020204" pitchFamily="34" charset="0"/>
               </a:rPr>
-              <a:t>Inventor/coinventor on 5 issued patents</a:t>
+              <a:t>BS, physics and math (minor), University of New Mexico</a:t>
             </a:r>
           </a:p>
           <a:p>
@@ -43862,7 +44027,7 @@
               <a:rPr lang="en-US" sz="2800" b="0" dirty="0">
                 <a:cs typeface="Arial" panose="020B0604020202020204" pitchFamily="34" charset="0"/>
               </a:rPr>
-              <a:t>Consulting clients include Microsoft, SAP, Lloyds Banking Group</a:t>
+              <a:t>MS and PhD, geophysics, Princeton University – John von Neuman Supercomputing Fellow</a:t>
             </a:r>
           </a:p>
           <a:p>
@@ -43872,32 +44037,6 @@
               </a:spcBef>
             </a:pPr>
             <a:r>
-              <a:rPr lang="en-US" sz="2800" b="0" dirty="0">
-                <a:cs typeface="Arial" panose="020B0604020202020204" pitchFamily="34" charset="0"/>
-              </a:rPr>
-              <a:t>BS, physics and math (minor), University of New Mexico</a:t>
-            </a:r>
-          </a:p>
-          <a:p>
-            <a:pPr>
-              <a:spcBef>
-                <a:spcPts val="300"/>
-              </a:spcBef>
-            </a:pPr>
-            <a:r>
-              <a:rPr lang="en-US" sz="2800" b="0" dirty="0">
-                <a:cs typeface="Arial" panose="020B0604020202020204" pitchFamily="34" charset="0"/>
-              </a:rPr>
-              <a:t>MS and PhD, geophysics, Princeton University – John von Neuman Supercomputing Fellow</a:t>
-            </a:r>
-          </a:p>
-          <a:p>
-            <a:pPr>
-              <a:spcBef>
-                <a:spcPts val="300"/>
-              </a:spcBef>
-            </a:pPr>
-            <a:r>
               <a:rPr lang="en-US" dirty="0">
                 <a:cs typeface="Arial" panose="020B0604020202020204" pitchFamily="34" charset="0"/>
               </a:rPr>
@@ -43909,10 +44048,40 @@
           </a:p>
         </p:txBody>
       </p:sp>
+      <p:pic>
+        <p:nvPicPr>
+          <p:cNvPr id="7" name="Picture 6">
+            <a:extLst>
+              <a:ext uri="{FF2B5EF4-FFF2-40B4-BE49-F238E27FC236}">
+                <a16:creationId xmlns:a16="http://schemas.microsoft.com/office/drawing/2014/main" id="{86C42CD4-C141-02EC-25C6-E3A4379847A3}"/>
+              </a:ext>
+            </a:extLst>
+          </p:cNvPr>
+          <p:cNvPicPr>
+            <a:picLocks noChangeAspect="1"/>
+          </p:cNvPicPr>
+          <p:nvPr/>
+        </p:nvPicPr>
+        <p:blipFill>
+          <a:blip r:embed="rId2"/>
+          <a:stretch>
+            <a:fillRect/>
+          </a:stretch>
+        </p:blipFill>
+        <p:spPr>
+          <a:xfrm>
+            <a:off x="8324238" y="446017"/>
+            <a:ext cx="3632018" cy="2982983"/>
+          </a:xfrm>
+          <a:prstGeom prst="rect">
+            <a:avLst/>
+          </a:prstGeom>
+        </p:spPr>
+      </p:pic>
     </p:spTree>
     <p:extLst>
       <p:ext uri="{BB962C8B-B14F-4D97-AF65-F5344CB8AC3E}">
-        <p14:creationId xmlns:p14="http://schemas.microsoft.com/office/powerpoint/2010/main" val="2505992720"/>
+        <p14:creationId xmlns:p14="http://schemas.microsoft.com/office/powerpoint/2010/main" val="1399518346"/>
       </p:ext>
     </p:extLst>
   </p:cSld>

</xml_diff>

<commit_message>
Minor updates and corrections
</commit_message>
<xml_diff>
--- a/slides/1_Introduction.pptx
+++ b/slides/1_Introduction.pptx
@@ -13300,13 +13300,8 @@
             </a:r>
             <a:r>
               <a:rPr lang="en-US" dirty="0"/>
-              <a:t>plus online discussion questions and projects for </a:t>
-            </a:r>
-            <a:r>
-              <a:rPr lang="en-US"/>
-              <a:t>graduate credit</a:t>
-            </a:r>
-            <a:endParaRPr lang="en-US" dirty="0"/>
+              <a:t>plus online discussion questions and projects for graduate credit</a:t>
+            </a:r>
           </a:p>
           <a:p>
             <a:r>
@@ -13805,8 +13800,12 @@
             <a:pPr lvl="1"/>
             <a:r>
               <a:rPr lang="en-US" dirty="0"/>
-              <a:t>Expect 9 assignments</a:t>
-            </a:r>
+              <a:t>Expect 8 assignments </a:t>
+            </a:r>
+            <a:br>
+              <a:rPr lang="en-US" dirty="0"/>
+            </a:br>
+            <a:endParaRPr lang="en-US" dirty="0"/>
           </a:p>
         </p:txBody>
       </p:sp>
@@ -20331,8 +20330,8 @@
           <a:chExt cx="0" cy="0"/>
         </a:xfrm>
       </p:grpSpPr>
-      <mc:AlternateContent xmlns:mc="http://schemas.openxmlformats.org/markup-compatibility/2006" xmlns:a14="http://schemas.microsoft.com/office/drawing/2010/main">
-        <mc:Choice Requires="a14">
+      <mc:AlternateContent xmlns:mc="http://schemas.openxmlformats.org/markup-compatibility/2006">
+        <mc:Choice xmlns:a14="http://schemas.microsoft.com/office/drawing/2010/main" Requires="a14">
           <p:sp>
             <p:nvSpPr>
               <p:cNvPr id="3" name="Content Placeholder 2">
@@ -20450,7 +20449,7 @@
               <a:p>
                 <a:r>
                   <a:rPr lang="en-US" dirty="0"/>
-                  <a:t>Key is a scalar, typically one of </a:t>
+                  <a:t>Key is typically a scalar, and one of </a:t>
                 </a:r>
               </a:p>
               <a:p>
@@ -20487,7 +20486,7 @@
             </p:txBody>
           </p:sp>
         </mc:Choice>
-        <mc:Fallback xmlns="">
+        <mc:Fallback>
           <p:sp>
             <p:nvSpPr>
               <p:cNvPr id="3" name="Content Placeholder 2">
@@ -21247,7 +21246,7 @@
                                         <p:tgtEl>
                                           <p:spTgt spid="3">
                                             <p:txEl>
-                                              <p:pRg st="1" end="1"/>
+                                              <p:pRg st="3" end="3"/>
                                             </p:txEl>
                                           </p:spTgt>
                                         </p:tgtEl>
@@ -21262,26 +21261,39 @@
                                   </p:childTnLst>
                                 </p:cTn>
                               </p:par>
-                            </p:childTnLst>
-                          </p:cTn>
-                        </p:par>
-                      </p:childTnLst>
-                    </p:cTn>
-                  </p:par>
-                  <p:par>
-                    <p:cTn id="7" fill="hold">
-                      <p:stCondLst>
-                        <p:cond delay="indefinite"/>
-                      </p:stCondLst>
-                      <p:childTnLst>
-                        <p:par>
-                          <p:cTn id="8" fill="hold">
-                            <p:stCondLst>
-                              <p:cond delay="0"/>
-                            </p:stCondLst>
-                            <p:childTnLst>
                               <p:par>
-                                <p:cTn id="9" presetID="1" presetClass="entr" presetSubtype="0" fill="hold" nodeType="clickEffect">
+                                <p:cTn id="7" presetID="1" presetClass="entr" presetSubtype="0" fill="hold" nodeType="withEffect">
+                                  <p:stCondLst>
+                                    <p:cond delay="0"/>
+                                  </p:stCondLst>
+                                  <p:childTnLst>
+                                    <p:set>
+                                      <p:cBhvr>
+                                        <p:cTn id="8" dur="1" fill="hold">
+                                          <p:stCondLst>
+                                            <p:cond delay="0"/>
+                                          </p:stCondLst>
+                                        </p:cTn>
+                                        <p:tgtEl>
+                                          <p:spTgt spid="3">
+                                            <p:txEl>
+                                              <p:pRg st="4" end="4"/>
+                                            </p:txEl>
+                                          </p:spTgt>
+                                        </p:tgtEl>
+                                        <p:attrNameLst>
+                                          <p:attrName>style.visibility</p:attrName>
+                                        </p:attrNameLst>
+                                      </p:cBhvr>
+                                      <p:to>
+                                        <p:strVal val="visible"/>
+                                      </p:to>
+                                    </p:set>
+                                  </p:childTnLst>
+                                </p:cTn>
+                              </p:par>
+                              <p:par>
+                                <p:cTn id="9" presetID="1" presetClass="entr" presetSubtype="0" fill="hold" nodeType="withEffect">
                                   <p:stCondLst>
                                     <p:cond delay="0"/>
                                   </p:stCondLst>
@@ -21296,7 +21308,7 @@
                                         <p:tgtEl>
                                           <p:spTgt spid="3">
                                             <p:txEl>
-                                              <p:pRg st="2" end="2"/>
+                                              <p:pRg st="5" end="5"/>
                                             </p:txEl>
                                           </p:spTgt>
                                         </p:tgtEl>
@@ -21311,26 +21323,39 @@
                                   </p:childTnLst>
                                 </p:cTn>
                               </p:par>
-                            </p:childTnLst>
-                          </p:cTn>
-                        </p:par>
-                      </p:childTnLst>
-                    </p:cTn>
-                  </p:par>
-                  <p:par>
-                    <p:cTn id="11" fill="hold">
-                      <p:stCondLst>
-                        <p:cond delay="indefinite"/>
-                      </p:stCondLst>
-                      <p:childTnLst>
-                        <p:par>
-                          <p:cTn id="12" fill="hold">
-                            <p:stCondLst>
-                              <p:cond delay="0"/>
-                            </p:stCondLst>
-                            <p:childTnLst>
                               <p:par>
-                                <p:cTn id="13" presetID="1" presetClass="entr" presetSubtype="0" fill="hold" nodeType="clickEffect">
+                                <p:cTn id="11" presetID="1" presetClass="entr" presetSubtype="0" fill="hold" nodeType="withEffect">
+                                  <p:stCondLst>
+                                    <p:cond delay="0"/>
+                                  </p:stCondLst>
+                                  <p:childTnLst>
+                                    <p:set>
+                                      <p:cBhvr>
+                                        <p:cTn id="12" dur="1" fill="hold">
+                                          <p:stCondLst>
+                                            <p:cond delay="0"/>
+                                          </p:stCondLst>
+                                        </p:cTn>
+                                        <p:tgtEl>
+                                          <p:spTgt spid="3">
+                                            <p:txEl>
+                                              <p:pRg st="6" end="6"/>
+                                            </p:txEl>
+                                          </p:spTgt>
+                                        </p:tgtEl>
+                                        <p:attrNameLst>
+                                          <p:attrName>style.visibility</p:attrName>
+                                        </p:attrNameLst>
+                                      </p:cBhvr>
+                                      <p:to>
+                                        <p:strVal val="visible"/>
+                                      </p:to>
+                                    </p:set>
+                                  </p:childTnLst>
+                                </p:cTn>
+                              </p:par>
+                              <p:par>
+                                <p:cTn id="13" presetID="1" presetClass="entr" presetSubtype="0" fill="hold" nodeType="withEffect">
                                   <p:stCondLst>
                                     <p:cond delay="0"/>
                                   </p:stCondLst>
@@ -21345,7 +21370,7 @@
                                         <p:tgtEl>
                                           <p:spTgt spid="3">
                                             <p:txEl>
-                                              <p:pRg st="3" end="3"/>
+                                              <p:pRg st="7" end="7"/>
                                             </p:txEl>
                                           </p:spTgt>
                                         </p:tgtEl>
@@ -21376,7 +21401,7 @@
                                         <p:tgtEl>
                                           <p:spTgt spid="3">
                                             <p:txEl>
-                                              <p:pRg st="4" end="4"/>
+                                              <p:pRg st="8" end="8"/>
                                             </p:txEl>
                                           </p:spTgt>
                                         </p:tgtEl>
@@ -21407,7 +21432,7 @@
                                         <p:tgtEl>
                                           <p:spTgt spid="3">
                                             <p:txEl>
-                                              <p:pRg st="5" end="5"/>
+                                              <p:pRg st="9" end="9"/>
                                             </p:txEl>
                                           </p:spTgt>
                                         </p:tgtEl>
@@ -21431,130 +21456,6 @@
                                     <p:set>
                                       <p:cBhvr>
                                         <p:cTn id="20" dur="1" fill="hold">
-                                          <p:stCondLst>
-                                            <p:cond delay="0"/>
-                                          </p:stCondLst>
-                                        </p:cTn>
-                                        <p:tgtEl>
-                                          <p:spTgt spid="3">
-                                            <p:txEl>
-                                              <p:pRg st="6" end="6"/>
-                                            </p:txEl>
-                                          </p:spTgt>
-                                        </p:tgtEl>
-                                        <p:attrNameLst>
-                                          <p:attrName>style.visibility</p:attrName>
-                                        </p:attrNameLst>
-                                      </p:cBhvr>
-                                      <p:to>
-                                        <p:strVal val="visible"/>
-                                      </p:to>
-                                    </p:set>
-                                  </p:childTnLst>
-                                </p:cTn>
-                              </p:par>
-                              <p:par>
-                                <p:cTn id="21" presetID="1" presetClass="entr" presetSubtype="0" fill="hold" nodeType="withEffect">
-                                  <p:stCondLst>
-                                    <p:cond delay="0"/>
-                                  </p:stCondLst>
-                                  <p:childTnLst>
-                                    <p:set>
-                                      <p:cBhvr>
-                                        <p:cTn id="22" dur="1" fill="hold">
-                                          <p:stCondLst>
-                                            <p:cond delay="0"/>
-                                          </p:stCondLst>
-                                        </p:cTn>
-                                        <p:tgtEl>
-                                          <p:spTgt spid="3">
-                                            <p:txEl>
-                                              <p:pRg st="7" end="7"/>
-                                            </p:txEl>
-                                          </p:spTgt>
-                                        </p:tgtEl>
-                                        <p:attrNameLst>
-                                          <p:attrName>style.visibility</p:attrName>
-                                        </p:attrNameLst>
-                                      </p:cBhvr>
-                                      <p:to>
-                                        <p:strVal val="visible"/>
-                                      </p:to>
-                                    </p:set>
-                                  </p:childTnLst>
-                                </p:cTn>
-                              </p:par>
-                              <p:par>
-                                <p:cTn id="23" presetID="1" presetClass="entr" presetSubtype="0" fill="hold" nodeType="withEffect">
-                                  <p:stCondLst>
-                                    <p:cond delay="0"/>
-                                  </p:stCondLst>
-                                  <p:childTnLst>
-                                    <p:set>
-                                      <p:cBhvr>
-                                        <p:cTn id="24" dur="1" fill="hold">
-                                          <p:stCondLst>
-                                            <p:cond delay="0"/>
-                                          </p:stCondLst>
-                                        </p:cTn>
-                                        <p:tgtEl>
-                                          <p:spTgt spid="3">
-                                            <p:txEl>
-                                              <p:pRg st="8" end="8"/>
-                                            </p:txEl>
-                                          </p:spTgt>
-                                        </p:tgtEl>
-                                        <p:attrNameLst>
-                                          <p:attrName>style.visibility</p:attrName>
-                                        </p:attrNameLst>
-                                      </p:cBhvr>
-                                      <p:to>
-                                        <p:strVal val="visible"/>
-                                      </p:to>
-                                    </p:set>
-                                  </p:childTnLst>
-                                </p:cTn>
-                              </p:par>
-                              <p:par>
-                                <p:cTn id="25" presetID="1" presetClass="entr" presetSubtype="0" fill="hold" nodeType="withEffect">
-                                  <p:stCondLst>
-                                    <p:cond delay="0"/>
-                                  </p:stCondLst>
-                                  <p:childTnLst>
-                                    <p:set>
-                                      <p:cBhvr>
-                                        <p:cTn id="26" dur="1" fill="hold">
-                                          <p:stCondLst>
-                                            <p:cond delay="0"/>
-                                          </p:stCondLst>
-                                        </p:cTn>
-                                        <p:tgtEl>
-                                          <p:spTgt spid="3">
-                                            <p:txEl>
-                                              <p:pRg st="9" end="9"/>
-                                            </p:txEl>
-                                          </p:spTgt>
-                                        </p:tgtEl>
-                                        <p:attrNameLst>
-                                          <p:attrName>style.visibility</p:attrName>
-                                        </p:attrNameLst>
-                                      </p:cBhvr>
-                                      <p:to>
-                                        <p:strVal val="visible"/>
-                                      </p:to>
-                                    </p:set>
-                                  </p:childTnLst>
-                                </p:cTn>
-                              </p:par>
-                              <p:par>
-                                <p:cTn id="27" presetID="1" presetClass="entr" presetSubtype="0" fill="hold" nodeType="withEffect">
-                                  <p:stCondLst>
-                                    <p:cond delay="0"/>
-                                  </p:stCondLst>
-                                  <p:childTnLst>
-                                    <p:set>
-                                      <p:cBhvr>
-                                        <p:cTn id="28" dur="1" fill="hold">
                                           <p:stCondLst>
                                             <p:cond delay="0"/>
                                           </p:stCondLst>
@@ -22796,7 +22697,10 @@
             </a:r>
           </a:p>
           <a:p>
-            <a:endParaRPr lang="en-US" dirty="0"/>
+            <a:r>
+              <a:rPr lang="en-US" dirty="0"/>
+              <a:t>…</a:t>
+            </a:r>
           </a:p>
           <a:p>
             <a:pPr marL="0" indent="0">
@@ -23154,6 +23058,55 @@
                                           <p:spTgt spid="3">
                                             <p:txEl>
                                               <p:pRg st="5" end="5"/>
+                                            </p:txEl>
+                                          </p:spTgt>
+                                        </p:tgtEl>
+                                        <p:attrNameLst>
+                                          <p:attrName>style.visibility</p:attrName>
+                                        </p:attrNameLst>
+                                      </p:cBhvr>
+                                      <p:to>
+                                        <p:strVal val="visible"/>
+                                      </p:to>
+                                    </p:set>
+                                  </p:childTnLst>
+                                </p:cTn>
+                              </p:par>
+                            </p:childTnLst>
+                          </p:cTn>
+                        </p:par>
+                      </p:childTnLst>
+                    </p:cTn>
+                  </p:par>
+                  <p:par>
+                    <p:cTn id="27" fill="hold">
+                      <p:stCondLst>
+                        <p:cond delay="indefinite"/>
+                      </p:stCondLst>
+                      <p:childTnLst>
+                        <p:par>
+                          <p:cTn id="28" fill="hold">
+                            <p:stCondLst>
+                              <p:cond delay="0"/>
+                            </p:stCondLst>
+                            <p:childTnLst>
+                              <p:par>
+                                <p:cTn id="29" presetID="1" presetClass="entr" presetSubtype="0" fill="hold" nodeType="clickEffect">
+                                  <p:stCondLst>
+                                    <p:cond delay="0"/>
+                                  </p:stCondLst>
+                                  <p:childTnLst>
+                                    <p:set>
+                                      <p:cBhvr>
+                                        <p:cTn id="30" dur="1" fill="hold">
+                                          <p:stCondLst>
+                                            <p:cond delay="0"/>
+                                          </p:stCondLst>
+                                        </p:cTn>
+                                        <p:tgtEl>
+                                          <p:spTgt spid="3">
+                                            <p:txEl>
+                                              <p:pRg st="6" end="6"/>
                                             </p:txEl>
                                           </p:spTgt>
                                         </p:tgtEl>
@@ -24419,8 +24372,8 @@
           </a:p>
         </p:txBody>
       </p:sp>
-      <mc:AlternateContent xmlns:mc="http://schemas.openxmlformats.org/markup-compatibility/2006" xmlns:a14="http://schemas.microsoft.com/office/drawing/2010/main">
-        <mc:Choice Requires="a14">
+      <mc:AlternateContent xmlns:mc="http://schemas.openxmlformats.org/markup-compatibility/2006">
+        <mc:Choice xmlns:a14="http://schemas.microsoft.com/office/drawing/2010/main" Requires="a14">
           <p:graphicFrame>
             <p:nvGraphicFramePr>
               <p:cNvPr id="2" name="Table 3">
@@ -24436,7 +24389,7 @@
               <p:nvPr>
                 <p:extLst>
                   <p:ext uri="{D42A27DB-BD31-4B8C-83A1-F6EECF244321}">
-                    <p14:modId xmlns:p14="http://schemas.microsoft.com/office/powerpoint/2010/main" val="3456537298"/>
+                    <p14:modId xmlns:p14="http://schemas.microsoft.com/office/powerpoint/2010/main" val="2628367177"/>
                   </p:ext>
                 </p:extLst>
               </p:nvPr>
@@ -26075,7 +26028,7 @@
             </a:graphic>
           </p:graphicFrame>
         </mc:Choice>
-        <mc:Fallback xmlns="">
+        <mc:Fallback>
           <p:graphicFrame>
             <p:nvGraphicFramePr>
               <p:cNvPr id="2" name="Table 3">
@@ -26091,7 +26044,7 @@
               <p:nvPr>
                 <p:extLst>
                   <p:ext uri="{D42A27DB-BD31-4B8C-83A1-F6EECF244321}">
-                    <p14:modId xmlns:p14="http://schemas.microsoft.com/office/powerpoint/2010/main" val="3456537298"/>
+                    <p14:modId xmlns:p14="http://schemas.microsoft.com/office/powerpoint/2010/main" val="2628367177"/>
                   </p:ext>
                 </p:extLst>
               </p:nvPr>
@@ -29877,26 +29830,35 @@
                                   </p:childTnLst>
                                 </p:cTn>
                               </p:par>
-                            </p:childTnLst>
-                          </p:cTn>
-                        </p:par>
-                      </p:childTnLst>
-                    </p:cTn>
-                  </p:par>
-                  <p:par>
-                    <p:cTn id="7" fill="hold">
-                      <p:stCondLst>
-                        <p:cond delay="indefinite"/>
-                      </p:stCondLst>
-                      <p:childTnLst>
-                        <p:par>
-                          <p:cTn id="8" fill="hold">
-                            <p:stCondLst>
-                              <p:cond delay="0"/>
-                            </p:stCondLst>
-                            <p:childTnLst>
                               <p:par>
-                                <p:cTn id="9" presetID="1" presetClass="entr" presetSubtype="0" fill="hold" nodeType="clickEffect">
+                                <p:cTn id="7" presetID="1" presetClass="entr" presetSubtype="0" fill="hold" nodeType="withEffect">
+                                  <p:stCondLst>
+                                    <p:cond delay="0"/>
+                                  </p:stCondLst>
+                                  <p:childTnLst>
+                                    <p:set>
+                                      <p:cBhvr>
+                                        <p:cTn id="8" dur="1" fill="hold">
+                                          <p:stCondLst>
+                                            <p:cond delay="0"/>
+                                          </p:stCondLst>
+                                        </p:cTn>
+                                        <p:tgtEl>
+                                          <p:spTgt spid="9"/>
+                                        </p:tgtEl>
+                                        <p:attrNameLst>
+                                          <p:attrName>style.visibility</p:attrName>
+                                        </p:attrNameLst>
+                                      </p:cBhvr>
+                                      <p:to>
+                                        <p:strVal val="visible"/>
+                                      </p:to>
+                                    </p:set>
+                                  </p:childTnLst>
+                                </p:cTn>
+                              </p:par>
+                              <p:par>
+                                <p:cTn id="9" presetID="1" presetClass="entr" presetSubtype="0" fill="hold" grpId="0" nodeType="withEffect">
                                   <p:stCondLst>
                                     <p:cond delay="0"/>
                                   </p:stCondLst>
@@ -29909,11 +29871,7 @@
                                           </p:stCondLst>
                                         </p:cTn>
                                         <p:tgtEl>
-                                          <p:spTgt spid="42">
-                                            <p:txEl>
-                                              <p:pRg st="1" end="1"/>
-                                            </p:txEl>
-                                          </p:spTgt>
+                                          <p:spTgt spid="40"/>
                                         </p:tgtEl>
                                         <p:attrNameLst>
                                           <p:attrName>style.visibility</p:attrName>
@@ -29960,6 +29918,514 @@
                                         <p:tgtEl>
                                           <p:spTgt spid="42">
                                             <p:txEl>
+                                              <p:pRg st="1" end="1"/>
+                                            </p:txEl>
+                                          </p:spTgt>
+                                        </p:tgtEl>
+                                        <p:attrNameLst>
+                                          <p:attrName>style.visibility</p:attrName>
+                                        </p:attrNameLst>
+                                      </p:cBhvr>
+                                      <p:to>
+                                        <p:strVal val="visible"/>
+                                      </p:to>
+                                    </p:set>
+                                  </p:childTnLst>
+                                </p:cTn>
+                              </p:par>
+                              <p:par>
+                                <p:cTn id="15" presetID="1" presetClass="entr" presetSubtype="0" fill="hold" grpId="0" nodeType="withEffect">
+                                  <p:stCondLst>
+                                    <p:cond delay="0"/>
+                                  </p:stCondLst>
+                                  <p:childTnLst>
+                                    <p:set>
+                                      <p:cBhvr>
+                                        <p:cTn id="16" dur="1" fill="hold">
+                                          <p:stCondLst>
+                                            <p:cond delay="0"/>
+                                          </p:stCondLst>
+                                        </p:cTn>
+                                        <p:tgtEl>
+                                          <p:spTgt spid="2"/>
+                                        </p:tgtEl>
+                                        <p:attrNameLst>
+                                          <p:attrName>style.visibility</p:attrName>
+                                        </p:attrNameLst>
+                                      </p:cBhvr>
+                                      <p:to>
+                                        <p:strVal val="visible"/>
+                                      </p:to>
+                                    </p:set>
+                                  </p:childTnLst>
+                                </p:cTn>
+                              </p:par>
+                              <p:par>
+                                <p:cTn id="17" presetID="1" presetClass="entr" presetSubtype="0" fill="hold" grpId="0" nodeType="withEffect">
+                                  <p:stCondLst>
+                                    <p:cond delay="0"/>
+                                  </p:stCondLst>
+                                  <p:childTnLst>
+                                    <p:set>
+                                      <p:cBhvr>
+                                        <p:cTn id="18" dur="1" fill="hold">
+                                          <p:stCondLst>
+                                            <p:cond delay="0"/>
+                                          </p:stCondLst>
+                                        </p:cTn>
+                                        <p:tgtEl>
+                                          <p:spTgt spid="5"/>
+                                        </p:tgtEl>
+                                        <p:attrNameLst>
+                                          <p:attrName>style.visibility</p:attrName>
+                                        </p:attrNameLst>
+                                      </p:cBhvr>
+                                      <p:to>
+                                        <p:strVal val="visible"/>
+                                      </p:to>
+                                    </p:set>
+                                  </p:childTnLst>
+                                </p:cTn>
+                              </p:par>
+                              <p:par>
+                                <p:cTn id="19" presetID="1" presetClass="entr" presetSubtype="0" fill="hold" grpId="0" nodeType="withEffect">
+                                  <p:stCondLst>
+                                    <p:cond delay="0"/>
+                                  </p:stCondLst>
+                                  <p:childTnLst>
+                                    <p:set>
+                                      <p:cBhvr>
+                                        <p:cTn id="20" dur="1" fill="hold">
+                                          <p:stCondLst>
+                                            <p:cond delay="0"/>
+                                          </p:stCondLst>
+                                        </p:cTn>
+                                        <p:tgtEl>
+                                          <p:spTgt spid="11"/>
+                                        </p:tgtEl>
+                                        <p:attrNameLst>
+                                          <p:attrName>style.visibility</p:attrName>
+                                        </p:attrNameLst>
+                                      </p:cBhvr>
+                                      <p:to>
+                                        <p:strVal val="visible"/>
+                                      </p:to>
+                                    </p:set>
+                                  </p:childTnLst>
+                                </p:cTn>
+                              </p:par>
+                              <p:par>
+                                <p:cTn id="21" presetID="1" presetClass="entr" presetSubtype="0" fill="hold" grpId="0" nodeType="withEffect">
+                                  <p:stCondLst>
+                                    <p:cond delay="0"/>
+                                  </p:stCondLst>
+                                  <p:childTnLst>
+                                    <p:set>
+                                      <p:cBhvr>
+                                        <p:cTn id="22" dur="1" fill="hold">
+                                          <p:stCondLst>
+                                            <p:cond delay="0"/>
+                                          </p:stCondLst>
+                                        </p:cTn>
+                                        <p:tgtEl>
+                                          <p:spTgt spid="12"/>
+                                        </p:tgtEl>
+                                        <p:attrNameLst>
+                                          <p:attrName>style.visibility</p:attrName>
+                                        </p:attrNameLst>
+                                      </p:cBhvr>
+                                      <p:to>
+                                        <p:strVal val="visible"/>
+                                      </p:to>
+                                    </p:set>
+                                  </p:childTnLst>
+                                </p:cTn>
+                              </p:par>
+                              <p:par>
+                                <p:cTn id="23" presetID="1" presetClass="entr" presetSubtype="0" fill="hold" grpId="0" nodeType="withEffect">
+                                  <p:stCondLst>
+                                    <p:cond delay="0"/>
+                                  </p:stCondLst>
+                                  <p:childTnLst>
+                                    <p:set>
+                                      <p:cBhvr>
+                                        <p:cTn id="24" dur="1" fill="hold">
+                                          <p:stCondLst>
+                                            <p:cond delay="0"/>
+                                          </p:stCondLst>
+                                        </p:cTn>
+                                        <p:tgtEl>
+                                          <p:spTgt spid="14"/>
+                                        </p:tgtEl>
+                                        <p:attrNameLst>
+                                          <p:attrName>style.visibility</p:attrName>
+                                        </p:attrNameLst>
+                                      </p:cBhvr>
+                                      <p:to>
+                                        <p:strVal val="visible"/>
+                                      </p:to>
+                                    </p:set>
+                                  </p:childTnLst>
+                                </p:cTn>
+                              </p:par>
+                              <p:par>
+                                <p:cTn id="25" presetID="1" presetClass="entr" presetSubtype="0" fill="hold" grpId="0" nodeType="withEffect">
+                                  <p:stCondLst>
+                                    <p:cond delay="0"/>
+                                  </p:stCondLst>
+                                  <p:childTnLst>
+                                    <p:set>
+                                      <p:cBhvr>
+                                        <p:cTn id="26" dur="1" fill="hold">
+                                          <p:stCondLst>
+                                            <p:cond delay="0"/>
+                                          </p:stCondLst>
+                                        </p:cTn>
+                                        <p:tgtEl>
+                                          <p:spTgt spid="15"/>
+                                        </p:tgtEl>
+                                        <p:attrNameLst>
+                                          <p:attrName>style.visibility</p:attrName>
+                                        </p:attrNameLst>
+                                      </p:cBhvr>
+                                      <p:to>
+                                        <p:strVal val="visible"/>
+                                      </p:to>
+                                    </p:set>
+                                  </p:childTnLst>
+                                </p:cTn>
+                              </p:par>
+                              <p:par>
+                                <p:cTn id="27" presetID="1" presetClass="entr" presetSubtype="0" fill="hold" grpId="0" nodeType="withEffect">
+                                  <p:stCondLst>
+                                    <p:cond delay="0"/>
+                                  </p:stCondLst>
+                                  <p:childTnLst>
+                                    <p:set>
+                                      <p:cBhvr>
+                                        <p:cTn id="28" dur="1" fill="hold">
+                                          <p:stCondLst>
+                                            <p:cond delay="0"/>
+                                          </p:stCondLst>
+                                        </p:cTn>
+                                        <p:tgtEl>
+                                          <p:spTgt spid="23"/>
+                                        </p:tgtEl>
+                                        <p:attrNameLst>
+                                          <p:attrName>style.visibility</p:attrName>
+                                        </p:attrNameLst>
+                                      </p:cBhvr>
+                                      <p:to>
+                                        <p:strVal val="visible"/>
+                                      </p:to>
+                                    </p:set>
+                                  </p:childTnLst>
+                                </p:cTn>
+                              </p:par>
+                              <p:par>
+                                <p:cTn id="29" presetID="1" presetClass="entr" presetSubtype="0" fill="hold" grpId="0" nodeType="withEffect">
+                                  <p:stCondLst>
+                                    <p:cond delay="0"/>
+                                  </p:stCondLst>
+                                  <p:childTnLst>
+                                    <p:set>
+                                      <p:cBhvr>
+                                        <p:cTn id="30" dur="1" fill="hold">
+                                          <p:stCondLst>
+                                            <p:cond delay="0"/>
+                                          </p:stCondLst>
+                                        </p:cTn>
+                                        <p:tgtEl>
+                                          <p:spTgt spid="24"/>
+                                        </p:tgtEl>
+                                        <p:attrNameLst>
+                                          <p:attrName>style.visibility</p:attrName>
+                                        </p:attrNameLst>
+                                      </p:cBhvr>
+                                      <p:to>
+                                        <p:strVal val="visible"/>
+                                      </p:to>
+                                    </p:set>
+                                  </p:childTnLst>
+                                </p:cTn>
+                              </p:par>
+                              <p:par>
+                                <p:cTn id="31" presetID="1" presetClass="entr" presetSubtype="0" fill="hold" grpId="0" nodeType="withEffect">
+                                  <p:stCondLst>
+                                    <p:cond delay="0"/>
+                                  </p:stCondLst>
+                                  <p:childTnLst>
+                                    <p:set>
+                                      <p:cBhvr>
+                                        <p:cTn id="32" dur="1" fill="hold">
+                                          <p:stCondLst>
+                                            <p:cond delay="0"/>
+                                          </p:stCondLst>
+                                        </p:cTn>
+                                        <p:tgtEl>
+                                          <p:spTgt spid="29"/>
+                                        </p:tgtEl>
+                                        <p:attrNameLst>
+                                          <p:attrName>style.visibility</p:attrName>
+                                        </p:attrNameLst>
+                                      </p:cBhvr>
+                                      <p:to>
+                                        <p:strVal val="visible"/>
+                                      </p:to>
+                                    </p:set>
+                                  </p:childTnLst>
+                                </p:cTn>
+                              </p:par>
+                              <p:par>
+                                <p:cTn id="33" presetID="1" presetClass="entr" presetSubtype="0" fill="hold" grpId="0" nodeType="withEffect">
+                                  <p:stCondLst>
+                                    <p:cond delay="0"/>
+                                  </p:stCondLst>
+                                  <p:childTnLst>
+                                    <p:set>
+                                      <p:cBhvr>
+                                        <p:cTn id="34" dur="1" fill="hold">
+                                          <p:stCondLst>
+                                            <p:cond delay="0"/>
+                                          </p:stCondLst>
+                                        </p:cTn>
+                                        <p:tgtEl>
+                                          <p:spTgt spid="30"/>
+                                        </p:tgtEl>
+                                        <p:attrNameLst>
+                                          <p:attrName>style.visibility</p:attrName>
+                                        </p:attrNameLst>
+                                      </p:cBhvr>
+                                      <p:to>
+                                        <p:strVal val="visible"/>
+                                      </p:to>
+                                    </p:set>
+                                  </p:childTnLst>
+                                </p:cTn>
+                              </p:par>
+                              <p:par>
+                                <p:cTn id="35" presetID="1" presetClass="entr" presetSubtype="0" fill="hold" grpId="0" nodeType="withEffect">
+                                  <p:stCondLst>
+                                    <p:cond delay="0"/>
+                                  </p:stCondLst>
+                                  <p:childTnLst>
+                                    <p:set>
+                                      <p:cBhvr>
+                                        <p:cTn id="36" dur="1" fill="hold">
+                                          <p:stCondLst>
+                                            <p:cond delay="0"/>
+                                          </p:stCondLst>
+                                        </p:cTn>
+                                        <p:tgtEl>
+                                          <p:spTgt spid="31"/>
+                                        </p:tgtEl>
+                                        <p:attrNameLst>
+                                          <p:attrName>style.visibility</p:attrName>
+                                        </p:attrNameLst>
+                                      </p:cBhvr>
+                                      <p:to>
+                                        <p:strVal val="visible"/>
+                                      </p:to>
+                                    </p:set>
+                                  </p:childTnLst>
+                                </p:cTn>
+                              </p:par>
+                              <p:par>
+                                <p:cTn id="37" presetID="1" presetClass="entr" presetSubtype="0" fill="hold" grpId="0" nodeType="withEffect">
+                                  <p:stCondLst>
+                                    <p:cond delay="0"/>
+                                  </p:stCondLst>
+                                  <p:childTnLst>
+                                    <p:set>
+                                      <p:cBhvr>
+                                        <p:cTn id="38" dur="1" fill="hold">
+                                          <p:stCondLst>
+                                            <p:cond delay="0"/>
+                                          </p:stCondLst>
+                                        </p:cTn>
+                                        <p:tgtEl>
+                                          <p:spTgt spid="32"/>
+                                        </p:tgtEl>
+                                        <p:attrNameLst>
+                                          <p:attrName>style.visibility</p:attrName>
+                                        </p:attrNameLst>
+                                      </p:cBhvr>
+                                      <p:to>
+                                        <p:strVal val="visible"/>
+                                      </p:to>
+                                    </p:set>
+                                  </p:childTnLst>
+                                </p:cTn>
+                              </p:par>
+                              <p:par>
+                                <p:cTn id="39" presetID="1" presetClass="entr" presetSubtype="0" fill="hold" grpId="0" nodeType="withEffect">
+                                  <p:stCondLst>
+                                    <p:cond delay="0"/>
+                                  </p:stCondLst>
+                                  <p:childTnLst>
+                                    <p:set>
+                                      <p:cBhvr>
+                                        <p:cTn id="40" dur="1" fill="hold">
+                                          <p:stCondLst>
+                                            <p:cond delay="0"/>
+                                          </p:stCondLst>
+                                        </p:cTn>
+                                        <p:tgtEl>
+                                          <p:spTgt spid="33"/>
+                                        </p:tgtEl>
+                                        <p:attrNameLst>
+                                          <p:attrName>style.visibility</p:attrName>
+                                        </p:attrNameLst>
+                                      </p:cBhvr>
+                                      <p:to>
+                                        <p:strVal val="visible"/>
+                                      </p:to>
+                                    </p:set>
+                                  </p:childTnLst>
+                                </p:cTn>
+                              </p:par>
+                              <p:par>
+                                <p:cTn id="41" presetID="1" presetClass="entr" presetSubtype="0" fill="hold" grpId="0" nodeType="withEffect">
+                                  <p:stCondLst>
+                                    <p:cond delay="0"/>
+                                  </p:stCondLst>
+                                  <p:childTnLst>
+                                    <p:set>
+                                      <p:cBhvr>
+                                        <p:cTn id="42" dur="1" fill="hold">
+                                          <p:stCondLst>
+                                            <p:cond delay="0"/>
+                                          </p:stCondLst>
+                                        </p:cTn>
+                                        <p:tgtEl>
+                                          <p:spTgt spid="36"/>
+                                        </p:tgtEl>
+                                        <p:attrNameLst>
+                                          <p:attrName>style.visibility</p:attrName>
+                                        </p:attrNameLst>
+                                      </p:cBhvr>
+                                      <p:to>
+                                        <p:strVal val="visible"/>
+                                      </p:to>
+                                    </p:set>
+                                  </p:childTnLst>
+                                </p:cTn>
+                              </p:par>
+                              <p:par>
+                                <p:cTn id="43" presetID="1" presetClass="entr" presetSubtype="0" fill="hold" grpId="0" nodeType="withEffect">
+                                  <p:stCondLst>
+                                    <p:cond delay="0"/>
+                                  </p:stCondLst>
+                                  <p:childTnLst>
+                                    <p:set>
+                                      <p:cBhvr>
+                                        <p:cTn id="44" dur="1" fill="hold">
+                                          <p:stCondLst>
+                                            <p:cond delay="0"/>
+                                          </p:stCondLst>
+                                        </p:cTn>
+                                        <p:tgtEl>
+                                          <p:spTgt spid="37"/>
+                                        </p:tgtEl>
+                                        <p:attrNameLst>
+                                          <p:attrName>style.visibility</p:attrName>
+                                        </p:attrNameLst>
+                                      </p:cBhvr>
+                                      <p:to>
+                                        <p:strVal val="visible"/>
+                                      </p:to>
+                                    </p:set>
+                                  </p:childTnLst>
+                                </p:cTn>
+                              </p:par>
+                              <p:par>
+                                <p:cTn id="45" presetID="1" presetClass="entr" presetSubtype="0" fill="hold" grpId="0" nodeType="withEffect">
+                                  <p:stCondLst>
+                                    <p:cond delay="0"/>
+                                  </p:stCondLst>
+                                  <p:childTnLst>
+                                    <p:set>
+                                      <p:cBhvr>
+                                        <p:cTn id="46" dur="1" fill="hold">
+                                          <p:stCondLst>
+                                            <p:cond delay="0"/>
+                                          </p:stCondLst>
+                                        </p:cTn>
+                                        <p:tgtEl>
+                                          <p:spTgt spid="38"/>
+                                        </p:tgtEl>
+                                        <p:attrNameLst>
+                                          <p:attrName>style.visibility</p:attrName>
+                                        </p:attrNameLst>
+                                      </p:cBhvr>
+                                      <p:to>
+                                        <p:strVal val="visible"/>
+                                      </p:to>
+                                    </p:set>
+                                  </p:childTnLst>
+                                </p:cTn>
+                              </p:par>
+                              <p:par>
+                                <p:cTn id="47" presetID="1" presetClass="entr" presetSubtype="0" fill="hold" grpId="0" nodeType="withEffect">
+                                  <p:stCondLst>
+                                    <p:cond delay="0"/>
+                                  </p:stCondLst>
+                                  <p:childTnLst>
+                                    <p:set>
+                                      <p:cBhvr>
+                                        <p:cTn id="48" dur="1" fill="hold">
+                                          <p:stCondLst>
+                                            <p:cond delay="0"/>
+                                          </p:stCondLst>
+                                        </p:cTn>
+                                        <p:tgtEl>
+                                          <p:spTgt spid="41"/>
+                                        </p:tgtEl>
+                                        <p:attrNameLst>
+                                          <p:attrName>style.visibility</p:attrName>
+                                        </p:attrNameLst>
+                                      </p:cBhvr>
+                                      <p:to>
+                                        <p:strVal val="visible"/>
+                                      </p:to>
+                                    </p:set>
+                                  </p:childTnLst>
+                                </p:cTn>
+                              </p:par>
+                            </p:childTnLst>
+                          </p:cTn>
+                        </p:par>
+                      </p:childTnLst>
+                    </p:cTn>
+                  </p:par>
+                  <p:par>
+                    <p:cTn id="49" fill="hold">
+                      <p:stCondLst>
+                        <p:cond delay="indefinite"/>
+                      </p:stCondLst>
+                      <p:childTnLst>
+                        <p:par>
+                          <p:cTn id="50" fill="hold">
+                            <p:stCondLst>
+                              <p:cond delay="0"/>
+                            </p:stCondLst>
+                            <p:childTnLst>
+                              <p:par>
+                                <p:cTn id="51" presetID="1" presetClass="entr" presetSubtype="0" fill="hold" nodeType="clickEffect">
+                                  <p:stCondLst>
+                                    <p:cond delay="0"/>
+                                  </p:stCondLst>
+                                  <p:childTnLst>
+                                    <p:set>
+                                      <p:cBhvr>
+                                        <p:cTn id="52" dur="1" fill="hold">
+                                          <p:stCondLst>
+                                            <p:cond delay="0"/>
+                                          </p:stCondLst>
+                                        </p:cTn>
+                                        <p:tgtEl>
+                                          <p:spTgt spid="42">
+                                            <p:txEl>
                                               <p:pRg st="2" end="2"/>
                                             </p:txEl>
                                           </p:spTgt>
@@ -29982,26 +30448,26 @@
                     </p:cTn>
                   </p:par>
                   <p:par>
-                    <p:cTn id="15" fill="hold">
+                    <p:cTn id="53" fill="hold">
                       <p:stCondLst>
                         <p:cond delay="indefinite"/>
                       </p:stCondLst>
                       <p:childTnLst>
                         <p:par>
-                          <p:cTn id="16" fill="hold">
+                          <p:cTn id="54" fill="hold">
                             <p:stCondLst>
                               <p:cond delay="0"/>
                             </p:stCondLst>
                             <p:childTnLst>
                               <p:par>
-                                <p:cTn id="17" presetID="1" presetClass="entr" presetSubtype="0" fill="hold" nodeType="clickEffect">
+                                <p:cTn id="55" presetID="1" presetClass="entr" presetSubtype="0" fill="hold" nodeType="clickEffect">
                                   <p:stCondLst>
                                     <p:cond delay="0"/>
                                   </p:stCondLst>
                                   <p:childTnLst>
                                     <p:set>
                                       <p:cBhvr>
-                                        <p:cTn id="18" dur="1" fill="hold">
+                                        <p:cTn id="56" dur="1" fill="hold">
                                           <p:stCondLst>
                                             <p:cond delay="0"/>
                                           </p:stCondLst>
@@ -30024,6 +30490,87 @@
                                   </p:childTnLst>
                                 </p:cTn>
                               </p:par>
+                              <p:par>
+                                <p:cTn id="57" presetID="1" presetClass="entr" presetSubtype="0" fill="hold" grpId="0" nodeType="withEffect">
+                                  <p:stCondLst>
+                                    <p:cond delay="0"/>
+                                  </p:stCondLst>
+                                  <p:childTnLst>
+                                    <p:set>
+                                      <p:cBhvr>
+                                        <p:cTn id="58" dur="1" fill="hold">
+                                          <p:stCondLst>
+                                            <p:cond delay="0"/>
+                                          </p:stCondLst>
+                                        </p:cTn>
+                                        <p:tgtEl>
+                                          <p:spTgt spid="16"/>
+                                        </p:tgtEl>
+                                        <p:attrNameLst>
+                                          <p:attrName>style.visibility</p:attrName>
+                                        </p:attrNameLst>
+                                      </p:cBhvr>
+                                      <p:to>
+                                        <p:strVal val="visible"/>
+                                      </p:to>
+                                    </p:set>
+                                  </p:childTnLst>
+                                </p:cTn>
+                              </p:par>
+                              <p:par>
+                                <p:cTn id="59" presetID="1" presetClass="entr" presetSubtype="0" fill="hold" nodeType="withEffect">
+                                  <p:stCondLst>
+                                    <p:cond delay="0"/>
+                                  </p:stCondLst>
+                                  <p:childTnLst>
+                                    <p:set>
+                                      <p:cBhvr>
+                                        <p:cTn id="60" dur="1" fill="hold">
+                                          <p:stCondLst>
+                                            <p:cond delay="0"/>
+                                          </p:stCondLst>
+                                        </p:cTn>
+                                        <p:tgtEl>
+                                          <p:spTgt spid="10"/>
+                                        </p:tgtEl>
+                                        <p:attrNameLst>
+                                          <p:attrName>style.visibility</p:attrName>
+                                        </p:attrNameLst>
+                                      </p:cBhvr>
+                                      <p:to>
+                                        <p:strVal val="visible"/>
+                                      </p:to>
+                                    </p:set>
+                                  </p:childTnLst>
+                                </p:cTn>
+                              </p:par>
+                              <p:par>
+                                <p:cTn id="61" presetID="1" presetClass="entr" presetSubtype="0" fill="hold" nodeType="withEffect">
+                                  <p:stCondLst>
+                                    <p:cond delay="0"/>
+                                  </p:stCondLst>
+                                  <p:childTnLst>
+                                    <p:set>
+                                      <p:cBhvr>
+                                        <p:cTn id="62" dur="1" fill="hold">
+                                          <p:stCondLst>
+                                            <p:cond delay="0"/>
+                                          </p:stCondLst>
+                                        </p:cTn>
+                                        <p:tgtEl>
+                                          <p:spTgt spid="34"/>
+                                        </p:tgtEl>
+                                        <p:attrNameLst>
+                                          <p:attrName>style.visibility</p:attrName>
+                                        </p:attrNameLst>
+                                      </p:cBhvr>
+                                      <p:to>
+                                        <p:strVal val="visible"/>
+                                      </p:to>
+                                    </p:set>
+                                  </p:childTnLst>
+                                </p:cTn>
+                              </p:par>
                             </p:childTnLst>
                           </p:cTn>
                         </p:par>
@@ -30031,26 +30578,26 @@
                     </p:cTn>
                   </p:par>
                   <p:par>
-                    <p:cTn id="19" fill="hold">
+                    <p:cTn id="63" fill="hold">
                       <p:stCondLst>
                         <p:cond delay="indefinite"/>
                       </p:stCondLst>
                       <p:childTnLst>
                         <p:par>
-                          <p:cTn id="20" fill="hold">
+                          <p:cTn id="64" fill="hold">
                             <p:stCondLst>
                               <p:cond delay="0"/>
                             </p:stCondLst>
                             <p:childTnLst>
                               <p:par>
-                                <p:cTn id="21" presetID="1" presetClass="entr" presetSubtype="0" fill="hold" nodeType="clickEffect">
+                                <p:cTn id="65" presetID="1" presetClass="entr" presetSubtype="0" fill="hold" nodeType="clickEffect">
                                   <p:stCondLst>
                                     <p:cond delay="0"/>
                                   </p:stCondLst>
                                   <p:childTnLst>
                                     <p:set>
                                       <p:cBhvr>
-                                        <p:cTn id="22" dur="1" fill="hold">
+                                        <p:cTn id="66" dur="1" fill="hold">
                                           <p:stCondLst>
                                             <p:cond delay="0"/>
                                           </p:stCondLst>
@@ -30080,26 +30627,26 @@
                     </p:cTn>
                   </p:par>
                   <p:par>
-                    <p:cTn id="23" fill="hold">
+                    <p:cTn id="67" fill="hold">
                       <p:stCondLst>
                         <p:cond delay="indefinite"/>
                       </p:stCondLst>
                       <p:childTnLst>
                         <p:par>
-                          <p:cTn id="24" fill="hold">
+                          <p:cTn id="68" fill="hold">
                             <p:stCondLst>
                               <p:cond delay="0"/>
                             </p:stCondLst>
                             <p:childTnLst>
                               <p:par>
-                                <p:cTn id="25" presetID="1" presetClass="entr" presetSubtype="0" fill="hold" nodeType="clickEffect">
+                                <p:cTn id="69" presetID="1" presetClass="entr" presetSubtype="0" fill="hold" nodeType="clickEffect">
                                   <p:stCondLst>
                                     <p:cond delay="0"/>
                                   </p:stCondLst>
                                   <p:childTnLst>
                                     <p:set>
                                       <p:cBhvr>
-                                        <p:cTn id="26" dur="1" fill="hold">
+                                        <p:cTn id="70" dur="1" fill="hold">
                                           <p:stCondLst>
                                             <p:cond delay="0"/>
                                           </p:stCondLst>
@@ -30129,617 +30676,19 @@
                     </p:cTn>
                   </p:par>
                   <p:par>
-                    <p:cTn id="27" fill="hold">
+                    <p:cTn id="71" fill="hold">
                       <p:stCondLst>
                         <p:cond delay="indefinite"/>
                       </p:stCondLst>
                       <p:childTnLst>
                         <p:par>
-                          <p:cTn id="28" fill="hold">
+                          <p:cTn id="72" fill="hold">
                             <p:stCondLst>
                               <p:cond delay="0"/>
                             </p:stCondLst>
                             <p:childTnLst>
                               <p:par>
-                                <p:cTn id="29" presetID="1" presetClass="entr" presetSubtype="0" fill="hold" nodeType="clickEffect">
-                                  <p:stCondLst>
-                                    <p:cond delay="0"/>
-                                  </p:stCondLst>
-                                  <p:childTnLst>
-                                    <p:set>
-                                      <p:cBhvr>
-                                        <p:cTn id="30" dur="1" fill="hold">
-                                          <p:stCondLst>
-                                            <p:cond delay="0"/>
-                                          </p:stCondLst>
-                                        </p:cTn>
-                                        <p:tgtEl>
-                                          <p:spTgt spid="42">
-                                            <p:txEl>
-                                              <p:pRg st="6" end="6"/>
-                                            </p:txEl>
-                                          </p:spTgt>
-                                        </p:tgtEl>
-                                        <p:attrNameLst>
-                                          <p:attrName>style.visibility</p:attrName>
-                                        </p:attrNameLst>
-                                      </p:cBhvr>
-                                      <p:to>
-                                        <p:strVal val="visible"/>
-                                      </p:to>
-                                    </p:set>
-                                  </p:childTnLst>
-                                </p:cTn>
-                              </p:par>
-                              <p:par>
-                                <p:cTn id="31" presetID="1" presetClass="entr" presetSubtype="0" fill="hold" nodeType="withEffect">
-                                  <p:stCondLst>
-                                    <p:cond delay="0"/>
-                                  </p:stCondLst>
-                                  <p:childTnLst>
-                                    <p:set>
-                                      <p:cBhvr>
-                                        <p:cTn id="32" dur="1" fill="hold">
-                                          <p:stCondLst>
-                                            <p:cond delay="0"/>
-                                          </p:stCondLst>
-                                        </p:cTn>
-                                        <p:tgtEl>
-                                          <p:spTgt spid="9"/>
-                                        </p:tgtEl>
-                                        <p:attrNameLst>
-                                          <p:attrName>style.visibility</p:attrName>
-                                        </p:attrNameLst>
-                                      </p:cBhvr>
-                                      <p:to>
-                                        <p:strVal val="visible"/>
-                                      </p:to>
-                                    </p:set>
-                                  </p:childTnLst>
-                                </p:cTn>
-                              </p:par>
-                              <p:par>
-                                <p:cTn id="33" presetID="1" presetClass="entr" presetSubtype="0" fill="hold" grpId="0" nodeType="withEffect">
-                                  <p:stCondLst>
-                                    <p:cond delay="0"/>
-                                  </p:stCondLst>
-                                  <p:childTnLst>
-                                    <p:set>
-                                      <p:cBhvr>
-                                        <p:cTn id="34" dur="1" fill="hold">
-                                          <p:stCondLst>
-                                            <p:cond delay="0"/>
-                                          </p:stCondLst>
-                                        </p:cTn>
-                                        <p:tgtEl>
-                                          <p:spTgt spid="40"/>
-                                        </p:tgtEl>
-                                        <p:attrNameLst>
-                                          <p:attrName>style.visibility</p:attrName>
-                                        </p:attrNameLst>
-                                      </p:cBhvr>
-                                      <p:to>
-                                        <p:strVal val="visible"/>
-                                      </p:to>
-                                    </p:set>
-                                  </p:childTnLst>
-                                </p:cTn>
-                              </p:par>
-                              <p:par>
-                                <p:cTn id="35" presetID="1" presetClass="entr" presetSubtype="0" fill="hold" grpId="0" nodeType="withEffect">
-                                  <p:stCondLst>
-                                    <p:cond delay="0"/>
-                                  </p:stCondLst>
-                                  <p:childTnLst>
-                                    <p:set>
-                                      <p:cBhvr>
-                                        <p:cTn id="36" dur="1" fill="hold">
-                                          <p:stCondLst>
-                                            <p:cond delay="0"/>
-                                          </p:stCondLst>
-                                        </p:cTn>
-                                        <p:tgtEl>
-                                          <p:spTgt spid="23"/>
-                                        </p:tgtEl>
-                                        <p:attrNameLst>
-                                          <p:attrName>style.visibility</p:attrName>
-                                        </p:attrNameLst>
-                                      </p:cBhvr>
-                                      <p:to>
-                                        <p:strVal val="visible"/>
-                                      </p:to>
-                                    </p:set>
-                                  </p:childTnLst>
-                                </p:cTn>
-                              </p:par>
-                              <p:par>
-                                <p:cTn id="37" presetID="1" presetClass="entr" presetSubtype="0" fill="hold" grpId="0" nodeType="withEffect">
-                                  <p:stCondLst>
-                                    <p:cond delay="0"/>
-                                  </p:stCondLst>
-                                  <p:childTnLst>
-                                    <p:set>
-                                      <p:cBhvr>
-                                        <p:cTn id="38" dur="1" fill="hold">
-                                          <p:stCondLst>
-                                            <p:cond delay="0"/>
-                                          </p:stCondLst>
-                                        </p:cTn>
-                                        <p:tgtEl>
-                                          <p:spTgt spid="2"/>
-                                        </p:tgtEl>
-                                        <p:attrNameLst>
-                                          <p:attrName>style.visibility</p:attrName>
-                                        </p:attrNameLst>
-                                      </p:cBhvr>
-                                      <p:to>
-                                        <p:strVal val="visible"/>
-                                      </p:to>
-                                    </p:set>
-                                  </p:childTnLst>
-                                </p:cTn>
-                              </p:par>
-                              <p:par>
-                                <p:cTn id="39" presetID="1" presetClass="entr" presetSubtype="0" fill="hold" grpId="0" nodeType="withEffect">
-                                  <p:stCondLst>
-                                    <p:cond delay="0"/>
-                                  </p:stCondLst>
-                                  <p:childTnLst>
-                                    <p:set>
-                                      <p:cBhvr>
-                                        <p:cTn id="40" dur="1" fill="hold">
-                                          <p:stCondLst>
-                                            <p:cond delay="0"/>
-                                          </p:stCondLst>
-                                        </p:cTn>
-                                        <p:tgtEl>
-                                          <p:spTgt spid="5"/>
-                                        </p:tgtEl>
-                                        <p:attrNameLst>
-                                          <p:attrName>style.visibility</p:attrName>
-                                        </p:attrNameLst>
-                                      </p:cBhvr>
-                                      <p:to>
-                                        <p:strVal val="visible"/>
-                                      </p:to>
-                                    </p:set>
-                                  </p:childTnLst>
-                                </p:cTn>
-                              </p:par>
-                              <p:par>
-                                <p:cTn id="41" presetID="1" presetClass="entr" presetSubtype="0" fill="hold" grpId="0" nodeType="withEffect">
-                                  <p:stCondLst>
-                                    <p:cond delay="0"/>
-                                  </p:stCondLst>
-                                  <p:childTnLst>
-                                    <p:set>
-                                      <p:cBhvr>
-                                        <p:cTn id="42" dur="1" fill="hold">
-                                          <p:stCondLst>
-                                            <p:cond delay="0"/>
-                                          </p:stCondLst>
-                                        </p:cTn>
-                                        <p:tgtEl>
-                                          <p:spTgt spid="11"/>
-                                        </p:tgtEl>
-                                        <p:attrNameLst>
-                                          <p:attrName>style.visibility</p:attrName>
-                                        </p:attrNameLst>
-                                      </p:cBhvr>
-                                      <p:to>
-                                        <p:strVal val="visible"/>
-                                      </p:to>
-                                    </p:set>
-                                  </p:childTnLst>
-                                </p:cTn>
-                              </p:par>
-                              <p:par>
-                                <p:cTn id="43" presetID="1" presetClass="entr" presetSubtype="0" fill="hold" grpId="0" nodeType="withEffect">
-                                  <p:stCondLst>
-                                    <p:cond delay="0"/>
-                                  </p:stCondLst>
-                                  <p:childTnLst>
-                                    <p:set>
-                                      <p:cBhvr>
-                                        <p:cTn id="44" dur="1" fill="hold">
-                                          <p:stCondLst>
-                                            <p:cond delay="0"/>
-                                          </p:stCondLst>
-                                        </p:cTn>
-                                        <p:tgtEl>
-                                          <p:spTgt spid="12"/>
-                                        </p:tgtEl>
-                                        <p:attrNameLst>
-                                          <p:attrName>style.visibility</p:attrName>
-                                        </p:attrNameLst>
-                                      </p:cBhvr>
-                                      <p:to>
-                                        <p:strVal val="visible"/>
-                                      </p:to>
-                                    </p:set>
-                                  </p:childTnLst>
-                                </p:cTn>
-                              </p:par>
-                              <p:par>
-                                <p:cTn id="45" presetID="1" presetClass="entr" presetSubtype="0" fill="hold" grpId="0" nodeType="withEffect">
-                                  <p:stCondLst>
-                                    <p:cond delay="0"/>
-                                  </p:stCondLst>
-                                  <p:childTnLst>
-                                    <p:set>
-                                      <p:cBhvr>
-                                        <p:cTn id="46" dur="1" fill="hold">
-                                          <p:stCondLst>
-                                            <p:cond delay="0"/>
-                                          </p:stCondLst>
-                                        </p:cTn>
-                                        <p:tgtEl>
-                                          <p:spTgt spid="14"/>
-                                        </p:tgtEl>
-                                        <p:attrNameLst>
-                                          <p:attrName>style.visibility</p:attrName>
-                                        </p:attrNameLst>
-                                      </p:cBhvr>
-                                      <p:to>
-                                        <p:strVal val="visible"/>
-                                      </p:to>
-                                    </p:set>
-                                  </p:childTnLst>
-                                </p:cTn>
-                              </p:par>
-                              <p:par>
-                                <p:cTn id="47" presetID="1" presetClass="entr" presetSubtype="0" fill="hold" grpId="0" nodeType="withEffect">
-                                  <p:stCondLst>
-                                    <p:cond delay="0"/>
-                                  </p:stCondLst>
-                                  <p:childTnLst>
-                                    <p:set>
-                                      <p:cBhvr>
-                                        <p:cTn id="48" dur="1" fill="hold">
-                                          <p:stCondLst>
-                                            <p:cond delay="0"/>
-                                          </p:stCondLst>
-                                        </p:cTn>
-                                        <p:tgtEl>
-                                          <p:spTgt spid="15"/>
-                                        </p:tgtEl>
-                                        <p:attrNameLst>
-                                          <p:attrName>style.visibility</p:attrName>
-                                        </p:attrNameLst>
-                                      </p:cBhvr>
-                                      <p:to>
-                                        <p:strVal val="visible"/>
-                                      </p:to>
-                                    </p:set>
-                                  </p:childTnLst>
-                                </p:cTn>
-                              </p:par>
-                              <p:par>
-                                <p:cTn id="49" presetID="1" presetClass="entr" presetSubtype="0" fill="hold" grpId="0" nodeType="withEffect">
-                                  <p:stCondLst>
-                                    <p:cond delay="0"/>
-                                  </p:stCondLst>
-                                  <p:childTnLst>
-                                    <p:set>
-                                      <p:cBhvr>
-                                        <p:cTn id="50" dur="1" fill="hold">
-                                          <p:stCondLst>
-                                            <p:cond delay="0"/>
-                                          </p:stCondLst>
-                                        </p:cTn>
-                                        <p:tgtEl>
-                                          <p:spTgt spid="24"/>
-                                        </p:tgtEl>
-                                        <p:attrNameLst>
-                                          <p:attrName>style.visibility</p:attrName>
-                                        </p:attrNameLst>
-                                      </p:cBhvr>
-                                      <p:to>
-                                        <p:strVal val="visible"/>
-                                      </p:to>
-                                    </p:set>
-                                  </p:childTnLst>
-                                </p:cTn>
-                              </p:par>
-                              <p:par>
-                                <p:cTn id="51" presetID="1" presetClass="entr" presetSubtype="0" fill="hold" grpId="0" nodeType="withEffect">
-                                  <p:stCondLst>
-                                    <p:cond delay="0"/>
-                                  </p:stCondLst>
-                                  <p:childTnLst>
-                                    <p:set>
-                                      <p:cBhvr>
-                                        <p:cTn id="52" dur="1" fill="hold">
-                                          <p:stCondLst>
-                                            <p:cond delay="0"/>
-                                          </p:stCondLst>
-                                        </p:cTn>
-                                        <p:tgtEl>
-                                          <p:spTgt spid="29"/>
-                                        </p:tgtEl>
-                                        <p:attrNameLst>
-                                          <p:attrName>style.visibility</p:attrName>
-                                        </p:attrNameLst>
-                                      </p:cBhvr>
-                                      <p:to>
-                                        <p:strVal val="visible"/>
-                                      </p:to>
-                                    </p:set>
-                                  </p:childTnLst>
-                                </p:cTn>
-                              </p:par>
-                              <p:par>
-                                <p:cTn id="53" presetID="1" presetClass="entr" presetSubtype="0" fill="hold" grpId="0" nodeType="withEffect">
-                                  <p:stCondLst>
-                                    <p:cond delay="0"/>
-                                  </p:stCondLst>
-                                  <p:childTnLst>
-                                    <p:set>
-                                      <p:cBhvr>
-                                        <p:cTn id="54" dur="1" fill="hold">
-                                          <p:stCondLst>
-                                            <p:cond delay="0"/>
-                                          </p:stCondLst>
-                                        </p:cTn>
-                                        <p:tgtEl>
-                                          <p:spTgt spid="30"/>
-                                        </p:tgtEl>
-                                        <p:attrNameLst>
-                                          <p:attrName>style.visibility</p:attrName>
-                                        </p:attrNameLst>
-                                      </p:cBhvr>
-                                      <p:to>
-                                        <p:strVal val="visible"/>
-                                      </p:to>
-                                    </p:set>
-                                  </p:childTnLst>
-                                </p:cTn>
-                              </p:par>
-                              <p:par>
-                                <p:cTn id="55" presetID="1" presetClass="entr" presetSubtype="0" fill="hold" grpId="0" nodeType="withEffect">
-                                  <p:stCondLst>
-                                    <p:cond delay="0"/>
-                                  </p:stCondLst>
-                                  <p:childTnLst>
-                                    <p:set>
-                                      <p:cBhvr>
-                                        <p:cTn id="56" dur="1" fill="hold">
-                                          <p:stCondLst>
-                                            <p:cond delay="0"/>
-                                          </p:stCondLst>
-                                        </p:cTn>
-                                        <p:tgtEl>
-                                          <p:spTgt spid="31"/>
-                                        </p:tgtEl>
-                                        <p:attrNameLst>
-                                          <p:attrName>style.visibility</p:attrName>
-                                        </p:attrNameLst>
-                                      </p:cBhvr>
-                                      <p:to>
-                                        <p:strVal val="visible"/>
-                                      </p:to>
-                                    </p:set>
-                                  </p:childTnLst>
-                                </p:cTn>
-                              </p:par>
-                              <p:par>
-                                <p:cTn id="57" presetID="1" presetClass="entr" presetSubtype="0" fill="hold" grpId="0" nodeType="withEffect">
-                                  <p:stCondLst>
-                                    <p:cond delay="0"/>
-                                  </p:stCondLst>
-                                  <p:childTnLst>
-                                    <p:set>
-                                      <p:cBhvr>
-                                        <p:cTn id="58" dur="1" fill="hold">
-                                          <p:stCondLst>
-                                            <p:cond delay="0"/>
-                                          </p:stCondLst>
-                                        </p:cTn>
-                                        <p:tgtEl>
-                                          <p:spTgt spid="32"/>
-                                        </p:tgtEl>
-                                        <p:attrNameLst>
-                                          <p:attrName>style.visibility</p:attrName>
-                                        </p:attrNameLst>
-                                      </p:cBhvr>
-                                      <p:to>
-                                        <p:strVal val="visible"/>
-                                      </p:to>
-                                    </p:set>
-                                  </p:childTnLst>
-                                </p:cTn>
-                              </p:par>
-                              <p:par>
-                                <p:cTn id="59" presetID="1" presetClass="entr" presetSubtype="0" fill="hold" grpId="0" nodeType="withEffect">
-                                  <p:stCondLst>
-                                    <p:cond delay="0"/>
-                                  </p:stCondLst>
-                                  <p:childTnLst>
-                                    <p:set>
-                                      <p:cBhvr>
-                                        <p:cTn id="60" dur="1" fill="hold">
-                                          <p:stCondLst>
-                                            <p:cond delay="0"/>
-                                          </p:stCondLst>
-                                        </p:cTn>
-                                        <p:tgtEl>
-                                          <p:spTgt spid="33"/>
-                                        </p:tgtEl>
-                                        <p:attrNameLst>
-                                          <p:attrName>style.visibility</p:attrName>
-                                        </p:attrNameLst>
-                                      </p:cBhvr>
-                                      <p:to>
-                                        <p:strVal val="visible"/>
-                                      </p:to>
-                                    </p:set>
-                                  </p:childTnLst>
-                                </p:cTn>
-                              </p:par>
-                              <p:par>
-                                <p:cTn id="61" presetID="1" presetClass="entr" presetSubtype="0" fill="hold" grpId="0" nodeType="withEffect">
-                                  <p:stCondLst>
-                                    <p:cond delay="0"/>
-                                  </p:stCondLst>
-                                  <p:childTnLst>
-                                    <p:set>
-                                      <p:cBhvr>
-                                        <p:cTn id="62" dur="1" fill="hold">
-                                          <p:stCondLst>
-                                            <p:cond delay="0"/>
-                                          </p:stCondLst>
-                                        </p:cTn>
-                                        <p:tgtEl>
-                                          <p:spTgt spid="36"/>
-                                        </p:tgtEl>
-                                        <p:attrNameLst>
-                                          <p:attrName>style.visibility</p:attrName>
-                                        </p:attrNameLst>
-                                      </p:cBhvr>
-                                      <p:to>
-                                        <p:strVal val="visible"/>
-                                      </p:to>
-                                    </p:set>
-                                  </p:childTnLst>
-                                </p:cTn>
-                              </p:par>
-                              <p:par>
-                                <p:cTn id="63" presetID="1" presetClass="entr" presetSubtype="0" fill="hold" grpId="0" nodeType="withEffect">
-                                  <p:stCondLst>
-                                    <p:cond delay="0"/>
-                                  </p:stCondLst>
-                                  <p:childTnLst>
-                                    <p:set>
-                                      <p:cBhvr>
-                                        <p:cTn id="64" dur="1" fill="hold">
-                                          <p:stCondLst>
-                                            <p:cond delay="0"/>
-                                          </p:stCondLst>
-                                        </p:cTn>
-                                        <p:tgtEl>
-                                          <p:spTgt spid="37"/>
-                                        </p:tgtEl>
-                                        <p:attrNameLst>
-                                          <p:attrName>style.visibility</p:attrName>
-                                        </p:attrNameLst>
-                                      </p:cBhvr>
-                                      <p:to>
-                                        <p:strVal val="visible"/>
-                                      </p:to>
-                                    </p:set>
-                                  </p:childTnLst>
-                                </p:cTn>
-                              </p:par>
-                              <p:par>
-                                <p:cTn id="65" presetID="1" presetClass="entr" presetSubtype="0" fill="hold" grpId="0" nodeType="withEffect">
-                                  <p:stCondLst>
-                                    <p:cond delay="0"/>
-                                  </p:stCondLst>
-                                  <p:childTnLst>
-                                    <p:set>
-                                      <p:cBhvr>
-                                        <p:cTn id="66" dur="1" fill="hold">
-                                          <p:stCondLst>
-                                            <p:cond delay="0"/>
-                                          </p:stCondLst>
-                                        </p:cTn>
-                                        <p:tgtEl>
-                                          <p:spTgt spid="38"/>
-                                        </p:tgtEl>
-                                        <p:attrNameLst>
-                                          <p:attrName>style.visibility</p:attrName>
-                                        </p:attrNameLst>
-                                      </p:cBhvr>
-                                      <p:to>
-                                        <p:strVal val="visible"/>
-                                      </p:to>
-                                    </p:set>
-                                  </p:childTnLst>
-                                </p:cTn>
-                              </p:par>
-                              <p:par>
-                                <p:cTn id="67" presetID="1" presetClass="entr" presetSubtype="0" fill="hold" grpId="0" nodeType="withEffect">
-                                  <p:stCondLst>
-                                    <p:cond delay="0"/>
-                                  </p:stCondLst>
-                                  <p:childTnLst>
-                                    <p:set>
-                                      <p:cBhvr>
-                                        <p:cTn id="68" dur="1" fill="hold">
-                                          <p:stCondLst>
-                                            <p:cond delay="0"/>
-                                          </p:stCondLst>
-                                        </p:cTn>
-                                        <p:tgtEl>
-                                          <p:spTgt spid="41"/>
-                                        </p:tgtEl>
-                                        <p:attrNameLst>
-                                          <p:attrName>style.visibility</p:attrName>
-                                        </p:attrNameLst>
-                                      </p:cBhvr>
-                                      <p:to>
-                                        <p:strVal val="visible"/>
-                                      </p:to>
-                                    </p:set>
-                                  </p:childTnLst>
-                                </p:cTn>
-                              </p:par>
-                              <p:par>
-                                <p:cTn id="69" presetID="1" presetClass="entr" presetSubtype="0" fill="hold" nodeType="withEffect">
-                                  <p:stCondLst>
-                                    <p:cond delay="0"/>
-                                  </p:stCondLst>
-                                  <p:childTnLst>
-                                    <p:set>
-                                      <p:cBhvr>
-                                        <p:cTn id="70" dur="1" fill="hold">
-                                          <p:stCondLst>
-                                            <p:cond delay="0"/>
-                                          </p:stCondLst>
-                                        </p:cTn>
-                                        <p:tgtEl>
-                                          <p:spTgt spid="10"/>
-                                        </p:tgtEl>
-                                        <p:attrNameLst>
-                                          <p:attrName>style.visibility</p:attrName>
-                                        </p:attrNameLst>
-                                      </p:cBhvr>
-                                      <p:to>
-                                        <p:strVal val="visible"/>
-                                      </p:to>
-                                    </p:set>
-                                  </p:childTnLst>
-                                </p:cTn>
-                              </p:par>
-                              <p:par>
-                                <p:cTn id="71" presetID="1" presetClass="entr" presetSubtype="0" fill="hold" grpId="0" nodeType="withEffect">
-                                  <p:stCondLst>
-                                    <p:cond delay="0"/>
-                                  </p:stCondLst>
-                                  <p:childTnLst>
-                                    <p:set>
-                                      <p:cBhvr>
-                                        <p:cTn id="72" dur="1" fill="hold">
-                                          <p:stCondLst>
-                                            <p:cond delay="0"/>
-                                          </p:stCondLst>
-                                        </p:cTn>
-                                        <p:tgtEl>
-                                          <p:spTgt spid="16"/>
-                                        </p:tgtEl>
-                                        <p:attrNameLst>
-                                          <p:attrName>style.visibility</p:attrName>
-                                        </p:attrNameLst>
-                                      </p:cBhvr>
-                                      <p:to>
-                                        <p:strVal val="visible"/>
-                                      </p:to>
-                                    </p:set>
-                                  </p:childTnLst>
-                                </p:cTn>
-                              </p:par>
-                              <p:par>
-                                <p:cTn id="73" presetID="1" presetClass="entr" presetSubtype="0" fill="hold" nodeType="withEffect">
+                                <p:cTn id="73" presetID="1" presetClass="entr" presetSubtype="0" fill="hold" nodeType="clickEffect">
                                   <p:stCondLst>
                                     <p:cond delay="0"/>
                                   </p:stCondLst>
@@ -30752,7 +30701,11 @@
                                           </p:stCondLst>
                                         </p:cTn>
                                         <p:tgtEl>
-                                          <p:spTgt spid="34"/>
+                                          <p:spTgt spid="42">
+                                            <p:txEl>
+                                              <p:pRg st="6" end="6"/>
+                                            </p:txEl>
+                                          </p:spTgt>
                                         </p:tgtEl>
                                         <p:attrNameLst>
                                           <p:attrName>style.visibility</p:attrName>
@@ -34579,8 +34532,8 @@
           <a:chExt cx="0" cy="0"/>
         </a:xfrm>
       </p:grpSpPr>
-      <mc:AlternateContent xmlns:mc="http://schemas.openxmlformats.org/markup-compatibility/2006" xmlns:a14="http://schemas.microsoft.com/office/drawing/2010/main">
-        <mc:Choice Requires="a14">
+      <mc:AlternateContent xmlns:mc="http://schemas.openxmlformats.org/markup-compatibility/2006">
+        <mc:Choice xmlns:a14="http://schemas.microsoft.com/office/drawing/2010/main" Requires="a14">
           <p:sp>
             <p:nvSpPr>
               <p:cNvPr id="3" name="Content Placeholder 2">
@@ -34958,6 +34911,20 @@
                         </m:r>
                       </m:sup>
                     </m:sSup>
+                    <m:r>
+                      <a:rPr lang="en-US" sz="2600" b="0" i="1" smtClean="0">
+                        <a:latin typeface="Cambria Math" panose="02040503050406030204" pitchFamily="18" charset="0"/>
+                        <a:ea typeface="Cambria Math" panose="02040503050406030204" pitchFamily="18" charset="0"/>
+                      </a:rPr>
+                      <m:t>≪</m:t>
+                    </m:r>
+                    <m:r>
+                      <a:rPr lang="en-US" sz="2600" b="0" i="1" smtClean="0">
+                        <a:latin typeface="Cambria Math" panose="02040503050406030204" pitchFamily="18" charset="0"/>
+                        <a:ea typeface="Cambria Math" panose="02040503050406030204" pitchFamily="18" charset="0"/>
+                      </a:rPr>
+                      <m:t>𝑝</m:t>
+                    </m:r>
                   </m:oMath>
                 </a14:m>
                 <a:endParaRPr lang="en-US" sz="2600" dirty="0"/>
@@ -34965,7 +34932,7 @@
             </p:txBody>
           </p:sp>
         </mc:Choice>
-        <mc:Fallback xmlns="">
+        <mc:Fallback>
           <p:sp>
             <p:nvSpPr>
               <p:cNvPr id="3" name="Content Placeholder 2">

</xml_diff>

<commit_message>
Corrected typo on slide
</commit_message>
<xml_diff>
--- a/slides/1_Introduction.pptx
+++ b/slides/1_Introduction.pptx
@@ -38329,7 +38329,15 @@
           <a:p>
             <a:r>
               <a:rPr lang="en-US" dirty="0"/>
-              <a:t>Searching colliding keys in less than linear time</a:t>
+              <a:t>Searching colliding keys </a:t>
+            </a:r>
+            <a:r>
+              <a:rPr lang="en-US"/>
+              <a:t>in greater </a:t>
+            </a:r>
+            <a:r>
+              <a:rPr lang="en-US" dirty="0"/>
+              <a:t>than linear time</a:t>
             </a:r>
           </a:p>
           <a:p>

</xml_diff>